<commit_message>
Remove card individual de aposentadorias
</commit_message>
<xml_diff>
--- a/exportacoes/Painel_Gestao_Pessoal_PMCE_EDITAVEL.pptx
+++ b/exportacoes/Painel_Gestao_Pessoal_PMCE_EDITAVEL.pptx
@@ -4374,7 +4374,7 @@
         <p:spPr>
           <a:xfrm>
             <a:off x="228600" y="1435608"/>
-            <a:ext cx="2240280" cy="941832"/>
+            <a:ext cx="2816352" cy="941832"/>
           </a:xfrm>
           <a:prstGeom prst="roundRect">
             <a:avLst/>
@@ -4462,7 +4462,7 @@
         <p:spPr>
           <a:xfrm>
             <a:off x="356616" y="1554480"/>
-            <a:ext cx="1664208" cy="237744"/>
+            <a:ext cx="2148840" cy="237744"/>
           </a:xfrm>
           <a:prstGeom prst="rect">
             <a:avLst/>
@@ -4503,7 +4503,7 @@
         </p:nvSpPr>
         <p:spPr>
           <a:xfrm>
-            <a:off x="2093976" y="1554480"/>
+            <a:off x="2670048" y="1554480"/>
             <a:ext cx="256032" cy="256032"/>
           </a:xfrm>
           <a:prstGeom prst="roundRect">
@@ -4546,7 +4546,7 @@
         </p:nvSpPr>
         <p:spPr>
           <a:xfrm>
-            <a:off x="2093976" y="1554480"/>
+            <a:off x="2670048" y="1554480"/>
             <a:ext cx="256032" cy="256032"/>
           </a:xfrm>
           <a:prstGeom prst="rect">
@@ -4708,7 +4708,7 @@
         <p:spPr>
           <a:xfrm>
             <a:off x="539496" y="2157984"/>
-            <a:ext cx="1755648" cy="146304"/>
+            <a:ext cx="2368296" cy="146304"/>
           </a:xfrm>
           <a:prstGeom prst="rect">
             <a:avLst/>
@@ -4749,8 +4749,8 @@
         </p:nvSpPr>
         <p:spPr>
           <a:xfrm>
-            <a:off x="2578608" y="1435608"/>
-            <a:ext cx="2240280" cy="941832"/>
+            <a:off x="3200400" y="1435608"/>
+            <a:ext cx="2816352" cy="941832"/>
           </a:xfrm>
           <a:prstGeom prst="roundRect">
             <a:avLst/>
@@ -4794,7 +4794,7 @@
         </p:nvSpPr>
         <p:spPr>
           <a:xfrm>
-            <a:off x="2578608" y="1499616"/>
+            <a:off x="3200400" y="1499616"/>
             <a:ext cx="32004" cy="813816"/>
           </a:xfrm>
           <a:prstGeom prst="rect">
@@ -4837,8 +4837,8 @@
         </p:nvSpPr>
         <p:spPr>
           <a:xfrm>
-            <a:off x="2706624" y="1554480"/>
-            <a:ext cx="1664208" cy="237744"/>
+            <a:off x="3328416" y="1554480"/>
+            <a:ext cx="2148840" cy="237744"/>
           </a:xfrm>
           <a:prstGeom prst="rect">
             <a:avLst/>
@@ -4866,8 +4866,7 @@
                 </a:solidFill>
                 <a:latin typeface="Segoe UI"/>
               </a:rPr>
-              <a:t>RAIO — Necessidade de efetivo
-das bases satélites</a:t>
+              <a:t>RAIO — Necessidade de efetivo das bases satélites</a:t>
             </a:r>
           </a:p>
         </p:txBody>
@@ -4880,7 +4879,7 @@
         </p:nvSpPr>
         <p:spPr>
           <a:xfrm>
-            <a:off x="4443983" y="1554480"/>
+            <a:off x="5641848" y="1554480"/>
             <a:ext cx="256032" cy="256032"/>
           </a:xfrm>
           <a:prstGeom prst="roundRect">
@@ -4923,7 +4922,7 @@
         </p:nvSpPr>
         <p:spPr>
           <a:xfrm>
-            <a:off x="4443983" y="1554480"/>
+            <a:off x="5641848" y="1554480"/>
             <a:ext cx="256032" cy="256032"/>
           </a:xfrm>
           <a:prstGeom prst="rect">
@@ -4965,7 +4964,7 @@
         </p:nvSpPr>
         <p:spPr>
           <a:xfrm>
-            <a:off x="2706624" y="1856232"/>
+            <a:off x="3328416" y="1856232"/>
             <a:ext cx="713232" cy="301752"/>
           </a:xfrm>
           <a:prstGeom prst="rect">
@@ -5007,7 +5006,7 @@
         </p:nvSpPr>
         <p:spPr>
           <a:xfrm>
-            <a:off x="3346703" y="1938528"/>
+            <a:off x="3968496" y="1938528"/>
             <a:ext cx="822960" cy="137160"/>
           </a:xfrm>
           <a:prstGeom prst="rect">
@@ -5049,8 +5048,8 @@
         </p:nvCxnSpPr>
         <p:spPr>
           <a:xfrm>
-            <a:off x="2706624" y="2221992"/>
-            <a:ext cx="128015" cy="0"/>
+            <a:off x="3328416" y="2221992"/>
+            <a:ext cx="128016" cy="0"/>
           </a:xfrm>
           <a:prstGeom prst="line">
             <a:avLst/>
@@ -5084,8 +5083,8 @@
         </p:nvSpPr>
         <p:spPr>
           <a:xfrm>
-            <a:off x="2889503" y="2157984"/>
-            <a:ext cx="1755648" cy="146304"/>
+            <a:off x="3511296" y="2157984"/>
+            <a:ext cx="2368296" cy="146304"/>
           </a:xfrm>
           <a:prstGeom prst="rect">
             <a:avLst/>
@@ -5126,8 +5125,8 @@
         </p:nvSpPr>
         <p:spPr>
           <a:xfrm>
-            <a:off x="4928616" y="1435608"/>
-            <a:ext cx="2240280" cy="941832"/>
+            <a:off x="6172200" y="1435608"/>
+            <a:ext cx="2816352" cy="941832"/>
           </a:xfrm>
           <a:prstGeom prst="roundRect">
             <a:avLst/>
@@ -5171,7 +5170,7 @@
         </p:nvSpPr>
         <p:spPr>
           <a:xfrm>
-            <a:off x="4928616" y="1499616"/>
+            <a:off x="6172200" y="1499616"/>
             <a:ext cx="32004" cy="813816"/>
           </a:xfrm>
           <a:prstGeom prst="rect">
@@ -5214,8 +5213,8 @@
         </p:nvSpPr>
         <p:spPr>
           <a:xfrm>
-            <a:off x="5056631" y="1554480"/>
-            <a:ext cx="1664208" cy="237744"/>
+            <a:off x="6300216" y="1554480"/>
+            <a:ext cx="2148840" cy="237744"/>
           </a:xfrm>
           <a:prstGeom prst="rect">
             <a:avLst/>
@@ -5256,7 +5255,7 @@
         </p:nvSpPr>
         <p:spPr>
           <a:xfrm>
-            <a:off x="6793992" y="1554480"/>
+            <a:off x="8613648" y="1554480"/>
             <a:ext cx="256032" cy="256032"/>
           </a:xfrm>
           <a:prstGeom prst="roundRect">
@@ -5299,7 +5298,7 @@
         </p:nvSpPr>
         <p:spPr>
           <a:xfrm>
-            <a:off x="6793992" y="1554480"/>
+            <a:off x="8613648" y="1554480"/>
             <a:ext cx="256032" cy="256032"/>
           </a:xfrm>
           <a:prstGeom prst="rect">
@@ -5341,7 +5340,7 @@
         </p:nvSpPr>
         <p:spPr>
           <a:xfrm>
-            <a:off x="5056631" y="1856232"/>
+            <a:off x="6300216" y="1856232"/>
             <a:ext cx="713232" cy="301752"/>
           </a:xfrm>
           <a:prstGeom prst="rect">
@@ -5383,7 +5382,7 @@
         </p:nvSpPr>
         <p:spPr>
           <a:xfrm>
-            <a:off x="5696712" y="1938528"/>
+            <a:off x="6940296" y="1938528"/>
             <a:ext cx="822960" cy="137160"/>
           </a:xfrm>
           <a:prstGeom prst="rect">
@@ -5425,8 +5424,8 @@
         </p:nvCxnSpPr>
         <p:spPr>
           <a:xfrm>
-            <a:off x="5056631" y="2221992"/>
-            <a:ext cx="128017" cy="0"/>
+            <a:off x="6300216" y="2221992"/>
+            <a:ext cx="128016" cy="0"/>
           </a:xfrm>
           <a:prstGeom prst="line">
             <a:avLst/>
@@ -5460,8 +5459,8 @@
         </p:nvSpPr>
         <p:spPr>
           <a:xfrm>
-            <a:off x="5239512" y="2157984"/>
-            <a:ext cx="1755648" cy="146304"/>
+            <a:off x="6483096" y="2157984"/>
+            <a:ext cx="2368296" cy="146304"/>
           </a:xfrm>
           <a:prstGeom prst="rect">
             <a:avLst/>
@@ -5502,8 +5501,8 @@
         </p:nvSpPr>
         <p:spPr>
           <a:xfrm>
-            <a:off x="7278624" y="1435608"/>
-            <a:ext cx="2240280" cy="941832"/>
+            <a:off x="9144000" y="1435608"/>
+            <a:ext cx="2816352" cy="941832"/>
           </a:xfrm>
           <a:prstGeom prst="roundRect">
             <a:avLst/>
@@ -5547,7 +5546,7 @@
         </p:nvSpPr>
         <p:spPr>
           <a:xfrm>
-            <a:off x="7278624" y="1499616"/>
+            <a:off x="9144000" y="1499616"/>
             <a:ext cx="32004" cy="813816"/>
           </a:xfrm>
           <a:prstGeom prst="rect">
@@ -5590,8 +5589,8 @@
         </p:nvSpPr>
         <p:spPr>
           <a:xfrm>
-            <a:off x="7406640" y="1554480"/>
-            <a:ext cx="1664208" cy="237744"/>
+            <a:off x="9272016" y="1554480"/>
+            <a:ext cx="2148840" cy="237744"/>
           </a:xfrm>
           <a:prstGeom prst="rect">
             <a:avLst/>
@@ -5632,7 +5631,7 @@
         </p:nvSpPr>
         <p:spPr>
           <a:xfrm>
-            <a:off x="9144000" y="1554480"/>
+            <a:off x="11585448" y="1554480"/>
             <a:ext cx="256032" cy="256032"/>
           </a:xfrm>
           <a:prstGeom prst="roundRect">
@@ -5675,7 +5674,7 @@
         </p:nvSpPr>
         <p:spPr>
           <a:xfrm>
-            <a:off x="9144000" y="1554480"/>
+            <a:off x="11585448" y="1554480"/>
             <a:ext cx="256032" cy="256032"/>
           </a:xfrm>
           <a:prstGeom prst="rect">
@@ -5717,7 +5716,7 @@
         </p:nvSpPr>
         <p:spPr>
           <a:xfrm>
-            <a:off x="7406640" y="1856232"/>
+            <a:off x="9272016" y="1856232"/>
             <a:ext cx="713232" cy="301752"/>
           </a:xfrm>
           <a:prstGeom prst="rect">
@@ -5759,7 +5758,7 @@
         </p:nvSpPr>
         <p:spPr>
           <a:xfrm>
-            <a:off x="8046720" y="1938528"/>
+            <a:off x="9912096" y="1938528"/>
             <a:ext cx="822960" cy="137160"/>
           </a:xfrm>
           <a:prstGeom prst="rect">
@@ -5801,7 +5800,7 @@
         </p:nvCxnSpPr>
         <p:spPr>
           <a:xfrm>
-            <a:off x="7406640" y="2221992"/>
+            <a:off x="9272016" y="2221992"/>
             <a:ext cx="128016" cy="0"/>
           </a:xfrm>
           <a:prstGeom prst="line">
@@ -5836,8 +5835,8 @@
         </p:nvSpPr>
         <p:spPr>
           <a:xfrm>
-            <a:off x="7589520" y="2157984"/>
-            <a:ext cx="1755648" cy="146304"/>
+            <a:off x="9454896" y="2157984"/>
+            <a:ext cx="2368296" cy="146304"/>
           </a:xfrm>
           <a:prstGeom prst="rect">
             <a:avLst/>
@@ -5878,8 +5877,8 @@
         </p:nvSpPr>
         <p:spPr>
           <a:xfrm>
-            <a:off x="9628632" y="1435608"/>
-            <a:ext cx="2240280" cy="941832"/>
+            <a:off x="228600" y="2487168"/>
+            <a:ext cx="6153912" cy="4105656"/>
           </a:xfrm>
           <a:prstGeom prst="roundRect">
             <a:avLst/>
@@ -5915,277 +5914,23 @@
           </a:p>
         </p:txBody>
       </p:sp>
-      <p:sp>
-        <p:nvSpPr>
-          <p:cNvPr id="59" name="Rectangle 58"/>
-          <p:cNvSpPr/>
-          <p:nvPr/>
-        </p:nvSpPr>
-        <p:spPr>
-          <a:xfrm>
-            <a:off x="9628632" y="1499616"/>
-            <a:ext cx="32004" cy="813816"/>
-          </a:xfrm>
-          <a:prstGeom prst="rect">
-            <a:avLst/>
-          </a:prstGeom>
-          <a:solidFill>
-            <a:srgbClr val="698342"/>
-          </a:solidFill>
-          <a:ln w="8890">
-            <a:noFill/>
-          </a:ln>
-        </p:spPr>
-        <p:style>
-          <a:lnRef idx="1">
-            <a:schemeClr val="accent1"/>
-          </a:lnRef>
-          <a:fillRef idx="3">
-            <a:schemeClr val="accent1"/>
-          </a:fillRef>
-          <a:effectRef idx="2">
-            <a:schemeClr val="accent1"/>
-          </a:effectRef>
-          <a:fontRef idx="minor">
-            <a:schemeClr val="lt1"/>
-          </a:fontRef>
-        </p:style>
-        <p:txBody>
-          <a:bodyPr rtlCol="0" anchor="ctr"/>
-          <a:lstStyle/>
-          <a:p>
-            <a:pPr algn="ctr"/>
-          </a:p>
-        </p:txBody>
-      </p:sp>
-      <p:sp>
-        <p:nvSpPr>
-          <p:cNvPr id="60" name="TextBox 59"/>
-          <p:cNvSpPr txBox="1"/>
-          <p:nvPr/>
-        </p:nvSpPr>
-        <p:spPr>
-          <a:xfrm>
-            <a:off x="9756648" y="1554480"/>
-            <a:ext cx="1664208" cy="237744"/>
-          </a:xfrm>
-          <a:prstGeom prst="rect">
-            <a:avLst/>
-          </a:prstGeom>
-          <a:noFill/>
-        </p:spPr>
-        <p:txBody>
-          <a:bodyPr wrap="none" lIns="0" rIns="0" tIns="0" bIns="0" anchor="t">
-            <a:spAutoFit/>
-          </a:bodyPr>
-          <a:lstStyle/>
-          <a:p>
-            <a:pPr algn="l">
-              <a:spcBef>
-                <a:spcPts val="0"/>
-              </a:spcBef>
-              <a:spcAft>
-                <a:spcPts val="0"/>
-              </a:spcAft>
-            </a:pPr>
-            <a:r>
-              <a:rPr sz="780" b="1">
-                <a:solidFill>
-                  <a:srgbClr val="16231D"/>
-                </a:solidFill>
-                <a:latin typeface="Segoe UI"/>
-              </a:rPr>
-              <a:t>Aposentadorias</a:t>
-            </a:r>
-          </a:p>
-        </p:txBody>
-      </p:sp>
-      <p:sp>
-        <p:nvSpPr>
-          <p:cNvPr id="61" name="Rounded Rectangle 60"/>
-          <p:cNvSpPr/>
-          <p:nvPr/>
-        </p:nvSpPr>
-        <p:spPr>
-          <a:xfrm>
-            <a:off x="11494008" y="1554480"/>
-            <a:ext cx="256032" cy="256032"/>
-          </a:xfrm>
-          <a:prstGeom prst="roundRect">
-            <a:avLst/>
-          </a:prstGeom>
-          <a:solidFill>
-            <a:srgbClr val="EDF3E4"/>
-          </a:solidFill>
-          <a:ln w="8890">
-            <a:noFill/>
-          </a:ln>
-        </p:spPr>
-        <p:style>
-          <a:lnRef idx="1">
-            <a:schemeClr val="accent1"/>
-          </a:lnRef>
-          <a:fillRef idx="3">
-            <a:schemeClr val="accent1"/>
-          </a:fillRef>
-          <a:effectRef idx="2">
-            <a:schemeClr val="accent1"/>
-          </a:effectRef>
-          <a:fontRef idx="minor">
-            <a:schemeClr val="lt1"/>
-          </a:fontRef>
-        </p:style>
-        <p:txBody>
-          <a:bodyPr rtlCol="0" anchor="ctr"/>
-          <a:lstStyle/>
-          <a:p>
-            <a:pPr algn="ctr"/>
-          </a:p>
-        </p:txBody>
-      </p:sp>
-      <p:sp>
-        <p:nvSpPr>
-          <p:cNvPr id="62" name="TextBox 61"/>
-          <p:cNvSpPr txBox="1"/>
-          <p:nvPr/>
-        </p:nvSpPr>
-        <p:spPr>
-          <a:xfrm>
-            <a:off x="11494008" y="1554480"/>
-            <a:ext cx="256032" cy="256032"/>
-          </a:xfrm>
-          <a:prstGeom prst="rect">
-            <a:avLst/>
-          </a:prstGeom>
-          <a:noFill/>
-        </p:spPr>
-        <p:txBody>
-          <a:bodyPr wrap="none" lIns="0" rIns="0" tIns="0" bIns="0" anchor="ctr">
-            <a:spAutoFit/>
-          </a:bodyPr>
-          <a:lstStyle/>
-          <a:p>
-            <a:pPr algn="ctr">
-              <a:spcBef>
-                <a:spcPts val="0"/>
-              </a:spcBef>
-              <a:spcAft>
-                <a:spcPts val="0"/>
-              </a:spcAft>
-            </a:pPr>
-            <a:r>
-              <a:rPr sz="800" b="1">
-                <a:solidFill>
-                  <a:srgbClr val="698342"/>
-                </a:solidFill>
-                <a:latin typeface="Segoe UI"/>
-              </a:rPr>
-              <a:t>●</a:t>
-            </a:r>
-          </a:p>
-        </p:txBody>
-      </p:sp>
-      <p:sp>
-        <p:nvSpPr>
-          <p:cNvPr id="63" name="TextBox 62"/>
-          <p:cNvSpPr txBox="1"/>
-          <p:nvPr/>
-        </p:nvSpPr>
-        <p:spPr>
-          <a:xfrm>
-            <a:off x="9756648" y="1856232"/>
-            <a:ext cx="713232" cy="301752"/>
-          </a:xfrm>
-          <a:prstGeom prst="rect">
-            <a:avLst/>
-          </a:prstGeom>
-          <a:noFill/>
-        </p:spPr>
-        <p:txBody>
-          <a:bodyPr wrap="none" lIns="0" rIns="0" tIns="0" bIns="0" anchor="ctr">
-            <a:spAutoFit/>
-          </a:bodyPr>
-          <a:lstStyle/>
-          <a:p>
-            <a:pPr algn="l">
-              <a:spcBef>
-                <a:spcPts val="0"/>
-              </a:spcBef>
-              <a:spcAft>
-                <a:spcPts val="0"/>
-              </a:spcAft>
-            </a:pPr>
-            <a:r>
-              <a:rPr sz="2300" b="1">
-                <a:solidFill>
-                  <a:srgbClr val="16231D"/>
-                </a:solidFill>
-                <a:latin typeface="Segoe UI"/>
-              </a:rPr>
-              <a:t>207</a:t>
-            </a:r>
-          </a:p>
-        </p:txBody>
-      </p:sp>
-      <p:sp>
-        <p:nvSpPr>
-          <p:cNvPr id="64" name="TextBox 63"/>
-          <p:cNvSpPr txBox="1"/>
-          <p:nvPr/>
-        </p:nvSpPr>
-        <p:spPr>
-          <a:xfrm>
-            <a:off x="10396728" y="1938528"/>
-            <a:ext cx="822960" cy="137160"/>
-          </a:xfrm>
-          <a:prstGeom prst="rect">
-            <a:avLst/>
-          </a:prstGeom>
-          <a:noFill/>
-        </p:spPr>
-        <p:txBody>
-          <a:bodyPr wrap="none" lIns="0" rIns="0" tIns="0" bIns="0" anchor="ctr">
-            <a:spAutoFit/>
-          </a:bodyPr>
-          <a:lstStyle/>
-          <a:p>
-            <a:pPr algn="l">
-              <a:spcBef>
-                <a:spcPts val="0"/>
-              </a:spcBef>
-              <a:spcAft>
-                <a:spcPts val="0"/>
-              </a:spcAft>
-            </a:pPr>
-            <a:r>
-              <a:rPr sz="670" b="0">
-                <a:solidFill>
-                  <a:srgbClr val="6D7973"/>
-                </a:solidFill>
-                <a:latin typeface="Segoe UI"/>
-              </a:rPr>
-              <a:t>militares</a:t>
-            </a:r>
-          </a:p>
-        </p:txBody>
-      </p:sp>
       <p:cxnSp>
         <p:nvCxnSpPr>
-          <p:cNvPr id="65" name="Connector 64"/>
+          <p:cNvPr id="59" name="Connector 58"/>
           <p:cNvCxnSpPr/>
           <p:nvPr/>
         </p:nvCxnSpPr>
         <p:spPr>
           <a:xfrm>
-            <a:off x="9756648" y="2221992"/>
-            <a:ext cx="128015" cy="0"/>
+            <a:off x="228600" y="2926080"/>
+            <a:ext cx="6153912" cy="0"/>
           </a:xfrm>
           <a:prstGeom prst="line">
             <a:avLst/>
           </a:prstGeom>
-          <a:ln w="16510">
+          <a:ln w="7620">
             <a:solidFill>
-              <a:srgbClr val="698342"/>
+              <a:srgbClr val="E9EEEB"/>
             </a:solidFill>
           </a:ln>
         </p:spPr>
@@ -6206,129 +5951,7 @@
       </p:cxnSp>
       <p:sp>
         <p:nvSpPr>
-          <p:cNvPr id="66" name="TextBox 65"/>
-          <p:cNvSpPr txBox="1"/>
-          <p:nvPr/>
-        </p:nvSpPr>
-        <p:spPr>
-          <a:xfrm>
-            <a:off x="9939528" y="2157984"/>
-            <a:ext cx="1755648" cy="146304"/>
-          </a:xfrm>
-          <a:prstGeom prst="rect">
-            <a:avLst/>
-          </a:prstGeom>
-          <a:noFill/>
-        </p:spPr>
-        <p:txBody>
-          <a:bodyPr wrap="none" lIns="0" rIns="0" tIns="0" bIns="0" anchor="ctr">
-            <a:spAutoFit/>
-          </a:bodyPr>
-          <a:lstStyle/>
-          <a:p>
-            <a:pPr algn="l">
-              <a:spcBef>
-                <a:spcPts val="0"/>
-              </a:spcBef>
-              <a:spcAft>
-                <a:spcPts val="0"/>
-              </a:spcAft>
-            </a:pPr>
-            <a:r>
-              <a:rPr sz="550" b="0">
-                <a:solidFill>
-                  <a:srgbClr val="6D7973"/>
-                </a:solidFill>
-                <a:latin typeface="Segoe UI"/>
-              </a:rPr>
-              <a:t>Referência: promoções requeridas</a:t>
-            </a:r>
-          </a:p>
-        </p:txBody>
-      </p:sp>
-      <p:sp>
-        <p:nvSpPr>
-          <p:cNvPr id="67" name="Rounded Rectangle 66"/>
-          <p:cNvSpPr/>
-          <p:nvPr/>
-        </p:nvSpPr>
-        <p:spPr>
-          <a:xfrm>
-            <a:off x="228600" y="2487168"/>
-            <a:ext cx="6153912" cy="4105656"/>
-          </a:xfrm>
-          <a:prstGeom prst="roundRect">
-            <a:avLst/>
-          </a:prstGeom>
-          <a:solidFill>
-            <a:srgbClr val="FFFFFF"/>
-          </a:solidFill>
-          <a:ln w="8890">
-            <a:solidFill>
-              <a:srgbClr val="DFE6E2"/>
-            </a:solidFill>
-          </a:ln>
-        </p:spPr>
-        <p:style>
-          <a:lnRef idx="1">
-            <a:schemeClr val="accent1"/>
-          </a:lnRef>
-          <a:fillRef idx="3">
-            <a:schemeClr val="accent1"/>
-          </a:fillRef>
-          <a:effectRef idx="2">
-            <a:schemeClr val="accent1"/>
-          </a:effectRef>
-          <a:fontRef idx="minor">
-            <a:schemeClr val="lt1"/>
-          </a:fontRef>
-        </p:style>
-        <p:txBody>
-          <a:bodyPr rtlCol="0" anchor="ctr"/>
-          <a:lstStyle/>
-          <a:p>
-            <a:pPr algn="ctr"/>
-          </a:p>
-        </p:txBody>
-      </p:sp>
-      <p:cxnSp>
-        <p:nvCxnSpPr>
-          <p:cNvPr id="68" name="Connector 67"/>
-          <p:cNvCxnSpPr/>
-          <p:nvPr/>
-        </p:nvCxnSpPr>
-        <p:spPr>
-          <a:xfrm>
-            <a:off x="228600" y="2926080"/>
-            <a:ext cx="6153912" cy="0"/>
-          </a:xfrm>
-          <a:prstGeom prst="line">
-            <a:avLst/>
-          </a:prstGeom>
-          <a:ln w="7620">
-            <a:solidFill>
-              <a:srgbClr val="E9EEEB"/>
-            </a:solidFill>
-          </a:ln>
-        </p:spPr>
-        <p:style>
-          <a:lnRef idx="2">
-            <a:schemeClr val="accent1"/>
-          </a:lnRef>
-          <a:fillRef idx="0">
-            <a:schemeClr val="accent1"/>
-          </a:fillRef>
-          <a:effectRef idx="1">
-            <a:schemeClr val="accent1"/>
-          </a:effectRef>
-          <a:fontRef idx="minor">
-            <a:schemeClr val="tx1"/>
-          </a:fontRef>
-        </p:style>
-      </p:cxnSp>
-      <p:sp>
-        <p:nvSpPr>
-          <p:cNvPr id="69" name="Rounded Rectangle 68"/>
+          <p:cNvPr id="60" name="Rounded Rectangle 59"/>
           <p:cNvSpPr/>
           <p:nvPr/>
         </p:nvSpPr>
@@ -6371,7 +5994,7 @@
       </p:sp>
       <p:sp>
         <p:nvSpPr>
-          <p:cNvPr id="70" name="TextBox 69"/>
+          <p:cNvPr id="61" name="TextBox 60"/>
           <p:cNvSpPr txBox="1"/>
           <p:nvPr/>
         </p:nvSpPr>
@@ -6413,7 +6036,7 @@
       </p:sp>
       <p:sp>
         <p:nvSpPr>
-          <p:cNvPr id="71" name="TextBox 70"/>
+          <p:cNvPr id="62" name="TextBox 61"/>
           <p:cNvSpPr txBox="1"/>
           <p:nvPr/>
         </p:nvSpPr>
@@ -6455,7 +6078,7 @@
       </p:sp>
       <p:sp>
         <p:nvSpPr>
-          <p:cNvPr id="72" name="TextBox 71"/>
+          <p:cNvPr id="63" name="TextBox 62"/>
           <p:cNvSpPr txBox="1"/>
           <p:nvPr/>
         </p:nvSpPr>
@@ -6497,7 +6120,7 @@
       </p:sp>
       <p:graphicFrame>
         <p:nvGraphicFramePr>
-          <p:cNvPr id="73" name="Chart 72"/>
+          <p:cNvPr id="64" name="Chart 63"/>
           <p:cNvGraphicFramePr>
             <a:graphicFrameLocks noGrp="1"/>
           </p:cNvGraphicFramePr>
@@ -6515,7 +6138,7 @@
       </p:graphicFrame>
       <p:sp>
         <p:nvSpPr>
-          <p:cNvPr id="74" name="TextBox 73"/>
+          <p:cNvPr id="65" name="TextBox 64"/>
           <p:cNvSpPr txBox="1"/>
           <p:nvPr/>
         </p:nvSpPr>
@@ -6557,7 +6180,7 @@
       </p:sp>
       <p:sp>
         <p:nvSpPr>
-          <p:cNvPr id="75" name="Rounded Rectangle 74"/>
+          <p:cNvPr id="66" name="Rounded Rectangle 65"/>
           <p:cNvSpPr/>
           <p:nvPr/>
         </p:nvSpPr>
@@ -6602,7 +6225,7 @@
       </p:sp>
       <p:cxnSp>
         <p:nvCxnSpPr>
-          <p:cNvPr id="76" name="Connector 75"/>
+          <p:cNvPr id="67" name="Connector 66"/>
           <p:cNvCxnSpPr/>
           <p:nvPr/>
         </p:nvCxnSpPr>
@@ -6637,7 +6260,7 @@
       </p:cxnSp>
       <p:sp>
         <p:nvSpPr>
-          <p:cNvPr id="77" name="Rounded Rectangle 76"/>
+          <p:cNvPr id="68" name="Rounded Rectangle 67"/>
           <p:cNvSpPr/>
           <p:nvPr/>
         </p:nvSpPr>
@@ -6680,7 +6303,7 @@
       </p:sp>
       <p:sp>
         <p:nvSpPr>
-          <p:cNvPr id="78" name="TextBox 77"/>
+          <p:cNvPr id="69" name="TextBox 68"/>
           <p:cNvSpPr txBox="1"/>
           <p:nvPr/>
         </p:nvSpPr>
@@ -6722,7 +6345,7 @@
       </p:sp>
       <p:sp>
         <p:nvSpPr>
-          <p:cNvPr id="79" name="TextBox 78"/>
+          <p:cNvPr id="70" name="TextBox 69"/>
           <p:cNvSpPr txBox="1"/>
           <p:nvPr/>
         </p:nvSpPr>
@@ -6764,7 +6387,7 @@
       </p:sp>
       <p:sp>
         <p:nvSpPr>
-          <p:cNvPr id="80" name="TextBox 79"/>
+          <p:cNvPr id="71" name="TextBox 70"/>
           <p:cNvSpPr txBox="1"/>
           <p:nvPr/>
         </p:nvSpPr>
@@ -6806,7 +6429,7 @@
       </p:sp>
       <p:sp>
         <p:nvSpPr>
-          <p:cNvPr id="81" name="Rounded Rectangle 80"/>
+          <p:cNvPr id="72" name="Rounded Rectangle 71"/>
           <p:cNvSpPr/>
           <p:nvPr/>
         </p:nvSpPr>
@@ -6851,7 +6474,7 @@
       </p:sp>
       <p:sp>
         <p:nvSpPr>
-          <p:cNvPr id="82" name="Rectangle 81"/>
+          <p:cNvPr id="73" name="Rectangle 72"/>
           <p:cNvSpPr/>
           <p:nvPr/>
         </p:nvSpPr>
@@ -6894,7 +6517,7 @@
       </p:sp>
       <p:sp>
         <p:nvSpPr>
-          <p:cNvPr id="83" name="TextBox 82"/>
+          <p:cNvPr id="74" name="TextBox 73"/>
           <p:cNvSpPr txBox="1"/>
           <p:nvPr/>
         </p:nvSpPr>
@@ -6936,7 +6559,7 @@
       </p:sp>
       <p:sp>
         <p:nvSpPr>
-          <p:cNvPr id="84" name="TextBox 83"/>
+          <p:cNvPr id="75" name="TextBox 74"/>
           <p:cNvSpPr txBox="1"/>
           <p:nvPr/>
         </p:nvSpPr>
@@ -6978,7 +6601,7 @@
       </p:sp>
       <p:sp>
         <p:nvSpPr>
-          <p:cNvPr id="85" name="TextBox 84"/>
+          <p:cNvPr id="76" name="TextBox 75"/>
           <p:cNvSpPr txBox="1"/>
           <p:nvPr/>
         </p:nvSpPr>
@@ -7020,7 +6643,7 @@
       </p:sp>
       <p:sp>
         <p:nvSpPr>
-          <p:cNvPr id="86" name="TextBox 85"/>
+          <p:cNvPr id="77" name="TextBox 76"/>
           <p:cNvSpPr txBox="1"/>
           <p:nvPr/>
         </p:nvSpPr>
@@ -7062,7 +6685,7 @@
       </p:sp>
       <p:sp>
         <p:nvSpPr>
-          <p:cNvPr id="87" name="Rounded Rectangle 86"/>
+          <p:cNvPr id="78" name="Rounded Rectangle 77"/>
           <p:cNvSpPr/>
           <p:nvPr/>
         </p:nvSpPr>
@@ -7107,7 +6730,7 @@
       </p:sp>
       <p:sp>
         <p:nvSpPr>
-          <p:cNvPr id="88" name="Rectangle 87"/>
+          <p:cNvPr id="79" name="Rectangle 78"/>
           <p:cNvSpPr/>
           <p:nvPr/>
         </p:nvSpPr>
@@ -7150,7 +6773,7 @@
       </p:sp>
       <p:sp>
         <p:nvSpPr>
-          <p:cNvPr id="89" name="TextBox 88"/>
+          <p:cNvPr id="80" name="TextBox 79"/>
           <p:cNvSpPr txBox="1"/>
           <p:nvPr/>
         </p:nvSpPr>
@@ -7192,7 +6815,7 @@
       </p:sp>
       <p:sp>
         <p:nvSpPr>
-          <p:cNvPr id="90" name="TextBox 89"/>
+          <p:cNvPr id="81" name="TextBox 80"/>
           <p:cNvSpPr txBox="1"/>
           <p:nvPr/>
         </p:nvSpPr>
@@ -7234,7 +6857,7 @@
       </p:sp>
       <p:sp>
         <p:nvSpPr>
-          <p:cNvPr id="91" name="TextBox 90"/>
+          <p:cNvPr id="82" name="TextBox 81"/>
           <p:cNvSpPr txBox="1"/>
           <p:nvPr/>
         </p:nvSpPr>
@@ -7276,7 +6899,7 @@
       </p:sp>
       <p:sp>
         <p:nvSpPr>
-          <p:cNvPr id="92" name="TextBox 91"/>
+          <p:cNvPr id="83" name="TextBox 82"/>
           <p:cNvSpPr txBox="1"/>
           <p:nvPr/>
         </p:nvSpPr>
@@ -7318,7 +6941,7 @@
       </p:sp>
       <p:sp>
         <p:nvSpPr>
-          <p:cNvPr id="93" name="Rounded Rectangle 92"/>
+          <p:cNvPr id="84" name="Rounded Rectangle 83"/>
           <p:cNvSpPr/>
           <p:nvPr/>
         </p:nvSpPr>
@@ -7363,7 +6986,7 @@
       </p:sp>
       <p:sp>
         <p:nvSpPr>
-          <p:cNvPr id="94" name="Rectangle 93"/>
+          <p:cNvPr id="85" name="Rectangle 84"/>
           <p:cNvSpPr/>
           <p:nvPr/>
         </p:nvSpPr>
@@ -7406,7 +7029,7 @@
       </p:sp>
       <p:sp>
         <p:nvSpPr>
-          <p:cNvPr id="95" name="TextBox 94"/>
+          <p:cNvPr id="86" name="TextBox 85"/>
           <p:cNvSpPr txBox="1"/>
           <p:nvPr/>
         </p:nvSpPr>
@@ -7448,7 +7071,7 @@
       </p:sp>
       <p:sp>
         <p:nvSpPr>
-          <p:cNvPr id="96" name="TextBox 95"/>
+          <p:cNvPr id="87" name="TextBox 86"/>
           <p:cNvSpPr txBox="1"/>
           <p:nvPr/>
         </p:nvSpPr>
@@ -7490,7 +7113,7 @@
       </p:sp>
       <p:sp>
         <p:nvSpPr>
-          <p:cNvPr id="97" name="TextBox 96"/>
+          <p:cNvPr id="88" name="TextBox 87"/>
           <p:cNvSpPr txBox="1"/>
           <p:nvPr/>
         </p:nvSpPr>
@@ -7532,7 +7155,7 @@
       </p:sp>
       <p:sp>
         <p:nvSpPr>
-          <p:cNvPr id="98" name="TextBox 97"/>
+          <p:cNvPr id="89" name="TextBox 88"/>
           <p:cNvSpPr txBox="1"/>
           <p:nvPr/>
         </p:nvSpPr>
@@ -7574,7 +7197,7 @@
       </p:sp>
       <p:sp>
         <p:nvSpPr>
-          <p:cNvPr id="99" name="Rounded Rectangle 98"/>
+          <p:cNvPr id="90" name="Rounded Rectangle 89"/>
           <p:cNvSpPr/>
           <p:nvPr/>
         </p:nvSpPr>
@@ -7619,7 +7242,7 @@
       </p:sp>
       <p:sp>
         <p:nvSpPr>
-          <p:cNvPr id="100" name="TextBox 99"/>
+          <p:cNvPr id="91" name="TextBox 90"/>
           <p:cNvSpPr txBox="1"/>
           <p:nvPr/>
         </p:nvSpPr>
@@ -7661,7 +7284,7 @@
       </p:sp>
       <p:sp>
         <p:nvSpPr>
-          <p:cNvPr id="101" name="Rounded Rectangle 100"/>
+          <p:cNvPr id="92" name="Rounded Rectangle 91"/>
           <p:cNvSpPr/>
           <p:nvPr/>
         </p:nvSpPr>
@@ -7706,7 +7329,7 @@
       </p:sp>
       <p:cxnSp>
         <p:nvCxnSpPr>
-          <p:cNvPr id="102" name="Connector 101"/>
+          <p:cNvPr id="93" name="Connector 92"/>
           <p:cNvCxnSpPr/>
           <p:nvPr/>
         </p:nvCxnSpPr>
@@ -7741,7 +7364,7 @@
       </p:cxnSp>
       <p:sp>
         <p:nvSpPr>
-          <p:cNvPr id="103" name="Rounded Rectangle 102"/>
+          <p:cNvPr id="94" name="Rounded Rectangle 93"/>
           <p:cNvSpPr/>
           <p:nvPr/>
         </p:nvSpPr>
@@ -7784,7 +7407,7 @@
       </p:sp>
       <p:sp>
         <p:nvSpPr>
-          <p:cNvPr id="104" name="TextBox 103"/>
+          <p:cNvPr id="95" name="TextBox 94"/>
           <p:cNvSpPr txBox="1"/>
           <p:nvPr/>
         </p:nvSpPr>
@@ -7826,7 +7449,7 @@
       </p:sp>
       <p:sp>
         <p:nvSpPr>
-          <p:cNvPr id="105" name="TextBox 104"/>
+          <p:cNvPr id="96" name="TextBox 95"/>
           <p:cNvSpPr txBox="1"/>
           <p:nvPr/>
         </p:nvSpPr>
@@ -7868,7 +7491,7 @@
       </p:sp>
       <p:sp>
         <p:nvSpPr>
-          <p:cNvPr id="106" name="TextBox 105"/>
+          <p:cNvPr id="97" name="TextBox 96"/>
           <p:cNvSpPr txBox="1"/>
           <p:nvPr/>
         </p:nvSpPr>
@@ -7910,7 +7533,7 @@
       </p:sp>
       <p:graphicFrame>
         <p:nvGraphicFramePr>
-          <p:cNvPr id="107" name="Chart 106"/>
+          <p:cNvPr id="98" name="Chart 97"/>
           <p:cNvGraphicFramePr>
             <a:graphicFrameLocks noGrp="1"/>
           </p:cNvGraphicFramePr>
@@ -7928,7 +7551,7 @@
       </p:graphicFrame>
       <p:sp>
         <p:nvSpPr>
-          <p:cNvPr id="108" name="TextBox 107"/>
+          <p:cNvPr id="99" name="TextBox 98"/>
           <p:cNvSpPr txBox="1"/>
           <p:nvPr/>
         </p:nvSpPr>
@@ -7970,7 +7593,7 @@
       </p:sp>
       <p:sp>
         <p:nvSpPr>
-          <p:cNvPr id="109" name="TextBox 108"/>
+          <p:cNvPr id="100" name="TextBox 99"/>
           <p:cNvSpPr txBox="1"/>
           <p:nvPr/>
         </p:nvSpPr>
@@ -8012,7 +7635,7 @@
       </p:sp>
       <p:sp>
         <p:nvSpPr>
-          <p:cNvPr id="110" name="Rectangle 109"/>
+          <p:cNvPr id="101" name="Rectangle 100"/>
           <p:cNvSpPr/>
           <p:nvPr/>
         </p:nvSpPr>
@@ -8057,7 +7680,7 @@
       </p:sp>
       <p:sp>
         <p:nvSpPr>
-          <p:cNvPr id="111" name="TextBox 110"/>
+          <p:cNvPr id="102" name="TextBox 101"/>
           <p:cNvSpPr txBox="1"/>
           <p:nvPr/>
         </p:nvSpPr>
@@ -8099,7 +7722,7 @@
       </p:sp>
       <p:sp>
         <p:nvSpPr>
-          <p:cNvPr id="112" name="TextBox 111"/>
+          <p:cNvPr id="103" name="TextBox 102"/>
           <p:cNvSpPr txBox="1"/>
           <p:nvPr/>
         </p:nvSpPr>
@@ -8141,7 +7764,7 @@
       </p:sp>
       <p:sp>
         <p:nvSpPr>
-          <p:cNvPr id="113" name="Rectangle 112"/>
+          <p:cNvPr id="104" name="Rectangle 103"/>
           <p:cNvSpPr/>
           <p:nvPr/>
         </p:nvSpPr>
@@ -8186,7 +7809,7 @@
       </p:sp>
       <p:sp>
         <p:nvSpPr>
-          <p:cNvPr id="114" name="TextBox 113"/>
+          <p:cNvPr id="105" name="TextBox 104"/>
           <p:cNvSpPr txBox="1"/>
           <p:nvPr/>
         </p:nvSpPr>
@@ -8228,7 +7851,7 @@
       </p:sp>
       <p:sp>
         <p:nvSpPr>
-          <p:cNvPr id="115" name="TextBox 114"/>
+          <p:cNvPr id="106" name="TextBox 105"/>
           <p:cNvSpPr txBox="1"/>
           <p:nvPr/>
         </p:nvSpPr>
@@ -8270,7 +7893,7 @@
       </p:sp>
       <p:sp>
         <p:nvSpPr>
-          <p:cNvPr id="116" name="TextBox 115"/>
+          <p:cNvPr id="107" name="TextBox 106"/>
           <p:cNvSpPr txBox="1"/>
           <p:nvPr/>
         </p:nvSpPr>
@@ -8312,7 +7935,7 @@
       </p:sp>
       <p:sp>
         <p:nvSpPr>
-          <p:cNvPr id="117" name="TextBox 116"/>
+          <p:cNvPr id="108" name="TextBox 107"/>
           <p:cNvSpPr txBox="1"/>
           <p:nvPr/>
         </p:nvSpPr>

</xml_diff>

<commit_message>
Centraliza os cards do painel
</commit_message>
<xml_diff>
--- a/exportacoes/Painel_Gestao_Pessoal_PMCE_EDITAVEL.pptx
+++ b/exportacoes/Painel_Gestao_Pessoal_PMCE_EDITAVEL.pptx
@@ -4373,8 +4373,8 @@
         </p:nvSpPr>
         <p:spPr>
           <a:xfrm>
-            <a:off x="228600" y="1435608"/>
-            <a:ext cx="2816352" cy="941832"/>
+            <a:off x="768096" y="1435608"/>
+            <a:ext cx="2542032" cy="941832"/>
           </a:xfrm>
           <a:prstGeom prst="roundRect">
             <a:avLst/>
@@ -4418,7 +4418,7 @@
         </p:nvSpPr>
         <p:spPr>
           <a:xfrm>
-            <a:off x="228600" y="1499616"/>
+            <a:off x="768096" y="1499616"/>
             <a:ext cx="32004" cy="813816"/>
           </a:xfrm>
           <a:prstGeom prst="rect">
@@ -4461,8 +4461,8 @@
         </p:nvSpPr>
         <p:spPr>
           <a:xfrm>
-            <a:off x="356616" y="1554480"/>
-            <a:ext cx="2148840" cy="237744"/>
+            <a:off x="896112" y="1554480"/>
+            <a:ext cx="1874519" cy="237744"/>
           </a:xfrm>
           <a:prstGeom prst="rect">
             <a:avLst/>
@@ -4503,7 +4503,7 @@
         </p:nvSpPr>
         <p:spPr>
           <a:xfrm>
-            <a:off x="2670048" y="1554480"/>
+            <a:off x="2935223" y="1554480"/>
             <a:ext cx="256032" cy="256032"/>
           </a:xfrm>
           <a:prstGeom prst="roundRect">
@@ -4546,7 +4546,7 @@
         </p:nvSpPr>
         <p:spPr>
           <a:xfrm>
-            <a:off x="2670048" y="1554480"/>
+            <a:off x="2935223" y="1554480"/>
             <a:ext cx="256032" cy="256032"/>
           </a:xfrm>
           <a:prstGeom prst="rect">
@@ -4588,7 +4588,7 @@
         </p:nvSpPr>
         <p:spPr>
           <a:xfrm>
-            <a:off x="356616" y="1856232"/>
+            <a:off x="896112" y="1856232"/>
             <a:ext cx="713232" cy="301752"/>
           </a:xfrm>
           <a:prstGeom prst="rect">
@@ -4630,7 +4630,7 @@
         </p:nvSpPr>
         <p:spPr>
           <a:xfrm>
-            <a:off x="996695" y="1938528"/>
+            <a:off x="1536192" y="1938528"/>
             <a:ext cx="822960" cy="137160"/>
           </a:xfrm>
           <a:prstGeom prst="rect">
@@ -4672,7 +4672,7 @@
         </p:nvCxnSpPr>
         <p:spPr>
           <a:xfrm>
-            <a:off x="356616" y="2221992"/>
+            <a:off x="896112" y="2221992"/>
             <a:ext cx="128016" cy="0"/>
           </a:xfrm>
           <a:prstGeom prst="line">
@@ -4707,8 +4707,8 @@
         </p:nvSpPr>
         <p:spPr>
           <a:xfrm>
-            <a:off x="539496" y="2157984"/>
-            <a:ext cx="2368296" cy="146304"/>
+            <a:off x="1078992" y="2157984"/>
+            <a:ext cx="2093976" cy="146304"/>
           </a:xfrm>
           <a:prstGeom prst="rect">
             <a:avLst/>
@@ -4749,8 +4749,8 @@
         </p:nvSpPr>
         <p:spPr>
           <a:xfrm>
-            <a:off x="3200400" y="1435608"/>
-            <a:ext cx="2816352" cy="941832"/>
+            <a:off x="3474720" y="1435608"/>
+            <a:ext cx="2542032" cy="941832"/>
           </a:xfrm>
           <a:prstGeom prst="roundRect">
             <a:avLst/>
@@ -4794,7 +4794,7 @@
         </p:nvSpPr>
         <p:spPr>
           <a:xfrm>
-            <a:off x="3200400" y="1499616"/>
+            <a:off x="3474720" y="1499616"/>
             <a:ext cx="32004" cy="813816"/>
           </a:xfrm>
           <a:prstGeom prst="rect">
@@ -4837,8 +4837,8 @@
         </p:nvSpPr>
         <p:spPr>
           <a:xfrm>
-            <a:off x="3328416" y="1554480"/>
-            <a:ext cx="2148840" cy="237744"/>
+            <a:off x="3602736" y="1554480"/>
+            <a:ext cx="1874519" cy="237744"/>
           </a:xfrm>
           <a:prstGeom prst="rect">
             <a:avLst/>
@@ -4964,7 +4964,7 @@
         </p:nvSpPr>
         <p:spPr>
           <a:xfrm>
-            <a:off x="3328416" y="1856232"/>
+            <a:off x="3602736" y="1856232"/>
             <a:ext cx="713232" cy="301752"/>
           </a:xfrm>
           <a:prstGeom prst="rect">
@@ -5006,7 +5006,7 @@
         </p:nvSpPr>
         <p:spPr>
           <a:xfrm>
-            <a:off x="3968496" y="1938528"/>
+            <a:off x="4242816" y="1938528"/>
             <a:ext cx="822960" cy="137160"/>
           </a:xfrm>
           <a:prstGeom prst="rect">
@@ -5048,7 +5048,7 @@
         </p:nvCxnSpPr>
         <p:spPr>
           <a:xfrm>
-            <a:off x="3328416" y="2221992"/>
+            <a:off x="3602736" y="2221992"/>
             <a:ext cx="128016" cy="0"/>
           </a:xfrm>
           <a:prstGeom prst="line">
@@ -5083,8 +5083,8 @@
         </p:nvSpPr>
         <p:spPr>
           <a:xfrm>
-            <a:off x="3511296" y="2157984"/>
-            <a:ext cx="2368296" cy="146304"/>
+            <a:off x="3785615" y="2157984"/>
+            <a:ext cx="2093976" cy="146304"/>
           </a:xfrm>
           <a:prstGeom prst="rect">
             <a:avLst/>
@@ -5125,8 +5125,8 @@
         </p:nvSpPr>
         <p:spPr>
           <a:xfrm>
-            <a:off x="6172200" y="1435608"/>
-            <a:ext cx="2816352" cy="941832"/>
+            <a:off x="6181344" y="1435608"/>
+            <a:ext cx="2542032" cy="941832"/>
           </a:xfrm>
           <a:prstGeom prst="roundRect">
             <a:avLst/>
@@ -5170,7 +5170,7 @@
         </p:nvSpPr>
         <p:spPr>
           <a:xfrm>
-            <a:off x="6172200" y="1499616"/>
+            <a:off x="6181344" y="1499616"/>
             <a:ext cx="32004" cy="813816"/>
           </a:xfrm>
           <a:prstGeom prst="rect">
@@ -5213,8 +5213,8 @@
         </p:nvSpPr>
         <p:spPr>
           <a:xfrm>
-            <a:off x="6300216" y="1554480"/>
-            <a:ext cx="2148840" cy="237744"/>
+            <a:off x="6309359" y="1554480"/>
+            <a:ext cx="1874519" cy="237744"/>
           </a:xfrm>
           <a:prstGeom prst="rect">
             <a:avLst/>
@@ -5255,7 +5255,7 @@
         </p:nvSpPr>
         <p:spPr>
           <a:xfrm>
-            <a:off x="8613648" y="1554480"/>
+            <a:off x="8348471" y="1554480"/>
             <a:ext cx="256032" cy="256032"/>
           </a:xfrm>
           <a:prstGeom prst="roundRect">
@@ -5298,7 +5298,7 @@
         </p:nvSpPr>
         <p:spPr>
           <a:xfrm>
-            <a:off x="8613648" y="1554480"/>
+            <a:off x="8348471" y="1554480"/>
             <a:ext cx="256032" cy="256032"/>
           </a:xfrm>
           <a:prstGeom prst="rect">
@@ -5340,7 +5340,7 @@
         </p:nvSpPr>
         <p:spPr>
           <a:xfrm>
-            <a:off x="6300216" y="1856232"/>
+            <a:off x="6309359" y="1856232"/>
             <a:ext cx="713232" cy="301752"/>
           </a:xfrm>
           <a:prstGeom prst="rect">
@@ -5382,7 +5382,7 @@
         </p:nvSpPr>
         <p:spPr>
           <a:xfrm>
-            <a:off x="6940296" y="1938528"/>
+            <a:off x="6949440" y="1938528"/>
             <a:ext cx="822960" cy="137160"/>
           </a:xfrm>
           <a:prstGeom prst="rect">
@@ -5424,8 +5424,8 @@
         </p:nvCxnSpPr>
         <p:spPr>
           <a:xfrm>
-            <a:off x="6300216" y="2221992"/>
-            <a:ext cx="128016" cy="0"/>
+            <a:off x="6309359" y="2221992"/>
+            <a:ext cx="128017" cy="0"/>
           </a:xfrm>
           <a:prstGeom prst="line">
             <a:avLst/>
@@ -5459,8 +5459,8 @@
         </p:nvSpPr>
         <p:spPr>
           <a:xfrm>
-            <a:off x="6483096" y="2157984"/>
-            <a:ext cx="2368296" cy="146304"/>
+            <a:off x="6492240" y="2157984"/>
+            <a:ext cx="2093976" cy="146304"/>
           </a:xfrm>
           <a:prstGeom prst="rect">
             <a:avLst/>
@@ -5501,8 +5501,8 @@
         </p:nvSpPr>
         <p:spPr>
           <a:xfrm>
-            <a:off x="9144000" y="1435608"/>
-            <a:ext cx="2816352" cy="941832"/>
+            <a:off x="8887968" y="1435608"/>
+            <a:ext cx="2542032" cy="941832"/>
           </a:xfrm>
           <a:prstGeom prst="roundRect">
             <a:avLst/>
@@ -5546,7 +5546,7 @@
         </p:nvSpPr>
         <p:spPr>
           <a:xfrm>
-            <a:off x="9144000" y="1499616"/>
+            <a:off x="8887968" y="1499616"/>
             <a:ext cx="32004" cy="813816"/>
           </a:xfrm>
           <a:prstGeom prst="rect">
@@ -5589,8 +5589,8 @@
         </p:nvSpPr>
         <p:spPr>
           <a:xfrm>
-            <a:off x="9272016" y="1554480"/>
-            <a:ext cx="2148840" cy="237744"/>
+            <a:off x="9015984" y="1554480"/>
+            <a:ext cx="1874519" cy="237744"/>
           </a:xfrm>
           <a:prstGeom prst="rect">
             <a:avLst/>
@@ -5631,7 +5631,7 @@
         </p:nvSpPr>
         <p:spPr>
           <a:xfrm>
-            <a:off x="11585448" y="1554480"/>
+            <a:off x="11055096" y="1554480"/>
             <a:ext cx="256032" cy="256032"/>
           </a:xfrm>
           <a:prstGeom prst="roundRect">
@@ -5674,7 +5674,7 @@
         </p:nvSpPr>
         <p:spPr>
           <a:xfrm>
-            <a:off x="11585448" y="1554480"/>
+            <a:off x="11055096" y="1554480"/>
             <a:ext cx="256032" cy="256032"/>
           </a:xfrm>
           <a:prstGeom prst="rect">
@@ -5716,7 +5716,7 @@
         </p:nvSpPr>
         <p:spPr>
           <a:xfrm>
-            <a:off x="9272016" y="1856232"/>
+            <a:off x="9015984" y="1856232"/>
             <a:ext cx="713232" cy="301752"/>
           </a:xfrm>
           <a:prstGeom prst="rect">
@@ -5758,7 +5758,7 @@
         </p:nvSpPr>
         <p:spPr>
           <a:xfrm>
-            <a:off x="9912096" y="1938528"/>
+            <a:off x="9656064" y="1938528"/>
             <a:ext cx="822960" cy="137160"/>
           </a:xfrm>
           <a:prstGeom prst="rect">
@@ -5800,7 +5800,7 @@
         </p:nvCxnSpPr>
         <p:spPr>
           <a:xfrm>
-            <a:off x="9272016" y="2221992"/>
+            <a:off x="9015984" y="2221992"/>
             <a:ext cx="128016" cy="0"/>
           </a:xfrm>
           <a:prstGeom prst="line">
@@ -5835,8 +5835,8 @@
         </p:nvSpPr>
         <p:spPr>
           <a:xfrm>
-            <a:off x="9454896" y="2157984"/>
-            <a:ext cx="2368296" cy="146304"/>
+            <a:off x="9198864" y="2157984"/>
+            <a:ext cx="2093976" cy="146304"/>
           </a:xfrm>
           <a:prstGeom prst="rect">
             <a:avLst/>

</xml_diff>

<commit_message>
Atualiza título estratégico do card RAIO
</commit_message>
<xml_diff>
--- a/exportacoes/Painel_Gestao_Pessoal_PMCE_EDITAVEL.pptx
+++ b/exportacoes/Painel_Gestao_Pessoal_PMCE_EDITAVEL.pptx
@@ -4838,7 +4838,7 @@
         <p:spPr>
           <a:xfrm>
             <a:off x="3602736" y="1554480"/>
-            <a:ext cx="1874519" cy="237744"/>
+            <a:ext cx="1874519" cy="310896"/>
           </a:xfrm>
           <a:prstGeom prst="rect">
             <a:avLst/>
@@ -4860,13 +4860,14 @@
               </a:spcAft>
             </a:pPr>
             <a:r>
-              <a:rPr sz="780" b="1">
+              <a:rPr sz="620" b="1">
                 <a:solidFill>
                   <a:srgbClr val="16231D"/>
                 </a:solidFill>
                 <a:latin typeface="Segoe UI"/>
               </a:rPr>
-              <a:t>RAIO — Necessidade de efetivo das bases satélites</a:t>
+              <a:t>RAIO — Necessidade de efetivo para compor
+as 20 bases satélites em 3 níveis de implementação</a:t>
             </a:r>
           </a:p>
         </p:txBody>

</xml_diff>

<commit_message>
Atualiza descrições estratégicas dos cards
</commit_message>
<xml_diff>
--- a/exportacoes/Painel_Gestao_Pessoal_PMCE_EDITAVEL.pptx
+++ b/exportacoes/Painel_Gestao_Pessoal_PMCE_EDITAVEL.pptx
@@ -4462,7 +4462,7 @@
         <p:spPr>
           <a:xfrm>
             <a:off x="896112" y="1554480"/>
-            <a:ext cx="1874519" cy="237744"/>
+            <a:ext cx="1874519" cy="274320"/>
           </a:xfrm>
           <a:prstGeom prst="rect">
             <a:avLst/>
@@ -4484,13 +4484,14 @@
               </a:spcAft>
             </a:pPr>
             <a:r>
-              <a:rPr sz="780" b="1">
+              <a:rPr sz="680" b="1">
                 <a:solidFill>
                   <a:srgbClr val="16231D"/>
                 </a:solidFill>
                 <a:latin typeface="Segoe UI"/>
               </a:rPr>
-              <a:t>Saídas de efetivo</a:t>
+              <a:t>Saídas de efetivo
+(exoneração — aposentadoria)</a:t>
             </a:r>
           </a:p>
         </p:txBody>
@@ -4707,7 +4708,7 @@
         </p:nvSpPr>
         <p:spPr>
           <a:xfrm>
-            <a:off x="1078992" y="2157984"/>
+            <a:off x="1078992" y="2139696"/>
             <a:ext cx="2093976" cy="146304"/>
           </a:xfrm>
           <a:prstGeom prst="rect">
@@ -4716,7 +4717,7 @@
           <a:noFill/>
         </p:spPr>
         <p:txBody>
-          <a:bodyPr wrap="none" lIns="0" rIns="0" tIns="0" bIns="0" anchor="ctr">
+          <a:bodyPr wrap="none" lIns="0" rIns="0" tIns="0" bIns="0" anchor="t">
             <a:spAutoFit/>
           </a:bodyPr>
           <a:lstStyle/>
@@ -5084,7 +5085,7 @@
         </p:nvSpPr>
         <p:spPr>
           <a:xfrm>
-            <a:off x="3785615" y="2157984"/>
+            <a:off x="3785615" y="2139696"/>
             <a:ext cx="2093976" cy="146304"/>
           </a:xfrm>
           <a:prstGeom prst="rect">
@@ -5093,7 +5094,7 @@
           <a:noFill/>
         </p:spPr>
         <p:txBody>
-          <a:bodyPr wrap="none" lIns="0" rIns="0" tIns="0" bIns="0" anchor="ctr">
+          <a:bodyPr wrap="none" lIns="0" rIns="0" tIns="0" bIns="0" anchor="t">
             <a:spAutoFit/>
           </a:bodyPr>
           <a:lstStyle/>
@@ -5460,16 +5461,16 @@
         </p:nvSpPr>
         <p:spPr>
           <a:xfrm>
-            <a:off x="6492240" y="2157984"/>
-            <a:ext cx="2093976" cy="146304"/>
-          </a:xfrm>
-          <a:prstGeom prst="rect">
-            <a:avLst/>
-          </a:prstGeom>
-          <a:noFill/>
-        </p:spPr>
-        <p:txBody>
-          <a:bodyPr wrap="none" lIns="0" rIns="0" tIns="0" bIns="0" anchor="ctr">
+            <a:off x="6492240" y="2139696"/>
+            <a:ext cx="2093976" cy="201168"/>
+          </a:xfrm>
+          <a:prstGeom prst="rect">
+            <a:avLst/>
+          </a:prstGeom>
+          <a:noFill/>
+        </p:spPr>
+        <p:txBody>
+          <a:bodyPr wrap="none" lIns="0" rIns="0" tIns="0" bIns="0" anchor="t">
             <a:spAutoFit/>
           </a:bodyPr>
           <a:lstStyle/>
@@ -5483,13 +5484,13 @@
               </a:spcAft>
             </a:pPr>
             <a:r>
-              <a:rPr sz="550" b="0">
+              <a:rPr sz="440" b="0">
                 <a:solidFill>
                   <a:srgbClr val="6D7973"/>
                 </a:solidFill>
                 <a:latin typeface="Segoe UI"/>
               </a:rPr>
-              <a:t>POG — Policiamento Ostensivo Geral · 22 OPM negativas</a:t>
+              <a:t>POG — Policiamento Ordinário · principais unidades militares</a:t>
             </a:r>
           </a:p>
         </p:txBody>
@@ -5591,7 +5592,7 @@
         <p:spPr>
           <a:xfrm>
             <a:off x="9015984" y="1554480"/>
-            <a:ext cx="1874519" cy="237744"/>
+            <a:ext cx="1874519" cy="274320"/>
           </a:xfrm>
           <a:prstGeom prst="rect">
             <a:avLst/>
@@ -5613,13 +5614,15 @@
               </a:spcAft>
             </a:pPr>
             <a:r>
-              <a:rPr sz="780" b="1">
+              <a:rPr sz="540" b="1">
                 <a:solidFill>
                   <a:srgbClr val="16231D"/>
                 </a:solidFill>
                 <a:latin typeface="Segoe UI"/>
               </a:rPr>
-              <a:t>COPAC — Necessidade PReVio</a:t>
+              <a:t>COPAC — Necessidade de efetivo
+para compor as 10 bases, sendo 04
+prioritárias em 2026 (PReVio)</a:t>
             </a:r>
           </a:p>
         </p:txBody>
@@ -5836,7 +5839,7 @@
         </p:nvSpPr>
         <p:spPr>
           <a:xfrm>
-            <a:off x="9198864" y="2157984"/>
+            <a:off x="9198864" y="2139696"/>
             <a:ext cx="2093976" cy="146304"/>
           </a:xfrm>
           <a:prstGeom prst="rect">
@@ -5845,7 +5848,7 @@
           <a:noFill/>
         </p:spPr>
         <p:txBody>
-          <a:bodyPr wrap="none" lIns="0" rIns="0" tIns="0" bIns="0" anchor="ctr">
+          <a:bodyPr wrap="none" lIns="0" rIns="0" tIns="0" bIns="0" anchor="t">
             <a:spAutoFit/>
           </a:bodyPr>
           <a:lstStyle/>
@@ -5865,7 +5868,7 @@
                 </a:solidFill>
                 <a:latin typeface="Segoe UI"/>
               </a:rPr>
-              <a:t>Complemento para 12 bases</a:t>
+              <a:t>10 bases · 04 prioritárias em 2026</a:t>
             </a:r>
           </a:p>
         </p:txBody>
@@ -6809,7 +6812,7 @@
                 </a:solidFill>
                 <a:latin typeface="Segoe UI"/>
               </a:rPr>
-              <a:t>POLICIAMENTO OSTENSIVO GERAL (POG)</a:t>
+              <a:t>POG · POLICIAMENTO ORDINÁRIO</a:t>
             </a:r>
           </a:p>
         </p:txBody>
@@ -6935,7 +6938,7 @@
                 </a:solidFill>
                 <a:latin typeface="Segoe UI"/>
               </a:rPr>
-              <a:t>22 das 88 OPM apresentam saldo negativo.</a:t>
+              <a:t>Déficit nas principais unidades militares analisadas.</a:t>
             </a:r>
           </a:p>
         </p:txBody>
@@ -7191,7 +7194,7 @@
                 </a:solidFill>
                 <a:latin typeface="Segoe UI"/>
               </a:rPr>
-              <a:t>Complemento para 12 bases; 63,6% do padrão projetado.</a:t>
+              <a:t>10 bases; 04 prioritárias em 2026.</a:t>
             </a:r>
           </a:p>
         </p:txBody>
@@ -7278,7 +7281,7 @@
                 </a:solidFill>
                 <a:latin typeface="Segoe UI"/>
               </a:rPr>
-              <a:t>●  304 soma os saldos negativos após excluir COGEIC, CGP e marcadores não OPM.</a:t>
+              <a:t>●  POG — Policiamento Ordinário: 304 soma os saldos negativos após as exclusões.</a:t>
             </a:r>
           </a:p>
         </p:txBody>

</xml_diff>

<commit_message>
Amplia e redistribui os cards do painel
</commit_message>
<xml_diff>
--- a/exportacoes/Painel_Gestao_Pessoal_PMCE_EDITAVEL.pptx
+++ b/exportacoes/Painel_Gestao_Pessoal_PMCE_EDITAVEL.pptx
@@ -4373,8 +4373,8 @@
         </p:nvSpPr>
         <p:spPr>
           <a:xfrm>
-            <a:off x="768096" y="1435608"/>
-            <a:ext cx="2542032" cy="941832"/>
+            <a:off x="448056" y="1389888"/>
+            <a:ext cx="2743200" cy="1042415"/>
           </a:xfrm>
           <a:prstGeom prst="roundRect">
             <a:avLst/>
@@ -4418,8 +4418,8 @@
         </p:nvSpPr>
         <p:spPr>
           <a:xfrm>
-            <a:off x="768096" y="1499616"/>
-            <a:ext cx="32004" cy="813816"/>
+            <a:off x="448056" y="1453896"/>
+            <a:ext cx="32004" cy="914399"/>
           </a:xfrm>
           <a:prstGeom prst="rect">
             <a:avLst/>
@@ -4461,8 +4461,8 @@
         </p:nvSpPr>
         <p:spPr>
           <a:xfrm>
-            <a:off x="896112" y="1554480"/>
-            <a:ext cx="1874519" cy="274320"/>
+            <a:off x="576072" y="1508760"/>
+            <a:ext cx="2075688" cy="274320"/>
           </a:xfrm>
           <a:prstGeom prst="rect">
             <a:avLst/>
@@ -4504,7 +4504,7 @@
         </p:nvSpPr>
         <p:spPr>
           <a:xfrm>
-            <a:off x="2935223" y="1554480"/>
+            <a:off x="2816352" y="1508760"/>
             <a:ext cx="256032" cy="256032"/>
           </a:xfrm>
           <a:prstGeom prst="roundRect">
@@ -4547,7 +4547,7 @@
         </p:nvSpPr>
         <p:spPr>
           <a:xfrm>
-            <a:off x="2935223" y="1554480"/>
+            <a:off x="2816352" y="1508760"/>
             <a:ext cx="256032" cy="256032"/>
           </a:xfrm>
           <a:prstGeom prst="rect">
@@ -4589,8 +4589,8 @@
         </p:nvSpPr>
         <p:spPr>
           <a:xfrm>
-            <a:off x="896112" y="1856232"/>
-            <a:ext cx="713232" cy="301752"/>
+            <a:off x="576072" y="1847088"/>
+            <a:ext cx="768096" cy="329184"/>
           </a:xfrm>
           <a:prstGeom prst="rect">
             <a:avLst/>
@@ -4612,7 +4612,7 @@
               </a:spcAft>
             </a:pPr>
             <a:r>
-              <a:rPr sz="2300" b="1">
+              <a:rPr sz="2500" b="1">
                 <a:solidFill>
                   <a:srgbClr val="16231D"/>
                 </a:solidFill>
@@ -4631,7 +4631,7 @@
         </p:nvSpPr>
         <p:spPr>
           <a:xfrm>
-            <a:off x="1536192" y="1938528"/>
+            <a:off x="1280160" y="1938528"/>
             <a:ext cx="822960" cy="137160"/>
           </a:xfrm>
           <a:prstGeom prst="rect">
@@ -4654,7 +4654,7 @@
               </a:spcAft>
             </a:pPr>
             <a:r>
-              <a:rPr sz="670" b="0">
+              <a:rPr sz="690" b="0">
                 <a:solidFill>
                   <a:srgbClr val="6D7973"/>
                 </a:solidFill>
@@ -4673,8 +4673,8 @@
         </p:nvCxnSpPr>
         <p:spPr>
           <a:xfrm>
-            <a:off x="896112" y="2221992"/>
-            <a:ext cx="128016" cy="0"/>
+            <a:off x="576072" y="2267712"/>
+            <a:ext cx="146304" cy="0"/>
           </a:xfrm>
           <a:prstGeom prst="line">
             <a:avLst/>
@@ -4708,8 +4708,8 @@
         </p:nvSpPr>
         <p:spPr>
           <a:xfrm>
-            <a:off x="1078992" y="2139696"/>
-            <a:ext cx="2093976" cy="146304"/>
+            <a:off x="768096" y="2185416"/>
+            <a:ext cx="2286000" cy="146304"/>
           </a:xfrm>
           <a:prstGeom prst="rect">
             <a:avLst/>
@@ -4750,8 +4750,8 @@
         </p:nvSpPr>
         <p:spPr>
           <a:xfrm>
-            <a:off x="3474720" y="1435608"/>
-            <a:ext cx="2542032" cy="941832"/>
+            <a:off x="3300984" y="1389888"/>
+            <a:ext cx="2743200" cy="1042415"/>
           </a:xfrm>
           <a:prstGeom prst="roundRect">
             <a:avLst/>
@@ -4795,8 +4795,8 @@
         </p:nvSpPr>
         <p:spPr>
           <a:xfrm>
-            <a:off x="3474720" y="1499616"/>
-            <a:ext cx="32004" cy="813816"/>
+            <a:off x="3300984" y="1453896"/>
+            <a:ext cx="32004" cy="914399"/>
           </a:xfrm>
           <a:prstGeom prst="rect">
             <a:avLst/>
@@ -4838,8 +4838,8 @@
         </p:nvSpPr>
         <p:spPr>
           <a:xfrm>
-            <a:off x="3602736" y="1554480"/>
-            <a:ext cx="1874519" cy="310896"/>
+            <a:off x="3429000" y="1508760"/>
+            <a:ext cx="2075688" cy="310896"/>
           </a:xfrm>
           <a:prstGeom prst="rect">
             <a:avLst/>
@@ -4881,7 +4881,7 @@
         </p:nvSpPr>
         <p:spPr>
           <a:xfrm>
-            <a:off x="5641848" y="1554480"/>
+            <a:off x="5669279" y="1508760"/>
             <a:ext cx="256032" cy="256032"/>
           </a:xfrm>
           <a:prstGeom prst="roundRect">
@@ -4924,7 +4924,7 @@
         </p:nvSpPr>
         <p:spPr>
           <a:xfrm>
-            <a:off x="5641848" y="1554480"/>
+            <a:off x="5669279" y="1508760"/>
             <a:ext cx="256032" cy="256032"/>
           </a:xfrm>
           <a:prstGeom prst="rect">
@@ -4966,8 +4966,8 @@
         </p:nvSpPr>
         <p:spPr>
           <a:xfrm>
-            <a:off x="3602736" y="1856232"/>
-            <a:ext cx="713232" cy="301752"/>
+            <a:off x="3429000" y="1847088"/>
+            <a:ext cx="768096" cy="329184"/>
           </a:xfrm>
           <a:prstGeom prst="rect">
             <a:avLst/>
@@ -4989,7 +4989,7 @@
               </a:spcAft>
             </a:pPr>
             <a:r>
-              <a:rPr sz="2300" b="1">
+              <a:rPr sz="2500" b="1">
                 <a:solidFill>
                   <a:srgbClr val="16231D"/>
                 </a:solidFill>
@@ -5008,7 +5008,7 @@
         </p:nvSpPr>
         <p:spPr>
           <a:xfrm>
-            <a:off x="4242816" y="1938528"/>
+            <a:off x="4133087" y="1938528"/>
             <a:ext cx="822960" cy="137160"/>
           </a:xfrm>
           <a:prstGeom prst="rect">
@@ -5031,7 +5031,7 @@
               </a:spcAft>
             </a:pPr>
             <a:r>
-              <a:rPr sz="670" b="0">
+              <a:rPr sz="690" b="0">
                 <a:solidFill>
                   <a:srgbClr val="6D7973"/>
                 </a:solidFill>
@@ -5050,8 +5050,8 @@
         </p:nvCxnSpPr>
         <p:spPr>
           <a:xfrm>
-            <a:off x="3602736" y="2221992"/>
-            <a:ext cx="128016" cy="0"/>
+            <a:off x="3429000" y="2267712"/>
+            <a:ext cx="146303" cy="0"/>
           </a:xfrm>
           <a:prstGeom prst="line">
             <a:avLst/>
@@ -5085,8 +5085,8 @@
         </p:nvSpPr>
         <p:spPr>
           <a:xfrm>
-            <a:off x="3785615" y="2139696"/>
-            <a:ext cx="2093976" cy="146304"/>
+            <a:off x="3621024" y="2185416"/>
+            <a:ext cx="2286000" cy="146304"/>
           </a:xfrm>
           <a:prstGeom prst="rect">
             <a:avLst/>
@@ -5127,8 +5127,8 @@
         </p:nvSpPr>
         <p:spPr>
           <a:xfrm>
-            <a:off x="6181344" y="1435608"/>
-            <a:ext cx="2542032" cy="941832"/>
+            <a:off x="6153912" y="1389888"/>
+            <a:ext cx="2743200" cy="1042415"/>
           </a:xfrm>
           <a:prstGeom prst="roundRect">
             <a:avLst/>
@@ -5172,8 +5172,8 @@
         </p:nvSpPr>
         <p:spPr>
           <a:xfrm>
-            <a:off x="6181344" y="1499616"/>
-            <a:ext cx="32004" cy="813816"/>
+            <a:off x="6153912" y="1453896"/>
+            <a:ext cx="32004" cy="914399"/>
           </a:xfrm>
           <a:prstGeom prst="rect">
             <a:avLst/>
@@ -5215,8 +5215,8 @@
         </p:nvSpPr>
         <p:spPr>
           <a:xfrm>
-            <a:off x="6309359" y="1554480"/>
-            <a:ext cx="1874519" cy="237744"/>
+            <a:off x="6281928" y="1508760"/>
+            <a:ext cx="2075688" cy="237744"/>
           </a:xfrm>
           <a:prstGeom prst="rect">
             <a:avLst/>
@@ -5257,7 +5257,7 @@
         </p:nvSpPr>
         <p:spPr>
           <a:xfrm>
-            <a:off x="8348471" y="1554480"/>
+            <a:off x="8522208" y="1508760"/>
             <a:ext cx="256032" cy="256032"/>
           </a:xfrm>
           <a:prstGeom prst="roundRect">
@@ -5300,7 +5300,7 @@
         </p:nvSpPr>
         <p:spPr>
           <a:xfrm>
-            <a:off x="8348471" y="1554480"/>
+            <a:off x="8522208" y="1508760"/>
             <a:ext cx="256032" cy="256032"/>
           </a:xfrm>
           <a:prstGeom prst="rect">
@@ -5342,8 +5342,8 @@
         </p:nvSpPr>
         <p:spPr>
           <a:xfrm>
-            <a:off x="6309359" y="1856232"/>
-            <a:ext cx="713232" cy="301752"/>
+            <a:off x="6281928" y="1847088"/>
+            <a:ext cx="768096" cy="329184"/>
           </a:xfrm>
           <a:prstGeom prst="rect">
             <a:avLst/>
@@ -5365,7 +5365,7 @@
               </a:spcAft>
             </a:pPr>
             <a:r>
-              <a:rPr sz="2300" b="1">
+              <a:rPr sz="2500" b="1">
                 <a:solidFill>
                   <a:srgbClr val="16231D"/>
                 </a:solidFill>
@@ -5384,7 +5384,7 @@
         </p:nvSpPr>
         <p:spPr>
           <a:xfrm>
-            <a:off x="6949440" y="1938528"/>
+            <a:off x="6986016" y="1938528"/>
             <a:ext cx="822960" cy="137160"/>
           </a:xfrm>
           <a:prstGeom prst="rect">
@@ -5407,7 +5407,7 @@
               </a:spcAft>
             </a:pPr>
             <a:r>
-              <a:rPr sz="670" b="0">
+              <a:rPr sz="690" b="0">
                 <a:solidFill>
                   <a:srgbClr val="6D7973"/>
                 </a:solidFill>
@@ -5426,8 +5426,8 @@
         </p:nvCxnSpPr>
         <p:spPr>
           <a:xfrm>
-            <a:off x="6309359" y="2221992"/>
-            <a:ext cx="128017" cy="0"/>
+            <a:off x="6281928" y="2267712"/>
+            <a:ext cx="146304" cy="0"/>
           </a:xfrm>
           <a:prstGeom prst="line">
             <a:avLst/>
@@ -5461,8 +5461,8 @@
         </p:nvSpPr>
         <p:spPr>
           <a:xfrm>
-            <a:off x="6492240" y="2139696"/>
-            <a:ext cx="2093976" cy="201168"/>
+            <a:off x="6473952" y="2185416"/>
+            <a:ext cx="2286000" cy="201168"/>
           </a:xfrm>
           <a:prstGeom prst="rect">
             <a:avLst/>
@@ -5503,8 +5503,8 @@
         </p:nvSpPr>
         <p:spPr>
           <a:xfrm>
-            <a:off x="8887968" y="1435608"/>
-            <a:ext cx="2542032" cy="941832"/>
+            <a:off x="9006840" y="1389888"/>
+            <a:ext cx="2743200" cy="1042415"/>
           </a:xfrm>
           <a:prstGeom prst="roundRect">
             <a:avLst/>
@@ -5548,8 +5548,8 @@
         </p:nvSpPr>
         <p:spPr>
           <a:xfrm>
-            <a:off x="8887968" y="1499616"/>
-            <a:ext cx="32004" cy="813816"/>
+            <a:off x="9006840" y="1453896"/>
+            <a:ext cx="32004" cy="914399"/>
           </a:xfrm>
           <a:prstGeom prst="rect">
             <a:avLst/>
@@ -5591,8 +5591,8 @@
         </p:nvSpPr>
         <p:spPr>
           <a:xfrm>
-            <a:off x="9015984" y="1554480"/>
-            <a:ext cx="1874519" cy="274320"/>
+            <a:off x="9134856" y="1508760"/>
+            <a:ext cx="2075688" cy="274320"/>
           </a:xfrm>
           <a:prstGeom prst="rect">
             <a:avLst/>
@@ -5635,7 +5635,7 @@
         </p:nvSpPr>
         <p:spPr>
           <a:xfrm>
-            <a:off x="11055096" y="1554480"/>
+            <a:off x="11375136" y="1508760"/>
             <a:ext cx="256032" cy="256032"/>
           </a:xfrm>
           <a:prstGeom prst="roundRect">
@@ -5678,7 +5678,7 @@
         </p:nvSpPr>
         <p:spPr>
           <a:xfrm>
-            <a:off x="11055096" y="1554480"/>
+            <a:off x="11375136" y="1508760"/>
             <a:ext cx="256032" cy="256032"/>
           </a:xfrm>
           <a:prstGeom prst="rect">
@@ -5720,8 +5720,8 @@
         </p:nvSpPr>
         <p:spPr>
           <a:xfrm>
-            <a:off x="9015984" y="1856232"/>
-            <a:ext cx="713232" cy="301752"/>
+            <a:off x="9134856" y="1847088"/>
+            <a:ext cx="768096" cy="329184"/>
           </a:xfrm>
           <a:prstGeom prst="rect">
             <a:avLst/>
@@ -5743,7 +5743,7 @@
               </a:spcAft>
             </a:pPr>
             <a:r>
-              <a:rPr sz="2300" b="1">
+              <a:rPr sz="2500" b="1">
                 <a:solidFill>
                   <a:srgbClr val="16231D"/>
                 </a:solidFill>
@@ -5762,7 +5762,7 @@
         </p:nvSpPr>
         <p:spPr>
           <a:xfrm>
-            <a:off x="9656064" y="1938528"/>
+            <a:off x="9838944" y="1938528"/>
             <a:ext cx="822960" cy="137160"/>
           </a:xfrm>
           <a:prstGeom prst="rect">
@@ -5785,7 +5785,7 @@
               </a:spcAft>
             </a:pPr>
             <a:r>
-              <a:rPr sz="670" b="0">
+              <a:rPr sz="690" b="0">
                 <a:solidFill>
                   <a:srgbClr val="6D7973"/>
                 </a:solidFill>
@@ -5804,8 +5804,8 @@
         </p:nvCxnSpPr>
         <p:spPr>
           <a:xfrm>
-            <a:off x="9015984" y="2221992"/>
-            <a:ext cx="128016" cy="0"/>
+            <a:off x="9134856" y="2267712"/>
+            <a:ext cx="146304" cy="0"/>
           </a:xfrm>
           <a:prstGeom prst="line">
             <a:avLst/>
@@ -5839,8 +5839,8 @@
         </p:nvSpPr>
         <p:spPr>
           <a:xfrm>
-            <a:off x="9198864" y="2139696"/>
-            <a:ext cx="2093976" cy="146304"/>
+            <a:off x="9326880" y="2185416"/>
+            <a:ext cx="2286000" cy="146304"/>
           </a:xfrm>
           <a:prstGeom prst="rect">
             <a:avLst/>

</xml_diff>

<commit_message>
Recalcula déficit e detalha informações por batalhão
</commit_message>
<xml_diff>
--- a/exportacoes/Painel_Gestao_Pessoal_PMCE_EDITAVEL.pptx
+++ b/exportacoes/Painel_Gestao_Pessoal_PMCE_EDITAVEL.pptx
@@ -5179,7 +5179,7 @@
             <a:avLst/>
           </a:prstGeom>
           <a:solidFill>
-            <a:srgbClr val="B58E35"/>
+            <a:srgbClr val="216F4C"/>
           </a:solidFill>
           <a:ln w="8890">
             <a:noFill/>
@@ -5264,7 +5264,7 @@
             <a:avLst/>
           </a:prstGeom>
           <a:solidFill>
-            <a:srgbClr val="F7EFD9"/>
+            <a:srgbClr val="E4F2E9"/>
           </a:solidFill>
           <a:ln w="8890">
             <a:noFill/>
@@ -5325,7 +5325,7 @@
             <a:r>
               <a:rPr sz="800" b="1">
                 <a:solidFill>
-                  <a:srgbClr val="B58E35"/>
+                  <a:srgbClr val="216F4C"/>
                 </a:solidFill>
                 <a:latin typeface="Segoe UI"/>
               </a:rPr>
@@ -5371,7 +5371,7 @@
                 </a:solidFill>
                 <a:latin typeface="Segoe UI"/>
               </a:rPr>
-              <a:t>304</a:t>
+              <a:t>111</a:t>
             </a:r>
           </a:p>
         </p:txBody>
@@ -5434,7 +5434,7 @@
           </a:prstGeom>
           <a:ln w="16510">
             <a:solidFill>
-              <a:srgbClr val="B58E35"/>
+              <a:srgbClr val="216F4C"/>
             </a:solidFill>
           </a:ln>
         </p:spPr>
@@ -5490,7 +5490,7 @@
                 </a:solidFill>
                 <a:latin typeface="Segoe UI"/>
               </a:rPr>
-              <a:t>POG — Policiamento Ordinário · principais unidades militares</a:t>
+              <a:t>POG — Policiamento Ordinário · 34 BPMs territoriais</a:t>
             </a:r>
           </a:p>
         </p:txBody>
@@ -6747,7 +6747,7 @@
             <a:avLst/>
           </a:prstGeom>
           <a:solidFill>
-            <a:srgbClr val="B58E35"/>
+            <a:srgbClr val="216F4C"/>
           </a:solidFill>
           <a:ln w="8890">
             <a:noFill/>
@@ -6854,7 +6854,7 @@
                 </a:solidFill>
                 <a:latin typeface="Segoe UI"/>
               </a:rPr>
-              <a:t>304</a:t>
+              <a:t>111</a:t>
             </a:r>
           </a:p>
         </p:txBody>
@@ -6938,7 +6938,7 @@
                 </a:solidFill>
                 <a:latin typeface="Segoe UI"/>
               </a:rPr>
-              <a:t>Déficit nas principais unidades militares analisadas.</a:t>
+              <a:t>Déficit calculado nos 34 BPMs territoriais.</a:t>
             </a:r>
           </a:p>
         </p:txBody>
@@ -7277,11 +7277,11 @@
             <a:r>
               <a:rPr sz="430" b="0">
                 <a:solidFill>
-                  <a:srgbClr val="806D3C"/>
-                </a:solidFill>
-                <a:latin typeface="Segoe UI"/>
-              </a:rPr>
-              <a:t>●  POG — Policiamento Ordinário: 304 soma os saldos negativos após as exclusões.</a:t>
+                  <a:srgbClr val="216F4C"/>
+                </a:solidFill>
+                <a:latin typeface="Segoe UI"/>
+              </a:rPr>
+              <a:t>●  POG — Policiamento Ordinário: 111 soma as perdas dos 12 BPMs com saldo negativo.</a:t>
             </a:r>
           </a:p>
         </p:txBody>
@@ -8949,7 +8949,7 @@
             <a:avLst/>
           </a:prstGeom>
           <a:solidFill>
-            <a:srgbClr val="3B7E9D"/>
+            <a:srgbClr val="13523B"/>
           </a:solidFill>
           <a:ln w="8890">
             <a:noFill/>
@@ -9014,7 +9014,7 @@
                 </a:solidFill>
                 <a:latin typeface="Segoe UI"/>
               </a:rPr>
-              <a:t>UNIDADES IDENTIFICADAS</a:t>
+              <a:t>BATALHÕES DESTACADOS</a:t>
             </a:r>
           </a:p>
         </p:txBody>
@@ -9056,7 +9056,7 @@
                 </a:solidFill>
                 <a:latin typeface="Segoe UI"/>
               </a:rPr>
-              <a:t>65</a:t>
+              <a:t>7</a:t>
             </a:r>
           </a:p>
         </p:txBody>
@@ -9098,7 +9098,7 @@
                 </a:solidFill>
                 <a:latin typeface="Segoe UI"/>
               </a:rPr>
-              <a:t>OPMs consolidadas pela unidade principal</a:t>
+              <a:t>BPMs no ranking territorial de origens</a:t>
             </a:r>
           </a:p>
         </p:txBody>
@@ -9519,7 +9519,7 @@
                 </a:solidFill>
                 <a:latin typeface="Segoe UI"/>
               </a:rPr>
-              <a:t>OPMs com mais saídas</a:t>
+              <a:t>Batalhões com mais saídas</a:t>
             </a:r>
           </a:p>
         </p:txBody>
@@ -9561,7 +9561,7 @@
                 </a:solidFill>
                 <a:latin typeface="Segoe UI"/>
               </a:rPr>
-              <a:t>Companhias agrupadas pela unidade principal · Top 10</a:t>
+              <a:t>BPMs presentes entre as principais origens · Top 7</a:t>
             </a:r>
           </a:p>
         </p:txBody>
@@ -9617,7 +9617,7 @@
         <p:spPr>
           <a:xfrm>
             <a:off x="649224" y="2834640"/>
-            <a:ext cx="786384" cy="128016"/>
+            <a:ext cx="1554480" cy="128016"/>
           </a:xfrm>
           <a:prstGeom prst="rect">
             <a:avLst/>
@@ -9645,7 +9645,7 @@
                 </a:solidFill>
                 <a:latin typeface="Segoe UI"/>
               </a:rPr>
-              <a:t>CPRAIO</a:t>
+              <a:t>12º BPM · Caucaia</a:t>
             </a:r>
           </a:p>
         </p:txBody>
@@ -9658,8 +9658,8 @@
         </p:nvSpPr>
         <p:spPr>
           <a:xfrm>
-            <a:off x="1481328" y="2866644"/>
-            <a:ext cx="3346703" cy="68580"/>
+            <a:off x="2249424" y="2866644"/>
+            <a:ext cx="2578607" cy="68580"/>
           </a:xfrm>
           <a:prstGeom prst="roundRect">
             <a:avLst/>
@@ -9701,8 +9701,8 @@
         </p:nvSpPr>
         <p:spPr>
           <a:xfrm>
-            <a:off x="1481328" y="2866644"/>
-            <a:ext cx="3346703" cy="68580"/>
+            <a:off x="2249424" y="2866644"/>
+            <a:ext cx="2578607" cy="68580"/>
           </a:xfrm>
           <a:prstGeom prst="roundRect">
             <a:avLst/>
@@ -9786,7 +9786,7 @@
         </p:nvSpPr>
         <p:spPr>
           <a:xfrm>
-            <a:off x="438912" y="3131820"/>
+            <a:off x="438912" y="3209544"/>
             <a:ext cx="164592" cy="128016"/>
           </a:xfrm>
           <a:prstGeom prst="rect">
@@ -9828,8 +9828,8 @@
         </p:nvSpPr>
         <p:spPr>
           <a:xfrm>
-            <a:off x="649224" y="3131820"/>
-            <a:ext cx="786384" cy="128016"/>
+            <a:off x="649224" y="3209544"/>
+            <a:ext cx="1554480" cy="128016"/>
           </a:xfrm>
           <a:prstGeom prst="rect">
             <a:avLst/>
@@ -9857,7 +9857,7 @@
                 </a:solidFill>
                 <a:latin typeface="Segoe UI"/>
               </a:rPr>
-              <a:t>12º BPM</a:t>
+              <a:t>17º BPM · Fortaleza</a:t>
             </a:r>
           </a:p>
         </p:txBody>
@@ -9870,8 +9870,8 @@
         </p:nvSpPr>
         <p:spPr>
           <a:xfrm>
-            <a:off x="1481328" y="3163824"/>
-            <a:ext cx="3346703" cy="68580"/>
+            <a:off x="2249424" y="3241548"/>
+            <a:ext cx="2578607" cy="68580"/>
           </a:xfrm>
           <a:prstGeom prst="roundRect">
             <a:avLst/>
@@ -9913,8 +9913,8 @@
         </p:nvSpPr>
         <p:spPr>
           <a:xfrm>
-            <a:off x="1481328" y="3163824"/>
-            <a:ext cx="3346703" cy="68580"/>
+            <a:off x="2249424" y="3241548"/>
+            <a:ext cx="2123559" cy="68580"/>
           </a:xfrm>
           <a:prstGeom prst="roundRect">
             <a:avLst/>
@@ -9956,7 +9956,7 @@
         </p:nvSpPr>
         <p:spPr>
           <a:xfrm>
-            <a:off x="5084064" y="3131820"/>
+            <a:off x="5084064" y="3209544"/>
             <a:ext cx="658368" cy="128016"/>
           </a:xfrm>
           <a:prstGeom prst="rect">
@@ -9985,7 +9985,7 @@
                 </a:solidFill>
                 <a:latin typeface="Segoe UI"/>
               </a:rPr>
-              <a:t>17 · 5,2%</a:t>
+              <a:t>14 · 4,3%</a:t>
             </a:r>
           </a:p>
         </p:txBody>
@@ -9998,7 +9998,7 @@
         </p:nvSpPr>
         <p:spPr>
           <a:xfrm>
-            <a:off x="438912" y="3429000"/>
+            <a:off x="438912" y="3584448"/>
             <a:ext cx="164592" cy="128016"/>
           </a:xfrm>
           <a:prstGeom prst="rect">
@@ -10040,8 +10040,8 @@
         </p:nvSpPr>
         <p:spPr>
           <a:xfrm>
-            <a:off x="649224" y="3429000"/>
-            <a:ext cx="786384" cy="128016"/>
+            <a:off x="649224" y="3584448"/>
+            <a:ext cx="1554480" cy="128016"/>
           </a:xfrm>
           <a:prstGeom prst="rect">
             <a:avLst/>
@@ -10069,7 +10069,7 @@
                 </a:solidFill>
                 <a:latin typeface="Segoe UI"/>
               </a:rPr>
-              <a:t>17º BPM</a:t>
+              <a:t>18º BPM · Fortaleza</a:t>
             </a:r>
           </a:p>
         </p:txBody>
@@ -10082,8 +10082,8 @@
         </p:nvSpPr>
         <p:spPr>
           <a:xfrm>
-            <a:off x="1481328" y="3461004"/>
-            <a:ext cx="3346703" cy="68580"/>
+            <a:off x="2249424" y="3616452"/>
+            <a:ext cx="2578607" cy="68580"/>
           </a:xfrm>
           <a:prstGeom prst="roundRect">
             <a:avLst/>
@@ -10125,8 +10125,8 @@
         </p:nvSpPr>
         <p:spPr>
           <a:xfrm>
-            <a:off x="1481328" y="3461004"/>
-            <a:ext cx="2756109" cy="68580"/>
+            <a:off x="2249424" y="3616452"/>
+            <a:ext cx="2123559" cy="68580"/>
           </a:xfrm>
           <a:prstGeom prst="roundRect">
             <a:avLst/>
@@ -10168,7 +10168,7 @@
         </p:nvSpPr>
         <p:spPr>
           <a:xfrm>
-            <a:off x="5084064" y="3429000"/>
+            <a:off x="5084064" y="3584448"/>
             <a:ext cx="658368" cy="128016"/>
           </a:xfrm>
           <a:prstGeom prst="rect">
@@ -10210,7 +10210,7 @@
         </p:nvSpPr>
         <p:spPr>
           <a:xfrm>
-            <a:off x="438912" y="3726180"/>
+            <a:off x="438912" y="3959352"/>
             <a:ext cx="164592" cy="128016"/>
           </a:xfrm>
           <a:prstGeom prst="rect">
@@ -10252,8 +10252,8 @@
         </p:nvSpPr>
         <p:spPr>
           <a:xfrm>
-            <a:off x="649224" y="3726180"/>
-            <a:ext cx="786384" cy="128016"/>
+            <a:off x="649224" y="3959352"/>
+            <a:ext cx="1554480" cy="128016"/>
           </a:xfrm>
           <a:prstGeom prst="rect">
             <a:avLst/>
@@ -10281,7 +10281,7 @@
                 </a:solidFill>
                 <a:latin typeface="Segoe UI"/>
               </a:rPr>
-              <a:t>18º BPM</a:t>
+              <a:t>6º BPM · Fortaleza</a:t>
             </a:r>
           </a:p>
         </p:txBody>
@@ -10294,8 +10294,8 @@
         </p:nvSpPr>
         <p:spPr>
           <a:xfrm>
-            <a:off x="1481328" y="3758184"/>
-            <a:ext cx="3346703" cy="68580"/>
+            <a:off x="2249424" y="3991356"/>
+            <a:ext cx="2578607" cy="68580"/>
           </a:xfrm>
           <a:prstGeom prst="roundRect">
             <a:avLst/>
@@ -10337,8 +10337,8 @@
         </p:nvSpPr>
         <p:spPr>
           <a:xfrm>
-            <a:off x="1481328" y="3758184"/>
-            <a:ext cx="2756109" cy="68580"/>
+            <a:off x="2249424" y="3991356"/>
+            <a:ext cx="2123559" cy="68580"/>
           </a:xfrm>
           <a:prstGeom prst="roundRect">
             <a:avLst/>
@@ -10380,7 +10380,7 @@
         </p:nvSpPr>
         <p:spPr>
           <a:xfrm>
-            <a:off x="5084064" y="3726180"/>
+            <a:off x="5084064" y="3959352"/>
             <a:ext cx="658368" cy="128016"/>
           </a:xfrm>
           <a:prstGeom prst="rect">
@@ -10422,7 +10422,7 @@
         </p:nvSpPr>
         <p:spPr>
           <a:xfrm>
-            <a:off x="438912" y="4023360"/>
+            <a:off x="438912" y="4334256"/>
             <a:ext cx="164592" cy="128016"/>
           </a:xfrm>
           <a:prstGeom prst="rect">
@@ -10464,8 +10464,8 @@
         </p:nvSpPr>
         <p:spPr>
           <a:xfrm>
-            <a:off x="649224" y="4023360"/>
-            <a:ext cx="786384" cy="128016"/>
+            <a:off x="649224" y="4334256"/>
+            <a:ext cx="1554480" cy="128016"/>
           </a:xfrm>
           <a:prstGeom prst="rect">
             <a:avLst/>
@@ -10493,7 +10493,7 @@
                 </a:solidFill>
                 <a:latin typeface="Segoe UI"/>
               </a:rPr>
-              <a:t>6º BPM</a:t>
+              <a:t>19º BPM · Fortaleza</a:t>
             </a:r>
           </a:p>
         </p:txBody>
@@ -10506,8 +10506,8 @@
         </p:nvSpPr>
         <p:spPr>
           <a:xfrm>
-            <a:off x="1481328" y="4055364"/>
-            <a:ext cx="3346703" cy="68580"/>
+            <a:off x="2249424" y="4366260"/>
+            <a:ext cx="2578607" cy="68580"/>
           </a:xfrm>
           <a:prstGeom prst="roundRect">
             <a:avLst/>
@@ -10549,8 +10549,8 @@
         </p:nvSpPr>
         <p:spPr>
           <a:xfrm>
-            <a:off x="1481328" y="4055364"/>
-            <a:ext cx="2756109" cy="68580"/>
+            <a:off x="2249424" y="4366260"/>
+            <a:ext cx="1820193" cy="68580"/>
           </a:xfrm>
           <a:prstGeom prst="roundRect">
             <a:avLst/>
@@ -10592,7 +10592,7 @@
         </p:nvSpPr>
         <p:spPr>
           <a:xfrm>
-            <a:off x="5084064" y="4023360"/>
+            <a:off x="5084064" y="4334256"/>
             <a:ext cx="658368" cy="128016"/>
           </a:xfrm>
           <a:prstGeom prst="rect">
@@ -10621,7 +10621,7 @@
                 </a:solidFill>
                 <a:latin typeface="Segoe UI"/>
               </a:rPr>
-              <a:t>14 · 4,3%</a:t>
+              <a:t>12 · 3,7%</a:t>
             </a:r>
           </a:p>
         </p:txBody>
@@ -10634,7 +10634,7 @@
         </p:nvSpPr>
         <p:spPr>
           <a:xfrm>
-            <a:off x="438912" y="4320540"/>
+            <a:off x="438912" y="4709160"/>
             <a:ext cx="164592" cy="128016"/>
           </a:xfrm>
           <a:prstGeom prst="rect">
@@ -10676,8 +10676,8 @@
         </p:nvSpPr>
         <p:spPr>
           <a:xfrm>
-            <a:off x="649224" y="4320540"/>
-            <a:ext cx="786384" cy="128016"/>
+            <a:off x="649224" y="4709160"/>
+            <a:ext cx="1554480" cy="128016"/>
           </a:xfrm>
           <a:prstGeom prst="rect">
             <a:avLst/>
@@ -10705,7 +10705,7 @@
                 </a:solidFill>
                 <a:latin typeface="Segoe UI"/>
               </a:rPr>
-              <a:t>BPTUR</a:t>
+              <a:t>20º BPM · Fortaleza</a:t>
             </a:r>
           </a:p>
         </p:txBody>
@@ -10718,8 +10718,8 @@
         </p:nvSpPr>
         <p:spPr>
           <a:xfrm>
-            <a:off x="1481328" y="4352544"/>
-            <a:ext cx="3346703" cy="68580"/>
+            <a:off x="2249424" y="4741164"/>
+            <a:ext cx="2578607" cy="68580"/>
           </a:xfrm>
           <a:prstGeom prst="roundRect">
             <a:avLst/>
@@ -10761,8 +10761,8 @@
         </p:nvSpPr>
         <p:spPr>
           <a:xfrm>
-            <a:off x="1481328" y="4352544"/>
-            <a:ext cx="2559244" cy="68580"/>
+            <a:off x="2249424" y="4741164"/>
+            <a:ext cx="1668511" cy="68580"/>
           </a:xfrm>
           <a:prstGeom prst="roundRect">
             <a:avLst/>
@@ -10804,7 +10804,7 @@
         </p:nvSpPr>
         <p:spPr>
           <a:xfrm>
-            <a:off x="5084064" y="4320540"/>
+            <a:off x="5084064" y="4709160"/>
             <a:ext cx="658368" cy="128016"/>
           </a:xfrm>
           <a:prstGeom prst="rect">
@@ -10833,7 +10833,7 @@
                 </a:solidFill>
                 <a:latin typeface="Segoe UI"/>
               </a:rPr>
-              <a:t>13 · 4,0%</a:t>
+              <a:t>11 · 3,4%</a:t>
             </a:r>
           </a:p>
         </p:txBody>
@@ -10846,7 +10846,7 @@
         </p:nvSpPr>
         <p:spPr>
           <a:xfrm>
-            <a:off x="438912" y="4617720"/>
+            <a:off x="438912" y="5084064"/>
             <a:ext cx="164592" cy="128016"/>
           </a:xfrm>
           <a:prstGeom prst="rect">
@@ -10888,8 +10888,8 @@
         </p:nvSpPr>
         <p:spPr>
           <a:xfrm>
-            <a:off x="649224" y="4617720"/>
-            <a:ext cx="786384" cy="128016"/>
+            <a:off x="649224" y="5084064"/>
+            <a:ext cx="1554480" cy="128016"/>
           </a:xfrm>
           <a:prstGeom prst="rect">
             <a:avLst/>
@@ -10917,7 +10917,7 @@
                 </a:solidFill>
                 <a:latin typeface="Segoe UI"/>
               </a:rPr>
-              <a:t>COPAC</a:t>
+              <a:t>24º BPM · Maranguape</a:t>
             </a:r>
           </a:p>
         </p:txBody>
@@ -10930,8 +10930,8 @@
         </p:nvSpPr>
         <p:spPr>
           <a:xfrm>
-            <a:off x="1481328" y="4649724"/>
-            <a:ext cx="3346703" cy="68580"/>
+            <a:off x="2249424" y="5116068"/>
+            <a:ext cx="2578607" cy="68580"/>
           </a:xfrm>
           <a:prstGeom prst="roundRect">
             <a:avLst/>
@@ -10973,8 +10973,8 @@
         </p:nvSpPr>
         <p:spPr>
           <a:xfrm>
-            <a:off x="1481328" y="4649724"/>
-            <a:ext cx="2559244" cy="68580"/>
+            <a:off x="2249424" y="5116068"/>
+            <a:ext cx="1516828" cy="68580"/>
           </a:xfrm>
           <a:prstGeom prst="roundRect">
             <a:avLst/>
@@ -11016,7 +11016,7 @@
         </p:nvSpPr>
         <p:spPr>
           <a:xfrm>
-            <a:off x="5084064" y="4617720"/>
+            <a:off x="5084064" y="5084064"/>
             <a:ext cx="658368" cy="128016"/>
           </a:xfrm>
           <a:prstGeom prst="rect">
@@ -11045,7 +11045,7 @@
                 </a:solidFill>
                 <a:latin typeface="Segoe UI"/>
               </a:rPr>
-              <a:t>13 · 4,0%</a:t>
+              <a:t>10 · 3,1%</a:t>
             </a:r>
           </a:p>
         </p:txBody>
@@ -11053,642 +11053,6 @@
       <p:sp>
         <p:nvSpPr>
           <p:cNvPr id="74" name="TextBox 73"/>
-          <p:cNvSpPr txBox="1"/>
-          <p:nvPr/>
-        </p:nvSpPr>
-        <p:spPr>
-          <a:xfrm>
-            <a:off x="438912" y="4914900"/>
-            <a:ext cx="164592" cy="128016"/>
-          </a:xfrm>
-          <a:prstGeom prst="rect">
-            <a:avLst/>
-          </a:prstGeom>
-          <a:noFill/>
-        </p:spPr>
-        <p:txBody>
-          <a:bodyPr wrap="none" lIns="0" rIns="0" tIns="0" bIns="0" anchor="ctr">
-            <a:spAutoFit/>
-          </a:bodyPr>
-          <a:lstStyle/>
-          <a:p>
-            <a:pPr algn="l">
-              <a:spcBef>
-                <a:spcPts val="0"/>
-              </a:spcBef>
-              <a:spcAft>
-                <a:spcPts val="0"/>
-              </a:spcAft>
-            </a:pPr>
-            <a:r>
-              <a:rPr sz="480" b="1">
-                <a:solidFill>
-                  <a:srgbClr val="9AA49F"/>
-                </a:solidFill>
-                <a:latin typeface="Segoe UI"/>
-              </a:rPr>
-              <a:t>08</a:t>
-            </a:r>
-          </a:p>
-        </p:txBody>
-      </p:sp>
-      <p:sp>
-        <p:nvSpPr>
-          <p:cNvPr id="75" name="TextBox 74"/>
-          <p:cNvSpPr txBox="1"/>
-          <p:nvPr/>
-        </p:nvSpPr>
-        <p:spPr>
-          <a:xfrm>
-            <a:off x="649224" y="4914900"/>
-            <a:ext cx="786384" cy="128016"/>
-          </a:xfrm>
-          <a:prstGeom prst="rect">
-            <a:avLst/>
-          </a:prstGeom>
-          <a:noFill/>
-        </p:spPr>
-        <p:txBody>
-          <a:bodyPr wrap="none" lIns="0" rIns="0" tIns="0" bIns="0" anchor="ctr">
-            <a:spAutoFit/>
-          </a:bodyPr>
-          <a:lstStyle/>
-          <a:p>
-            <a:pPr algn="l">
-              <a:spcBef>
-                <a:spcPts val="0"/>
-              </a:spcBef>
-              <a:spcAft>
-                <a:spcPts val="0"/>
-              </a:spcAft>
-            </a:pPr>
-            <a:r>
-              <a:rPr sz="540" b="1">
-                <a:solidFill>
-                  <a:srgbClr val="526059"/>
-                </a:solidFill>
-                <a:latin typeface="Segoe UI"/>
-              </a:rPr>
-              <a:t>19º BPM</a:t>
-            </a:r>
-          </a:p>
-        </p:txBody>
-      </p:sp>
-      <p:sp>
-        <p:nvSpPr>
-          <p:cNvPr id="76" name="Rounded Rectangle 75"/>
-          <p:cNvSpPr/>
-          <p:nvPr/>
-        </p:nvSpPr>
-        <p:spPr>
-          <a:xfrm>
-            <a:off x="1481328" y="4946904"/>
-            <a:ext cx="3346703" cy="68580"/>
-          </a:xfrm>
-          <a:prstGeom prst="roundRect">
-            <a:avLst/>
-          </a:prstGeom>
-          <a:solidFill>
-            <a:srgbClr val="EAF0ED"/>
-          </a:solidFill>
-          <a:ln w="8890">
-            <a:noFill/>
-          </a:ln>
-        </p:spPr>
-        <p:style>
-          <a:lnRef idx="1">
-            <a:schemeClr val="accent1"/>
-          </a:lnRef>
-          <a:fillRef idx="3">
-            <a:schemeClr val="accent1"/>
-          </a:fillRef>
-          <a:effectRef idx="2">
-            <a:schemeClr val="accent1"/>
-          </a:effectRef>
-          <a:fontRef idx="minor">
-            <a:schemeClr val="lt1"/>
-          </a:fontRef>
-        </p:style>
-        <p:txBody>
-          <a:bodyPr rtlCol="0" anchor="ctr"/>
-          <a:lstStyle/>
-          <a:p>
-            <a:pPr algn="ctr"/>
-          </a:p>
-        </p:txBody>
-      </p:sp>
-      <p:sp>
-        <p:nvSpPr>
-          <p:cNvPr id="77" name="Rounded Rectangle 76"/>
-          <p:cNvSpPr/>
-          <p:nvPr/>
-        </p:nvSpPr>
-        <p:spPr>
-          <a:xfrm>
-            <a:off x="1481328" y="4946904"/>
-            <a:ext cx="2362379" cy="68580"/>
-          </a:xfrm>
-          <a:prstGeom prst="roundRect">
-            <a:avLst/>
-          </a:prstGeom>
-          <a:solidFill>
-            <a:srgbClr val="1B8258"/>
-          </a:solidFill>
-          <a:ln w="8890">
-            <a:noFill/>
-          </a:ln>
-        </p:spPr>
-        <p:style>
-          <a:lnRef idx="1">
-            <a:schemeClr val="accent1"/>
-          </a:lnRef>
-          <a:fillRef idx="3">
-            <a:schemeClr val="accent1"/>
-          </a:fillRef>
-          <a:effectRef idx="2">
-            <a:schemeClr val="accent1"/>
-          </a:effectRef>
-          <a:fontRef idx="minor">
-            <a:schemeClr val="lt1"/>
-          </a:fontRef>
-        </p:style>
-        <p:txBody>
-          <a:bodyPr rtlCol="0" anchor="ctr"/>
-          <a:lstStyle/>
-          <a:p>
-            <a:pPr algn="ctr"/>
-          </a:p>
-        </p:txBody>
-      </p:sp>
-      <p:sp>
-        <p:nvSpPr>
-          <p:cNvPr id="78" name="TextBox 77"/>
-          <p:cNvSpPr txBox="1"/>
-          <p:nvPr/>
-        </p:nvSpPr>
-        <p:spPr>
-          <a:xfrm>
-            <a:off x="5084064" y="4914900"/>
-            <a:ext cx="658368" cy="128016"/>
-          </a:xfrm>
-          <a:prstGeom prst="rect">
-            <a:avLst/>
-          </a:prstGeom>
-          <a:noFill/>
-        </p:spPr>
-        <p:txBody>
-          <a:bodyPr wrap="none" lIns="0" rIns="0" tIns="0" bIns="0" anchor="ctr">
-            <a:spAutoFit/>
-          </a:bodyPr>
-          <a:lstStyle/>
-          <a:p>
-            <a:pPr algn="r">
-              <a:spcBef>
-                <a:spcPts val="0"/>
-              </a:spcBef>
-              <a:spcAft>
-                <a:spcPts val="0"/>
-              </a:spcAft>
-            </a:pPr>
-            <a:r>
-              <a:rPr sz="520" b="1">
-                <a:solidFill>
-                  <a:srgbClr val="16231D"/>
-                </a:solidFill>
-                <a:latin typeface="Segoe UI"/>
-              </a:rPr>
-              <a:t>12 · 3,7%</a:t>
-            </a:r>
-          </a:p>
-        </p:txBody>
-      </p:sp>
-      <p:sp>
-        <p:nvSpPr>
-          <p:cNvPr id="79" name="TextBox 78"/>
-          <p:cNvSpPr txBox="1"/>
-          <p:nvPr/>
-        </p:nvSpPr>
-        <p:spPr>
-          <a:xfrm>
-            <a:off x="438912" y="5212080"/>
-            <a:ext cx="164592" cy="128016"/>
-          </a:xfrm>
-          <a:prstGeom prst="rect">
-            <a:avLst/>
-          </a:prstGeom>
-          <a:noFill/>
-        </p:spPr>
-        <p:txBody>
-          <a:bodyPr wrap="none" lIns="0" rIns="0" tIns="0" bIns="0" anchor="ctr">
-            <a:spAutoFit/>
-          </a:bodyPr>
-          <a:lstStyle/>
-          <a:p>
-            <a:pPr algn="l">
-              <a:spcBef>
-                <a:spcPts val="0"/>
-              </a:spcBef>
-              <a:spcAft>
-                <a:spcPts val="0"/>
-              </a:spcAft>
-            </a:pPr>
-            <a:r>
-              <a:rPr sz="480" b="1">
-                <a:solidFill>
-                  <a:srgbClr val="9AA49F"/>
-                </a:solidFill>
-                <a:latin typeface="Segoe UI"/>
-              </a:rPr>
-              <a:t>09</a:t>
-            </a:r>
-          </a:p>
-        </p:txBody>
-      </p:sp>
-      <p:sp>
-        <p:nvSpPr>
-          <p:cNvPr id="80" name="TextBox 79"/>
-          <p:cNvSpPr txBox="1"/>
-          <p:nvPr/>
-        </p:nvSpPr>
-        <p:spPr>
-          <a:xfrm>
-            <a:off x="649224" y="5212080"/>
-            <a:ext cx="786384" cy="128016"/>
-          </a:xfrm>
-          <a:prstGeom prst="rect">
-            <a:avLst/>
-          </a:prstGeom>
-          <a:noFill/>
-        </p:spPr>
-        <p:txBody>
-          <a:bodyPr wrap="none" lIns="0" rIns="0" tIns="0" bIns="0" anchor="ctr">
-            <a:spAutoFit/>
-          </a:bodyPr>
-          <a:lstStyle/>
-          <a:p>
-            <a:pPr algn="l">
-              <a:spcBef>
-                <a:spcPts val="0"/>
-              </a:spcBef>
-              <a:spcAft>
-                <a:spcPts val="0"/>
-              </a:spcAft>
-            </a:pPr>
-            <a:r>
-              <a:rPr sz="540" b="1">
-                <a:solidFill>
-                  <a:srgbClr val="526059"/>
-                </a:solidFill>
-                <a:latin typeface="Segoe UI"/>
-              </a:rPr>
-              <a:t>20º BPM</a:t>
-            </a:r>
-          </a:p>
-        </p:txBody>
-      </p:sp>
-      <p:sp>
-        <p:nvSpPr>
-          <p:cNvPr id="81" name="Rounded Rectangle 80"/>
-          <p:cNvSpPr/>
-          <p:nvPr/>
-        </p:nvSpPr>
-        <p:spPr>
-          <a:xfrm>
-            <a:off x="1481328" y="5244084"/>
-            <a:ext cx="3346703" cy="68580"/>
-          </a:xfrm>
-          <a:prstGeom prst="roundRect">
-            <a:avLst/>
-          </a:prstGeom>
-          <a:solidFill>
-            <a:srgbClr val="EAF0ED"/>
-          </a:solidFill>
-          <a:ln w="8890">
-            <a:noFill/>
-          </a:ln>
-        </p:spPr>
-        <p:style>
-          <a:lnRef idx="1">
-            <a:schemeClr val="accent1"/>
-          </a:lnRef>
-          <a:fillRef idx="3">
-            <a:schemeClr val="accent1"/>
-          </a:fillRef>
-          <a:effectRef idx="2">
-            <a:schemeClr val="accent1"/>
-          </a:effectRef>
-          <a:fontRef idx="minor">
-            <a:schemeClr val="lt1"/>
-          </a:fontRef>
-        </p:style>
-        <p:txBody>
-          <a:bodyPr rtlCol="0" anchor="ctr"/>
-          <a:lstStyle/>
-          <a:p>
-            <a:pPr algn="ctr"/>
-          </a:p>
-        </p:txBody>
-      </p:sp>
-      <p:sp>
-        <p:nvSpPr>
-          <p:cNvPr id="82" name="Rounded Rectangle 81"/>
-          <p:cNvSpPr/>
-          <p:nvPr/>
-        </p:nvSpPr>
-        <p:spPr>
-          <a:xfrm>
-            <a:off x="1481328" y="5244084"/>
-            <a:ext cx="2165514" cy="68580"/>
-          </a:xfrm>
-          <a:prstGeom prst="roundRect">
-            <a:avLst/>
-          </a:prstGeom>
-          <a:solidFill>
-            <a:srgbClr val="1B8258"/>
-          </a:solidFill>
-          <a:ln w="8890">
-            <a:noFill/>
-          </a:ln>
-        </p:spPr>
-        <p:style>
-          <a:lnRef idx="1">
-            <a:schemeClr val="accent1"/>
-          </a:lnRef>
-          <a:fillRef idx="3">
-            <a:schemeClr val="accent1"/>
-          </a:fillRef>
-          <a:effectRef idx="2">
-            <a:schemeClr val="accent1"/>
-          </a:effectRef>
-          <a:fontRef idx="minor">
-            <a:schemeClr val="lt1"/>
-          </a:fontRef>
-        </p:style>
-        <p:txBody>
-          <a:bodyPr rtlCol="0" anchor="ctr"/>
-          <a:lstStyle/>
-          <a:p>
-            <a:pPr algn="ctr"/>
-          </a:p>
-        </p:txBody>
-      </p:sp>
-      <p:sp>
-        <p:nvSpPr>
-          <p:cNvPr id="83" name="TextBox 82"/>
-          <p:cNvSpPr txBox="1"/>
-          <p:nvPr/>
-        </p:nvSpPr>
-        <p:spPr>
-          <a:xfrm>
-            <a:off x="5084064" y="5212080"/>
-            <a:ext cx="658368" cy="128016"/>
-          </a:xfrm>
-          <a:prstGeom prst="rect">
-            <a:avLst/>
-          </a:prstGeom>
-          <a:noFill/>
-        </p:spPr>
-        <p:txBody>
-          <a:bodyPr wrap="none" lIns="0" rIns="0" tIns="0" bIns="0" anchor="ctr">
-            <a:spAutoFit/>
-          </a:bodyPr>
-          <a:lstStyle/>
-          <a:p>
-            <a:pPr algn="r">
-              <a:spcBef>
-                <a:spcPts val="0"/>
-              </a:spcBef>
-              <a:spcAft>
-                <a:spcPts val="0"/>
-              </a:spcAft>
-            </a:pPr>
-            <a:r>
-              <a:rPr sz="520" b="1">
-                <a:solidFill>
-                  <a:srgbClr val="16231D"/>
-                </a:solidFill>
-                <a:latin typeface="Segoe UI"/>
-              </a:rPr>
-              <a:t>11 · 3,4%</a:t>
-            </a:r>
-          </a:p>
-        </p:txBody>
-      </p:sp>
-      <p:sp>
-        <p:nvSpPr>
-          <p:cNvPr id="84" name="TextBox 83"/>
-          <p:cNvSpPr txBox="1"/>
-          <p:nvPr/>
-        </p:nvSpPr>
-        <p:spPr>
-          <a:xfrm>
-            <a:off x="438912" y="5509260"/>
-            <a:ext cx="164592" cy="128016"/>
-          </a:xfrm>
-          <a:prstGeom prst="rect">
-            <a:avLst/>
-          </a:prstGeom>
-          <a:noFill/>
-        </p:spPr>
-        <p:txBody>
-          <a:bodyPr wrap="none" lIns="0" rIns="0" tIns="0" bIns="0" anchor="ctr">
-            <a:spAutoFit/>
-          </a:bodyPr>
-          <a:lstStyle/>
-          <a:p>
-            <a:pPr algn="l">
-              <a:spcBef>
-                <a:spcPts val="0"/>
-              </a:spcBef>
-              <a:spcAft>
-                <a:spcPts val="0"/>
-              </a:spcAft>
-            </a:pPr>
-            <a:r>
-              <a:rPr sz="480" b="1">
-                <a:solidFill>
-                  <a:srgbClr val="9AA49F"/>
-                </a:solidFill>
-                <a:latin typeface="Segoe UI"/>
-              </a:rPr>
-              <a:t>10</a:t>
-            </a:r>
-          </a:p>
-        </p:txBody>
-      </p:sp>
-      <p:sp>
-        <p:nvSpPr>
-          <p:cNvPr id="85" name="TextBox 84"/>
-          <p:cNvSpPr txBox="1"/>
-          <p:nvPr/>
-        </p:nvSpPr>
-        <p:spPr>
-          <a:xfrm>
-            <a:off x="649224" y="5509260"/>
-            <a:ext cx="786384" cy="128016"/>
-          </a:xfrm>
-          <a:prstGeom prst="rect">
-            <a:avLst/>
-          </a:prstGeom>
-          <a:noFill/>
-        </p:spPr>
-        <p:txBody>
-          <a:bodyPr wrap="none" lIns="0" rIns="0" tIns="0" bIns="0" anchor="ctr">
-            <a:spAutoFit/>
-          </a:bodyPr>
-          <a:lstStyle/>
-          <a:p>
-            <a:pPr algn="l">
-              <a:spcBef>
-                <a:spcPts val="0"/>
-              </a:spcBef>
-              <a:spcAft>
-                <a:spcPts val="0"/>
-              </a:spcAft>
-            </a:pPr>
-            <a:r>
-              <a:rPr sz="540" b="1">
-                <a:solidFill>
-                  <a:srgbClr val="526059"/>
-                </a:solidFill>
-                <a:latin typeface="Segoe UI"/>
-              </a:rPr>
-              <a:t>24º BPM</a:t>
-            </a:r>
-          </a:p>
-        </p:txBody>
-      </p:sp>
-      <p:sp>
-        <p:nvSpPr>
-          <p:cNvPr id="86" name="Rounded Rectangle 85"/>
-          <p:cNvSpPr/>
-          <p:nvPr/>
-        </p:nvSpPr>
-        <p:spPr>
-          <a:xfrm>
-            <a:off x="1481328" y="5541264"/>
-            <a:ext cx="3346703" cy="68580"/>
-          </a:xfrm>
-          <a:prstGeom prst="roundRect">
-            <a:avLst/>
-          </a:prstGeom>
-          <a:solidFill>
-            <a:srgbClr val="EAF0ED"/>
-          </a:solidFill>
-          <a:ln w="8890">
-            <a:noFill/>
-          </a:ln>
-        </p:spPr>
-        <p:style>
-          <a:lnRef idx="1">
-            <a:schemeClr val="accent1"/>
-          </a:lnRef>
-          <a:fillRef idx="3">
-            <a:schemeClr val="accent1"/>
-          </a:fillRef>
-          <a:effectRef idx="2">
-            <a:schemeClr val="accent1"/>
-          </a:effectRef>
-          <a:fontRef idx="minor">
-            <a:schemeClr val="lt1"/>
-          </a:fontRef>
-        </p:style>
-        <p:txBody>
-          <a:bodyPr rtlCol="0" anchor="ctr"/>
-          <a:lstStyle/>
-          <a:p>
-            <a:pPr algn="ctr"/>
-          </a:p>
-        </p:txBody>
-      </p:sp>
-      <p:sp>
-        <p:nvSpPr>
-          <p:cNvPr id="87" name="Rounded Rectangle 86"/>
-          <p:cNvSpPr/>
-          <p:nvPr/>
-        </p:nvSpPr>
-        <p:spPr>
-          <a:xfrm>
-            <a:off x="1481328" y="5541264"/>
-            <a:ext cx="1968649" cy="68580"/>
-          </a:xfrm>
-          <a:prstGeom prst="roundRect">
-            <a:avLst/>
-          </a:prstGeom>
-          <a:solidFill>
-            <a:srgbClr val="1B8258"/>
-          </a:solidFill>
-          <a:ln w="8890">
-            <a:noFill/>
-          </a:ln>
-        </p:spPr>
-        <p:style>
-          <a:lnRef idx="1">
-            <a:schemeClr val="accent1"/>
-          </a:lnRef>
-          <a:fillRef idx="3">
-            <a:schemeClr val="accent1"/>
-          </a:fillRef>
-          <a:effectRef idx="2">
-            <a:schemeClr val="accent1"/>
-          </a:effectRef>
-          <a:fontRef idx="minor">
-            <a:schemeClr val="lt1"/>
-          </a:fontRef>
-        </p:style>
-        <p:txBody>
-          <a:bodyPr rtlCol="0" anchor="ctr"/>
-          <a:lstStyle/>
-          <a:p>
-            <a:pPr algn="ctr"/>
-          </a:p>
-        </p:txBody>
-      </p:sp>
-      <p:sp>
-        <p:nvSpPr>
-          <p:cNvPr id="88" name="TextBox 87"/>
-          <p:cNvSpPr txBox="1"/>
-          <p:nvPr/>
-        </p:nvSpPr>
-        <p:spPr>
-          <a:xfrm>
-            <a:off x="5084064" y="5509260"/>
-            <a:ext cx="658368" cy="128016"/>
-          </a:xfrm>
-          <a:prstGeom prst="rect">
-            <a:avLst/>
-          </a:prstGeom>
-          <a:noFill/>
-        </p:spPr>
-        <p:txBody>
-          <a:bodyPr wrap="none" lIns="0" rIns="0" tIns="0" bIns="0" anchor="ctr">
-            <a:spAutoFit/>
-          </a:bodyPr>
-          <a:lstStyle/>
-          <a:p>
-            <a:pPr algn="r">
-              <a:spcBef>
-                <a:spcPts val="0"/>
-              </a:spcBef>
-              <a:spcAft>
-                <a:spcPts val="0"/>
-              </a:spcAft>
-            </a:pPr>
-            <a:r>
-              <a:rPr sz="520" b="1">
-                <a:solidFill>
-                  <a:srgbClr val="16231D"/>
-                </a:solidFill>
-                <a:latin typeface="Segoe UI"/>
-              </a:rPr>
-              <a:t>10 · 3,1%</a:t>
-            </a:r>
-          </a:p>
-        </p:txBody>
-      </p:sp>
-      <p:sp>
-        <p:nvSpPr>
-          <p:cNvPr id="89" name="TextBox 88"/>
           <p:cNvSpPr txBox="1"/>
           <p:nvPr/>
         </p:nvSpPr>
@@ -11723,14 +11087,14 @@
                 </a:solidFill>
                 <a:latin typeface="Segoe UI"/>
               </a:rPr>
-              <a:t>CPRAIO e 12º BPM lideram, com 17 registros cada (5,2% do recorte).</a:t>
-            </a:r>
-          </a:p>
-        </p:txBody>
-      </p:sp>
-      <p:sp>
-        <p:nvSpPr>
-          <p:cNvPr id="90" name="Rounded Rectangle 89"/>
+              <a:t>O 12º BPM lidera o recorte por batalhão, com 17 registros (5,2% do total individualizado).</a:t>
+            </a:r>
+          </a:p>
+        </p:txBody>
+      </p:sp>
+      <p:sp>
+        <p:nvSpPr>
+          <p:cNvPr id="75" name="Rounded Rectangle 74"/>
           <p:cNvSpPr/>
           <p:nvPr/>
         </p:nvSpPr>
@@ -11775,7 +11139,7 @@
       </p:sp>
       <p:cxnSp>
         <p:nvCxnSpPr>
-          <p:cNvPr id="91" name="Connector 90"/>
+          <p:cNvPr id="76" name="Connector 75"/>
           <p:cNvCxnSpPr/>
           <p:nvPr/>
         </p:nvCxnSpPr>
@@ -11810,7 +11174,7 @@
       </p:cxnSp>
       <p:sp>
         <p:nvSpPr>
-          <p:cNvPr id="92" name="Rounded Rectangle 91"/>
+          <p:cNvPr id="77" name="Rounded Rectangle 76"/>
           <p:cNvSpPr/>
           <p:nvPr/>
         </p:nvSpPr>
@@ -11853,7 +11217,7 @@
       </p:sp>
       <p:sp>
         <p:nvSpPr>
-          <p:cNvPr id="93" name="TextBox 92"/>
+          <p:cNvPr id="78" name="TextBox 77"/>
           <p:cNvSpPr txBox="1"/>
           <p:nvPr/>
         </p:nvSpPr>
@@ -11895,7 +11259,7 @@
       </p:sp>
       <p:sp>
         <p:nvSpPr>
-          <p:cNvPr id="94" name="TextBox 93"/>
+          <p:cNvPr id="79" name="TextBox 78"/>
           <p:cNvSpPr txBox="1"/>
           <p:nvPr/>
         </p:nvSpPr>
@@ -11937,7 +11301,7 @@
       </p:sp>
       <p:sp>
         <p:nvSpPr>
-          <p:cNvPr id="95" name="TextBox 94"/>
+          <p:cNvPr id="80" name="TextBox 79"/>
           <p:cNvSpPr txBox="1"/>
           <p:nvPr/>
         </p:nvSpPr>
@@ -11979,7 +11343,7 @@
       </p:sp>
       <p:sp>
         <p:nvSpPr>
-          <p:cNvPr id="96" name="TextBox 95"/>
+          <p:cNvPr id="81" name="TextBox 80"/>
           <p:cNvSpPr txBox="1"/>
           <p:nvPr/>
         </p:nvSpPr>
@@ -12021,7 +11385,7 @@
       </p:sp>
       <p:sp>
         <p:nvSpPr>
-          <p:cNvPr id="97" name="TextBox 96"/>
+          <p:cNvPr id="82" name="TextBox 81"/>
           <p:cNvSpPr txBox="1"/>
           <p:nvPr/>
         </p:nvSpPr>
@@ -12063,7 +11427,7 @@
       </p:sp>
       <p:sp>
         <p:nvSpPr>
-          <p:cNvPr id="98" name="Rounded Rectangle 97"/>
+          <p:cNvPr id="83" name="Rounded Rectangle 82"/>
           <p:cNvSpPr/>
           <p:nvPr/>
         </p:nvSpPr>
@@ -12106,7 +11470,7 @@
       </p:sp>
       <p:sp>
         <p:nvSpPr>
-          <p:cNvPr id="99" name="Rounded Rectangle 98"/>
+          <p:cNvPr id="84" name="Rounded Rectangle 83"/>
           <p:cNvSpPr/>
           <p:nvPr/>
         </p:nvSpPr>
@@ -12149,7 +11513,7 @@
       </p:sp>
       <p:sp>
         <p:nvSpPr>
-          <p:cNvPr id="100" name="TextBox 99"/>
+          <p:cNvPr id="85" name="TextBox 84"/>
           <p:cNvSpPr txBox="1"/>
           <p:nvPr/>
         </p:nvSpPr>
@@ -12191,7 +11555,7 @@
       </p:sp>
       <p:sp>
         <p:nvSpPr>
-          <p:cNvPr id="101" name="TextBox 100"/>
+          <p:cNvPr id="86" name="TextBox 85"/>
           <p:cNvSpPr txBox="1"/>
           <p:nvPr/>
         </p:nvSpPr>
@@ -12233,7 +11597,7 @@
       </p:sp>
       <p:sp>
         <p:nvSpPr>
-          <p:cNvPr id="102" name="TextBox 101"/>
+          <p:cNvPr id="87" name="TextBox 86"/>
           <p:cNvSpPr txBox="1"/>
           <p:nvPr/>
         </p:nvSpPr>
@@ -12275,7 +11639,7 @@
       </p:sp>
       <p:sp>
         <p:nvSpPr>
-          <p:cNvPr id="103" name="Rounded Rectangle 102"/>
+          <p:cNvPr id="88" name="Rounded Rectangle 87"/>
           <p:cNvSpPr/>
           <p:nvPr/>
         </p:nvSpPr>
@@ -12318,7 +11682,7 @@
       </p:sp>
       <p:sp>
         <p:nvSpPr>
-          <p:cNvPr id="104" name="Rounded Rectangle 103"/>
+          <p:cNvPr id="89" name="Rounded Rectangle 88"/>
           <p:cNvSpPr/>
           <p:nvPr/>
         </p:nvSpPr>
@@ -12361,7 +11725,7 @@
       </p:sp>
       <p:sp>
         <p:nvSpPr>
-          <p:cNvPr id="105" name="TextBox 104"/>
+          <p:cNvPr id="90" name="TextBox 89"/>
           <p:cNvSpPr txBox="1"/>
           <p:nvPr/>
         </p:nvSpPr>
@@ -12403,7 +11767,7 @@
       </p:sp>
       <p:sp>
         <p:nvSpPr>
-          <p:cNvPr id="106" name="TextBox 105"/>
+          <p:cNvPr id="91" name="TextBox 90"/>
           <p:cNvSpPr txBox="1"/>
           <p:nvPr/>
         </p:nvSpPr>
@@ -12445,7 +11809,7 @@
       </p:sp>
       <p:sp>
         <p:nvSpPr>
-          <p:cNvPr id="107" name="TextBox 106"/>
+          <p:cNvPr id="92" name="TextBox 91"/>
           <p:cNvSpPr txBox="1"/>
           <p:nvPr/>
         </p:nvSpPr>
@@ -12487,7 +11851,7 @@
       </p:sp>
       <p:sp>
         <p:nvSpPr>
-          <p:cNvPr id="108" name="Rounded Rectangle 107"/>
+          <p:cNvPr id="93" name="Rounded Rectangle 92"/>
           <p:cNvSpPr/>
           <p:nvPr/>
         </p:nvSpPr>
@@ -12530,7 +11894,7 @@
       </p:sp>
       <p:sp>
         <p:nvSpPr>
-          <p:cNvPr id="109" name="Rounded Rectangle 108"/>
+          <p:cNvPr id="94" name="Rounded Rectangle 93"/>
           <p:cNvSpPr/>
           <p:nvPr/>
         </p:nvSpPr>
@@ -12573,7 +11937,7 @@
       </p:sp>
       <p:sp>
         <p:nvSpPr>
-          <p:cNvPr id="110" name="TextBox 109"/>
+          <p:cNvPr id="95" name="TextBox 94"/>
           <p:cNvSpPr txBox="1"/>
           <p:nvPr/>
         </p:nvSpPr>
@@ -12615,7 +11979,7 @@
       </p:sp>
       <p:sp>
         <p:nvSpPr>
-          <p:cNvPr id="111" name="TextBox 110"/>
+          <p:cNvPr id="96" name="TextBox 95"/>
           <p:cNvSpPr txBox="1"/>
           <p:nvPr/>
         </p:nvSpPr>
@@ -12657,7 +12021,7 @@
       </p:sp>
       <p:sp>
         <p:nvSpPr>
-          <p:cNvPr id="112" name="TextBox 111"/>
+          <p:cNvPr id="97" name="TextBox 96"/>
           <p:cNvSpPr txBox="1"/>
           <p:nvPr/>
         </p:nvSpPr>
@@ -12699,7 +12063,7 @@
       </p:sp>
       <p:sp>
         <p:nvSpPr>
-          <p:cNvPr id="113" name="Rounded Rectangle 112"/>
+          <p:cNvPr id="98" name="Rounded Rectangle 97"/>
           <p:cNvSpPr/>
           <p:nvPr/>
         </p:nvSpPr>
@@ -12742,7 +12106,7 @@
       </p:sp>
       <p:sp>
         <p:nvSpPr>
-          <p:cNvPr id="114" name="Rounded Rectangle 113"/>
+          <p:cNvPr id="99" name="Rounded Rectangle 98"/>
           <p:cNvSpPr/>
           <p:nvPr/>
         </p:nvSpPr>
@@ -12785,7 +12149,7 @@
       </p:sp>
       <p:sp>
         <p:nvSpPr>
-          <p:cNvPr id="115" name="TextBox 114"/>
+          <p:cNvPr id="100" name="TextBox 99"/>
           <p:cNvSpPr txBox="1"/>
           <p:nvPr/>
         </p:nvSpPr>
@@ -12827,7 +12191,7 @@
       </p:sp>
       <p:sp>
         <p:nvSpPr>
-          <p:cNvPr id="116" name="TextBox 115"/>
+          <p:cNvPr id="101" name="TextBox 100"/>
           <p:cNvSpPr txBox="1"/>
           <p:nvPr/>
         </p:nvSpPr>
@@ -12869,7 +12233,7 @@
       </p:sp>
       <p:sp>
         <p:nvSpPr>
-          <p:cNvPr id="117" name="TextBox 116"/>
+          <p:cNvPr id="102" name="TextBox 101"/>
           <p:cNvSpPr txBox="1"/>
           <p:nvPr/>
         </p:nvSpPr>
@@ -12911,7 +12275,7 @@
       </p:sp>
       <p:sp>
         <p:nvSpPr>
-          <p:cNvPr id="118" name="Rounded Rectangle 117"/>
+          <p:cNvPr id="103" name="Rounded Rectangle 102"/>
           <p:cNvSpPr/>
           <p:nvPr/>
         </p:nvSpPr>
@@ -12954,7 +12318,7 @@
       </p:sp>
       <p:sp>
         <p:nvSpPr>
-          <p:cNvPr id="119" name="Rounded Rectangle 118"/>
+          <p:cNvPr id="104" name="Rounded Rectangle 103"/>
           <p:cNvSpPr/>
           <p:nvPr/>
         </p:nvSpPr>
@@ -12997,7 +12361,7 @@
       </p:sp>
       <p:sp>
         <p:nvSpPr>
-          <p:cNvPr id="120" name="TextBox 119"/>
+          <p:cNvPr id="105" name="TextBox 104"/>
           <p:cNvSpPr txBox="1"/>
           <p:nvPr/>
         </p:nvSpPr>
@@ -13039,7 +12403,7 @@
       </p:sp>
       <p:sp>
         <p:nvSpPr>
-          <p:cNvPr id="121" name="TextBox 120"/>
+          <p:cNvPr id="106" name="TextBox 105"/>
           <p:cNvSpPr txBox="1"/>
           <p:nvPr/>
         </p:nvSpPr>
@@ -13081,7 +12445,7 @@
       </p:sp>
       <p:sp>
         <p:nvSpPr>
-          <p:cNvPr id="122" name="TextBox 121"/>
+          <p:cNvPr id="107" name="TextBox 106"/>
           <p:cNvSpPr txBox="1"/>
           <p:nvPr/>
         </p:nvSpPr>
@@ -13123,7 +12487,7 @@
       </p:sp>
       <p:sp>
         <p:nvSpPr>
-          <p:cNvPr id="123" name="Rounded Rectangle 122"/>
+          <p:cNvPr id="108" name="Rounded Rectangle 107"/>
           <p:cNvSpPr/>
           <p:nvPr/>
         </p:nvSpPr>
@@ -13166,7 +12530,7 @@
       </p:sp>
       <p:sp>
         <p:nvSpPr>
-          <p:cNvPr id="124" name="Rounded Rectangle 123"/>
+          <p:cNvPr id="109" name="Rounded Rectangle 108"/>
           <p:cNvSpPr/>
           <p:nvPr/>
         </p:nvSpPr>
@@ -13209,7 +12573,7 @@
       </p:sp>
       <p:sp>
         <p:nvSpPr>
-          <p:cNvPr id="125" name="TextBox 124"/>
+          <p:cNvPr id="110" name="TextBox 109"/>
           <p:cNvSpPr txBox="1"/>
           <p:nvPr/>
         </p:nvSpPr>
@@ -13251,7 +12615,7 @@
       </p:sp>
       <p:sp>
         <p:nvSpPr>
-          <p:cNvPr id="126" name="TextBox 125"/>
+          <p:cNvPr id="111" name="TextBox 110"/>
           <p:cNvSpPr txBox="1"/>
           <p:nvPr/>
         </p:nvSpPr>
@@ -13293,7 +12657,7 @@
       </p:sp>
       <p:sp>
         <p:nvSpPr>
-          <p:cNvPr id="127" name="TextBox 126"/>
+          <p:cNvPr id="112" name="TextBox 111"/>
           <p:cNvSpPr txBox="1"/>
           <p:nvPr/>
         </p:nvSpPr>
@@ -13335,7 +12699,7 @@
       </p:sp>
       <p:sp>
         <p:nvSpPr>
-          <p:cNvPr id="128" name="Rounded Rectangle 127"/>
+          <p:cNvPr id="113" name="Rounded Rectangle 112"/>
           <p:cNvSpPr/>
           <p:nvPr/>
         </p:nvSpPr>
@@ -13378,7 +12742,7 @@
       </p:sp>
       <p:sp>
         <p:nvSpPr>
-          <p:cNvPr id="129" name="Rounded Rectangle 128"/>
+          <p:cNvPr id="114" name="Rounded Rectangle 113"/>
           <p:cNvSpPr/>
           <p:nvPr/>
         </p:nvSpPr>
@@ -13421,7 +12785,7 @@
       </p:sp>
       <p:sp>
         <p:nvSpPr>
-          <p:cNvPr id="130" name="TextBox 129"/>
+          <p:cNvPr id="115" name="TextBox 114"/>
           <p:cNvSpPr txBox="1"/>
           <p:nvPr/>
         </p:nvSpPr>
@@ -13463,7 +12827,7 @@
       </p:sp>
       <p:sp>
         <p:nvSpPr>
-          <p:cNvPr id="131" name="TextBox 130"/>
+          <p:cNvPr id="116" name="TextBox 115"/>
           <p:cNvSpPr txBox="1"/>
           <p:nvPr/>
         </p:nvSpPr>
@@ -13505,7 +12869,7 @@
       </p:sp>
       <p:sp>
         <p:nvSpPr>
-          <p:cNvPr id="132" name="TextBox 131"/>
+          <p:cNvPr id="117" name="TextBox 116"/>
           <p:cNvSpPr txBox="1"/>
           <p:nvPr/>
         </p:nvSpPr>
@@ -13547,7 +12911,7 @@
       </p:sp>
       <p:sp>
         <p:nvSpPr>
-          <p:cNvPr id="133" name="Rounded Rectangle 132"/>
+          <p:cNvPr id="118" name="Rounded Rectangle 117"/>
           <p:cNvSpPr/>
           <p:nvPr/>
         </p:nvSpPr>
@@ -13590,7 +12954,7 @@
       </p:sp>
       <p:sp>
         <p:nvSpPr>
-          <p:cNvPr id="134" name="Rounded Rectangle 133"/>
+          <p:cNvPr id="119" name="Rounded Rectangle 118"/>
           <p:cNvSpPr/>
           <p:nvPr/>
         </p:nvSpPr>
@@ -13633,7 +12997,7 @@
       </p:sp>
       <p:sp>
         <p:nvSpPr>
-          <p:cNvPr id="135" name="TextBox 134"/>
+          <p:cNvPr id="120" name="TextBox 119"/>
           <p:cNvSpPr txBox="1"/>
           <p:nvPr/>
         </p:nvSpPr>
@@ -13675,7 +13039,7 @@
       </p:sp>
       <p:sp>
         <p:nvSpPr>
-          <p:cNvPr id="136" name="TextBox 135"/>
+          <p:cNvPr id="121" name="TextBox 120"/>
           <p:cNvSpPr txBox="1"/>
           <p:nvPr/>
         </p:nvSpPr>
@@ -13717,7 +13081,7 @@
       </p:sp>
       <p:sp>
         <p:nvSpPr>
-          <p:cNvPr id="137" name="Rounded Rectangle 136"/>
+          <p:cNvPr id="122" name="Rounded Rectangle 121"/>
           <p:cNvSpPr/>
           <p:nvPr/>
         </p:nvSpPr>
@@ -13762,7 +13126,7 @@
       </p:sp>
       <p:sp>
         <p:nvSpPr>
-          <p:cNvPr id="138" name="TextBox 137"/>
+          <p:cNvPr id="123" name="TextBox 122"/>
           <p:cNvSpPr txBox="1"/>
           <p:nvPr/>
         </p:nvSpPr>
@@ -13804,7 +13168,7 @@
       </p:sp>
       <p:sp>
         <p:nvSpPr>
-          <p:cNvPr id="139" name="TextBox 138"/>
+          <p:cNvPr id="124" name="TextBox 123"/>
           <p:cNvSpPr txBox="1"/>
           <p:nvPr/>
         </p:nvSpPr>
@@ -13846,7 +13210,7 @@
       </p:sp>
       <p:sp>
         <p:nvSpPr>
-          <p:cNvPr id="140" name="TextBox 139"/>
+          <p:cNvPr id="125" name="TextBox 124"/>
           <p:cNvSpPr txBox="1"/>
           <p:nvPr/>
         </p:nvSpPr>

</xml_diff>

<commit_message>
Remove mostrador de necessidades de efetivo
</commit_message>
<xml_diff>
--- a/exportacoes/Painel_Gestao_Pessoal_PMCE_EDITAVEL.pptx
+++ b/exportacoes/Painel_Gestao_Pessoal_PMCE_EDITAVEL.pptx
@@ -5882,7 +5882,7 @@
         <p:spPr>
           <a:xfrm>
             <a:off x="228600" y="2487168"/>
-            <a:ext cx="6153912" cy="4105656"/>
+            <a:ext cx="7543800" cy="4105656"/>
           </a:xfrm>
           <a:prstGeom prst="roundRect">
             <a:avLst/>
@@ -5927,7 +5927,7 @@
         <p:spPr>
           <a:xfrm>
             <a:off x="228600" y="2926080"/>
-            <a:ext cx="6153912" cy="0"/>
+            <a:ext cx="7543800" cy="0"/>
           </a:xfrm>
           <a:prstGeom prst="line">
             <a:avLst/>
@@ -6047,7 +6047,7 @@
         <p:spPr>
           <a:xfrm>
             <a:off x="649224" y="2587752"/>
-            <a:ext cx="5605272" cy="173736"/>
+            <a:ext cx="6995160" cy="173736"/>
           </a:xfrm>
           <a:prstGeom prst="rect">
             <a:avLst/>
@@ -6089,7 +6089,7 @@
         <p:spPr>
           <a:xfrm>
             <a:off x="649224" y="2761488"/>
-            <a:ext cx="5605272" cy="100584"/>
+            <a:ext cx="6995160" cy="100584"/>
           </a:xfrm>
           <a:prstGeom prst="rect">
             <a:avLst/>
@@ -6132,7 +6132,7 @@
         </p:nvGraphicFramePr>
         <p:xfrm>
           <a:off x="420624" y="3026664"/>
-          <a:ext cx="5715000" cy="3127248"/>
+          <a:ext cx="7095744" cy="3127248"/>
         </p:xfrm>
         <a:graphic>
           <a:graphicData uri="http://schemas.openxmlformats.org/drawingml/2006/chart">
@@ -6149,7 +6149,7 @@
         <p:spPr>
           <a:xfrm>
             <a:off x="420624" y="6300216"/>
-            <a:ext cx="5486400" cy="109728"/>
+            <a:ext cx="6949440" cy="109728"/>
           </a:xfrm>
           <a:prstGeom prst="rect">
             <a:avLst/>
@@ -6190,8 +6190,8 @@
         </p:nvSpPr>
         <p:spPr>
           <a:xfrm>
-            <a:off x="6492240" y="2487168"/>
-            <a:ext cx="2788920" cy="4105656"/>
+            <a:off x="7882127" y="2487168"/>
+            <a:ext cx="4078224" cy="4105656"/>
           </a:xfrm>
           <a:prstGeom prst="roundRect">
             <a:avLst/>
@@ -6235,8 +6235,8 @@
         </p:nvCxnSpPr>
         <p:spPr>
           <a:xfrm>
-            <a:off x="6492240" y="2926080"/>
-            <a:ext cx="2788919" cy="0"/>
+            <a:off x="7882127" y="2926080"/>
+            <a:ext cx="4078224" cy="0"/>
           </a:xfrm>
           <a:prstGeom prst="line">
             <a:avLst/>
@@ -6270,7 +6270,7 @@
         </p:nvSpPr>
         <p:spPr>
           <a:xfrm>
-            <a:off x="6601968" y="2606040"/>
+            <a:off x="7991855" y="2606040"/>
             <a:ext cx="246888" cy="228600"/>
           </a:xfrm>
           <a:prstGeom prst="roundRect">
@@ -6313,7 +6313,7 @@
         </p:nvSpPr>
         <p:spPr>
           <a:xfrm>
-            <a:off x="6601968" y="2606040"/>
+            <a:off x="7991855" y="2606040"/>
             <a:ext cx="246888" cy="228600"/>
           </a:xfrm>
           <a:prstGeom prst="rect">
@@ -6355,8 +6355,8 @@
         </p:nvSpPr>
         <p:spPr>
           <a:xfrm>
-            <a:off x="6912864" y="2587752"/>
-            <a:ext cx="2240279" cy="173736"/>
+            <a:off x="8302752" y="2587752"/>
+            <a:ext cx="3529584" cy="173736"/>
           </a:xfrm>
           <a:prstGeom prst="rect">
             <a:avLst/>
@@ -6384,7 +6384,7 @@
                 </a:solidFill>
                 <a:latin typeface="Segoe UI"/>
               </a:rPr>
-              <a:t>Necessidades de efetivo</a:t>
+              <a:t>Aposentadorias</a:t>
             </a:r>
           </a:p>
         </p:txBody>
@@ -6397,8 +6397,8 @@
         </p:nvSpPr>
         <p:spPr>
           <a:xfrm>
-            <a:off x="6912864" y="2761488"/>
-            <a:ext cx="2240279" cy="100584"/>
+            <a:off x="8302752" y="2761488"/>
+            <a:ext cx="3529584" cy="100584"/>
           </a:xfrm>
           <a:prstGeom prst="rect">
             <a:avLst/>
@@ -6426,1110 +6426,6 @@
                 </a:solidFill>
                 <a:latin typeface="Segoe UI"/>
               </a:rPr>
-              <a:t>RAIO, POG e COPAC/PReVio</a:t>
-            </a:r>
-          </a:p>
-        </p:txBody>
-      </p:sp>
-      <p:sp>
-        <p:nvSpPr>
-          <p:cNvPr id="72" name="Rounded Rectangle 71"/>
-          <p:cNvSpPr/>
-          <p:nvPr/>
-        </p:nvSpPr>
-        <p:spPr>
-          <a:xfrm>
-            <a:off x="6647688" y="3054096"/>
-            <a:ext cx="2487168" cy="594360"/>
-          </a:xfrm>
-          <a:prstGeom prst="roundRect">
-            <a:avLst/>
-          </a:prstGeom>
-          <a:solidFill>
-            <a:srgbClr val="FAFCFB"/>
-          </a:solidFill>
-          <a:ln w="8890">
-            <a:solidFill>
-              <a:srgbClr val="DFE6E2"/>
-            </a:solidFill>
-          </a:ln>
-        </p:spPr>
-        <p:style>
-          <a:lnRef idx="1">
-            <a:schemeClr val="accent1"/>
-          </a:lnRef>
-          <a:fillRef idx="3">
-            <a:schemeClr val="accent1"/>
-          </a:fillRef>
-          <a:effectRef idx="2">
-            <a:schemeClr val="accent1"/>
-          </a:effectRef>
-          <a:fontRef idx="minor">
-            <a:schemeClr val="lt1"/>
-          </a:fontRef>
-        </p:style>
-        <p:txBody>
-          <a:bodyPr rtlCol="0" anchor="ctr"/>
-          <a:lstStyle/>
-          <a:p>
-            <a:pPr algn="ctr"/>
-          </a:p>
-        </p:txBody>
-      </p:sp>
-      <p:sp>
-        <p:nvSpPr>
-          <p:cNvPr id="73" name="Rectangle 72"/>
-          <p:cNvSpPr/>
-          <p:nvPr/>
-        </p:nvSpPr>
-        <p:spPr>
-          <a:xfrm>
-            <a:off x="6647688" y="3090672"/>
-            <a:ext cx="27432" cy="521207"/>
-          </a:xfrm>
-          <a:prstGeom prst="rect">
-            <a:avLst/>
-          </a:prstGeom>
-          <a:solidFill>
-            <a:srgbClr val="3B7E9D"/>
-          </a:solidFill>
-          <a:ln w="8890">
-            <a:noFill/>
-          </a:ln>
-        </p:spPr>
-        <p:style>
-          <a:lnRef idx="1">
-            <a:schemeClr val="accent1"/>
-          </a:lnRef>
-          <a:fillRef idx="3">
-            <a:schemeClr val="accent1"/>
-          </a:fillRef>
-          <a:effectRef idx="2">
-            <a:schemeClr val="accent1"/>
-          </a:effectRef>
-          <a:fontRef idx="minor">
-            <a:schemeClr val="lt1"/>
-          </a:fontRef>
-        </p:style>
-        <p:txBody>
-          <a:bodyPr rtlCol="0" anchor="ctr"/>
-          <a:lstStyle/>
-          <a:p>
-            <a:pPr algn="ctr"/>
-          </a:p>
-        </p:txBody>
-      </p:sp>
-      <p:sp>
-        <p:nvSpPr>
-          <p:cNvPr id="74" name="TextBox 73"/>
-          <p:cNvSpPr txBox="1"/>
-          <p:nvPr/>
-        </p:nvSpPr>
-        <p:spPr>
-          <a:xfrm>
-            <a:off x="6775703" y="3145536"/>
-            <a:ext cx="2057400" cy="109728"/>
-          </a:xfrm>
-          <a:prstGeom prst="rect">
-            <a:avLst/>
-          </a:prstGeom>
-          <a:noFill/>
-        </p:spPr>
-        <p:txBody>
-          <a:bodyPr wrap="none" lIns="0" rIns="0" tIns="0" bIns="0" anchor="ctr">
-            <a:spAutoFit/>
-          </a:bodyPr>
-          <a:lstStyle/>
-          <a:p>
-            <a:pPr algn="l">
-              <a:spcBef>
-                <a:spcPts val="0"/>
-              </a:spcBef>
-              <a:spcAft>
-                <a:spcPts val="0"/>
-              </a:spcAft>
-            </a:pPr>
-            <a:r>
-              <a:rPr sz="560" b="1">
-                <a:solidFill>
-                  <a:srgbClr val="6D7973"/>
-                </a:solidFill>
-                <a:latin typeface="Segoe UI"/>
-              </a:rPr>
-              <a:t>RAIO · BASES SATÉLITES</a:t>
-            </a:r>
-          </a:p>
-        </p:txBody>
-      </p:sp>
-      <p:sp>
-        <p:nvSpPr>
-          <p:cNvPr id="75" name="TextBox 74"/>
-          <p:cNvSpPr txBox="1"/>
-          <p:nvPr/>
-        </p:nvSpPr>
-        <p:spPr>
-          <a:xfrm>
-            <a:off x="6775703" y="3282696"/>
-            <a:ext cx="640080" cy="256032"/>
-          </a:xfrm>
-          <a:prstGeom prst="rect">
-            <a:avLst/>
-          </a:prstGeom>
-          <a:noFill/>
-        </p:spPr>
-        <p:txBody>
-          <a:bodyPr wrap="none" lIns="0" rIns="0" tIns="0" bIns="0" anchor="ctr">
-            <a:spAutoFit/>
-          </a:bodyPr>
-          <a:lstStyle/>
-          <a:p>
-            <a:pPr algn="l">
-              <a:spcBef>
-                <a:spcPts val="0"/>
-              </a:spcBef>
-              <a:spcAft>
-                <a:spcPts val="0"/>
-              </a:spcAft>
-            </a:pPr>
-            <a:r>
-              <a:rPr sz="1900" b="1">
-                <a:solidFill>
-                  <a:srgbClr val="0D3C2D"/>
-                </a:solidFill>
-                <a:latin typeface="Segoe UI"/>
-              </a:rPr>
-              <a:t>912</a:t>
-            </a:r>
-          </a:p>
-        </p:txBody>
-      </p:sp>
-      <p:sp>
-        <p:nvSpPr>
-          <p:cNvPr id="76" name="TextBox 75"/>
-          <p:cNvSpPr txBox="1"/>
-          <p:nvPr/>
-        </p:nvSpPr>
-        <p:spPr>
-          <a:xfrm>
-            <a:off x="7342631" y="3364991"/>
-            <a:ext cx="502920" cy="109728"/>
-          </a:xfrm>
-          <a:prstGeom prst="rect">
-            <a:avLst/>
-          </a:prstGeom>
-          <a:noFill/>
-        </p:spPr>
-        <p:txBody>
-          <a:bodyPr wrap="none" lIns="0" rIns="0" tIns="0" bIns="0" anchor="ctr">
-            <a:spAutoFit/>
-          </a:bodyPr>
-          <a:lstStyle/>
-          <a:p>
-            <a:pPr algn="l">
-              <a:spcBef>
-                <a:spcPts val="0"/>
-              </a:spcBef>
-              <a:spcAft>
-                <a:spcPts val="0"/>
-              </a:spcAft>
-            </a:pPr>
-            <a:r>
-              <a:rPr sz="530" b="0">
-                <a:solidFill>
-                  <a:srgbClr val="6D7973"/>
-                </a:solidFill>
-                <a:latin typeface="Segoe UI"/>
-              </a:rPr>
-              <a:t>policiais</a:t>
-            </a:r>
-          </a:p>
-        </p:txBody>
-      </p:sp>
-      <p:sp>
-        <p:nvSpPr>
-          <p:cNvPr id="77" name="TextBox 76"/>
-          <p:cNvSpPr txBox="1"/>
-          <p:nvPr/>
-        </p:nvSpPr>
-        <p:spPr>
-          <a:xfrm>
-            <a:off x="6775703" y="3520439"/>
-            <a:ext cx="2194560" cy="73152"/>
-          </a:xfrm>
-          <a:prstGeom prst="rect">
-            <a:avLst/>
-          </a:prstGeom>
-          <a:noFill/>
-        </p:spPr>
-        <p:txBody>
-          <a:bodyPr wrap="none" lIns="0" rIns="0" tIns="0" bIns="0" anchor="ctr">
-            <a:spAutoFit/>
-          </a:bodyPr>
-          <a:lstStyle/>
-          <a:p>
-            <a:pPr algn="l">
-              <a:spcBef>
-                <a:spcPts val="0"/>
-              </a:spcBef>
-              <a:spcAft>
-                <a:spcPts val="0"/>
-              </a:spcAft>
-            </a:pPr>
-            <a:r>
-              <a:rPr sz="430" b="0">
-                <a:solidFill>
-                  <a:srgbClr val="6D7973"/>
-                </a:solidFill>
-                <a:latin typeface="Segoe UI"/>
-              </a:rPr>
-              <a:t>20 bases, 31 municípios satélite e 85,9% operacional.</a:t>
-            </a:r>
-          </a:p>
-        </p:txBody>
-      </p:sp>
-      <p:sp>
-        <p:nvSpPr>
-          <p:cNvPr id="78" name="Rounded Rectangle 77"/>
-          <p:cNvSpPr/>
-          <p:nvPr/>
-        </p:nvSpPr>
-        <p:spPr>
-          <a:xfrm>
-            <a:off x="6647688" y="3730752"/>
-            <a:ext cx="2487168" cy="594360"/>
-          </a:xfrm>
-          <a:prstGeom prst="roundRect">
-            <a:avLst/>
-          </a:prstGeom>
-          <a:solidFill>
-            <a:srgbClr val="FAFCFB"/>
-          </a:solidFill>
-          <a:ln w="8890">
-            <a:solidFill>
-              <a:srgbClr val="DFE6E2"/>
-            </a:solidFill>
-          </a:ln>
-        </p:spPr>
-        <p:style>
-          <a:lnRef idx="1">
-            <a:schemeClr val="accent1"/>
-          </a:lnRef>
-          <a:fillRef idx="3">
-            <a:schemeClr val="accent1"/>
-          </a:fillRef>
-          <a:effectRef idx="2">
-            <a:schemeClr val="accent1"/>
-          </a:effectRef>
-          <a:fontRef idx="minor">
-            <a:schemeClr val="lt1"/>
-          </a:fontRef>
-        </p:style>
-        <p:txBody>
-          <a:bodyPr rtlCol="0" anchor="ctr"/>
-          <a:lstStyle/>
-          <a:p>
-            <a:pPr algn="ctr"/>
-          </a:p>
-        </p:txBody>
-      </p:sp>
-      <p:sp>
-        <p:nvSpPr>
-          <p:cNvPr id="79" name="Rectangle 78"/>
-          <p:cNvSpPr/>
-          <p:nvPr/>
-        </p:nvSpPr>
-        <p:spPr>
-          <a:xfrm>
-            <a:off x="6647688" y="3767328"/>
-            <a:ext cx="27432" cy="521207"/>
-          </a:xfrm>
-          <a:prstGeom prst="rect">
-            <a:avLst/>
-          </a:prstGeom>
-          <a:solidFill>
-            <a:srgbClr val="216F4C"/>
-          </a:solidFill>
-          <a:ln w="8890">
-            <a:noFill/>
-          </a:ln>
-        </p:spPr>
-        <p:style>
-          <a:lnRef idx="1">
-            <a:schemeClr val="accent1"/>
-          </a:lnRef>
-          <a:fillRef idx="3">
-            <a:schemeClr val="accent1"/>
-          </a:fillRef>
-          <a:effectRef idx="2">
-            <a:schemeClr val="accent1"/>
-          </a:effectRef>
-          <a:fontRef idx="minor">
-            <a:schemeClr val="lt1"/>
-          </a:fontRef>
-        </p:style>
-        <p:txBody>
-          <a:bodyPr rtlCol="0" anchor="ctr"/>
-          <a:lstStyle/>
-          <a:p>
-            <a:pPr algn="ctr"/>
-          </a:p>
-        </p:txBody>
-      </p:sp>
-      <p:sp>
-        <p:nvSpPr>
-          <p:cNvPr id="80" name="TextBox 79"/>
-          <p:cNvSpPr txBox="1"/>
-          <p:nvPr/>
-        </p:nvSpPr>
-        <p:spPr>
-          <a:xfrm>
-            <a:off x="6775703" y="3822191"/>
-            <a:ext cx="2057400" cy="109728"/>
-          </a:xfrm>
-          <a:prstGeom prst="rect">
-            <a:avLst/>
-          </a:prstGeom>
-          <a:noFill/>
-        </p:spPr>
-        <p:txBody>
-          <a:bodyPr wrap="none" lIns="0" rIns="0" tIns="0" bIns="0" anchor="ctr">
-            <a:spAutoFit/>
-          </a:bodyPr>
-          <a:lstStyle/>
-          <a:p>
-            <a:pPr algn="l">
-              <a:spcBef>
-                <a:spcPts val="0"/>
-              </a:spcBef>
-              <a:spcAft>
-                <a:spcPts val="0"/>
-              </a:spcAft>
-            </a:pPr>
-            <a:r>
-              <a:rPr sz="560" b="1">
-                <a:solidFill>
-                  <a:srgbClr val="6D7973"/>
-                </a:solidFill>
-                <a:latin typeface="Segoe UI"/>
-              </a:rPr>
-              <a:t>POG · POLICIAMENTO ORDINÁRIO</a:t>
-            </a:r>
-          </a:p>
-        </p:txBody>
-      </p:sp>
-      <p:sp>
-        <p:nvSpPr>
-          <p:cNvPr id="81" name="TextBox 80"/>
-          <p:cNvSpPr txBox="1"/>
-          <p:nvPr/>
-        </p:nvSpPr>
-        <p:spPr>
-          <a:xfrm>
-            <a:off x="6775703" y="3959352"/>
-            <a:ext cx="640080" cy="256032"/>
-          </a:xfrm>
-          <a:prstGeom prst="rect">
-            <a:avLst/>
-          </a:prstGeom>
-          <a:noFill/>
-        </p:spPr>
-        <p:txBody>
-          <a:bodyPr wrap="none" lIns="0" rIns="0" tIns="0" bIns="0" anchor="ctr">
-            <a:spAutoFit/>
-          </a:bodyPr>
-          <a:lstStyle/>
-          <a:p>
-            <a:pPr algn="l">
-              <a:spcBef>
-                <a:spcPts val="0"/>
-              </a:spcBef>
-              <a:spcAft>
-                <a:spcPts val="0"/>
-              </a:spcAft>
-            </a:pPr>
-            <a:r>
-              <a:rPr sz="1900" b="1">
-                <a:solidFill>
-                  <a:srgbClr val="0D3C2D"/>
-                </a:solidFill>
-                <a:latin typeface="Segoe UI"/>
-              </a:rPr>
-              <a:t>111</a:t>
-            </a:r>
-          </a:p>
-        </p:txBody>
-      </p:sp>
-      <p:sp>
-        <p:nvSpPr>
-          <p:cNvPr id="82" name="TextBox 81"/>
-          <p:cNvSpPr txBox="1"/>
-          <p:nvPr/>
-        </p:nvSpPr>
-        <p:spPr>
-          <a:xfrm>
-            <a:off x="7342631" y="4041648"/>
-            <a:ext cx="502920" cy="109728"/>
-          </a:xfrm>
-          <a:prstGeom prst="rect">
-            <a:avLst/>
-          </a:prstGeom>
-          <a:noFill/>
-        </p:spPr>
-        <p:txBody>
-          <a:bodyPr wrap="none" lIns="0" rIns="0" tIns="0" bIns="0" anchor="ctr">
-            <a:spAutoFit/>
-          </a:bodyPr>
-          <a:lstStyle/>
-          <a:p>
-            <a:pPr algn="l">
-              <a:spcBef>
-                <a:spcPts val="0"/>
-              </a:spcBef>
-              <a:spcAft>
-                <a:spcPts val="0"/>
-              </a:spcAft>
-            </a:pPr>
-            <a:r>
-              <a:rPr sz="530" b="0">
-                <a:solidFill>
-                  <a:srgbClr val="6D7973"/>
-                </a:solidFill>
-                <a:latin typeface="Segoe UI"/>
-              </a:rPr>
-              <a:t>policiais</a:t>
-            </a:r>
-          </a:p>
-        </p:txBody>
-      </p:sp>
-      <p:sp>
-        <p:nvSpPr>
-          <p:cNvPr id="83" name="TextBox 82"/>
-          <p:cNvSpPr txBox="1"/>
-          <p:nvPr/>
-        </p:nvSpPr>
-        <p:spPr>
-          <a:xfrm>
-            <a:off x="6775703" y="4197096"/>
-            <a:ext cx="2194560" cy="73152"/>
-          </a:xfrm>
-          <a:prstGeom prst="rect">
-            <a:avLst/>
-          </a:prstGeom>
-          <a:noFill/>
-        </p:spPr>
-        <p:txBody>
-          <a:bodyPr wrap="none" lIns="0" rIns="0" tIns="0" bIns="0" anchor="ctr">
-            <a:spAutoFit/>
-          </a:bodyPr>
-          <a:lstStyle/>
-          <a:p>
-            <a:pPr algn="l">
-              <a:spcBef>
-                <a:spcPts val="0"/>
-              </a:spcBef>
-              <a:spcAft>
-                <a:spcPts val="0"/>
-              </a:spcAft>
-            </a:pPr>
-            <a:r>
-              <a:rPr sz="430" b="0">
-                <a:solidFill>
-                  <a:srgbClr val="6D7973"/>
-                </a:solidFill>
-                <a:latin typeface="Segoe UI"/>
-              </a:rPr>
-              <a:t>Déficit calculado nos 34 BPMs territoriais.</a:t>
-            </a:r>
-          </a:p>
-        </p:txBody>
-      </p:sp>
-      <p:sp>
-        <p:nvSpPr>
-          <p:cNvPr id="84" name="Rounded Rectangle 83"/>
-          <p:cNvSpPr/>
-          <p:nvPr/>
-        </p:nvSpPr>
-        <p:spPr>
-          <a:xfrm>
-            <a:off x="6647688" y="4407408"/>
-            <a:ext cx="2487168" cy="594360"/>
-          </a:xfrm>
-          <a:prstGeom prst="roundRect">
-            <a:avLst/>
-          </a:prstGeom>
-          <a:solidFill>
-            <a:srgbClr val="FAFCFB"/>
-          </a:solidFill>
-          <a:ln w="8890">
-            <a:solidFill>
-              <a:srgbClr val="DFE6E2"/>
-            </a:solidFill>
-          </a:ln>
-        </p:spPr>
-        <p:style>
-          <a:lnRef idx="1">
-            <a:schemeClr val="accent1"/>
-          </a:lnRef>
-          <a:fillRef idx="3">
-            <a:schemeClr val="accent1"/>
-          </a:fillRef>
-          <a:effectRef idx="2">
-            <a:schemeClr val="accent1"/>
-          </a:effectRef>
-          <a:fontRef idx="minor">
-            <a:schemeClr val="lt1"/>
-          </a:fontRef>
-        </p:style>
-        <p:txBody>
-          <a:bodyPr rtlCol="0" anchor="ctr"/>
-          <a:lstStyle/>
-          <a:p>
-            <a:pPr algn="ctr"/>
-          </a:p>
-        </p:txBody>
-      </p:sp>
-      <p:sp>
-        <p:nvSpPr>
-          <p:cNvPr id="85" name="Rectangle 84"/>
-          <p:cNvSpPr/>
-          <p:nvPr/>
-        </p:nvSpPr>
-        <p:spPr>
-          <a:xfrm>
-            <a:off x="6647688" y="4443984"/>
-            <a:ext cx="27432" cy="521207"/>
-          </a:xfrm>
-          <a:prstGeom prst="rect">
-            <a:avLst/>
-          </a:prstGeom>
-          <a:solidFill>
-            <a:srgbClr val="2B8982"/>
-          </a:solidFill>
-          <a:ln w="8890">
-            <a:noFill/>
-          </a:ln>
-        </p:spPr>
-        <p:style>
-          <a:lnRef idx="1">
-            <a:schemeClr val="accent1"/>
-          </a:lnRef>
-          <a:fillRef idx="3">
-            <a:schemeClr val="accent1"/>
-          </a:fillRef>
-          <a:effectRef idx="2">
-            <a:schemeClr val="accent1"/>
-          </a:effectRef>
-          <a:fontRef idx="minor">
-            <a:schemeClr val="lt1"/>
-          </a:fontRef>
-        </p:style>
-        <p:txBody>
-          <a:bodyPr rtlCol="0" anchor="ctr"/>
-          <a:lstStyle/>
-          <a:p>
-            <a:pPr algn="ctr"/>
-          </a:p>
-        </p:txBody>
-      </p:sp>
-      <p:sp>
-        <p:nvSpPr>
-          <p:cNvPr id="86" name="TextBox 85"/>
-          <p:cNvSpPr txBox="1"/>
-          <p:nvPr/>
-        </p:nvSpPr>
-        <p:spPr>
-          <a:xfrm>
-            <a:off x="6775703" y="4498848"/>
-            <a:ext cx="2057400" cy="109728"/>
-          </a:xfrm>
-          <a:prstGeom prst="rect">
-            <a:avLst/>
-          </a:prstGeom>
-          <a:noFill/>
-        </p:spPr>
-        <p:txBody>
-          <a:bodyPr wrap="none" lIns="0" rIns="0" tIns="0" bIns="0" anchor="ctr">
-            <a:spAutoFit/>
-          </a:bodyPr>
-          <a:lstStyle/>
-          <a:p>
-            <a:pPr algn="l">
-              <a:spcBef>
-                <a:spcPts val="0"/>
-              </a:spcBef>
-              <a:spcAft>
-                <a:spcPts val="0"/>
-              </a:spcAft>
-            </a:pPr>
-            <a:r>
-              <a:rPr sz="560" b="1">
-                <a:solidFill>
-                  <a:srgbClr val="6D7973"/>
-                </a:solidFill>
-                <a:latin typeface="Segoe UI"/>
-              </a:rPr>
-              <a:t>COPAC · NECESSIDADE PREVIO</a:t>
-            </a:r>
-          </a:p>
-        </p:txBody>
-      </p:sp>
-      <p:sp>
-        <p:nvSpPr>
-          <p:cNvPr id="87" name="TextBox 86"/>
-          <p:cNvSpPr txBox="1"/>
-          <p:nvPr/>
-        </p:nvSpPr>
-        <p:spPr>
-          <a:xfrm>
-            <a:off x="6775703" y="4636008"/>
-            <a:ext cx="640080" cy="256032"/>
-          </a:xfrm>
-          <a:prstGeom prst="rect">
-            <a:avLst/>
-          </a:prstGeom>
-          <a:noFill/>
-        </p:spPr>
-        <p:txBody>
-          <a:bodyPr wrap="none" lIns="0" rIns="0" tIns="0" bIns="0" anchor="ctr">
-            <a:spAutoFit/>
-          </a:bodyPr>
-          <a:lstStyle/>
-          <a:p>
-            <a:pPr algn="l">
-              <a:spcBef>
-                <a:spcPts val="0"/>
-              </a:spcBef>
-              <a:spcAft>
-                <a:spcPts val="0"/>
-              </a:spcAft>
-            </a:pPr>
-            <a:r>
-              <a:rPr sz="1900" b="1">
-                <a:solidFill>
-                  <a:srgbClr val="0D3C2D"/>
-                </a:solidFill>
-                <a:latin typeface="Segoe UI"/>
-              </a:rPr>
-              <a:t>229</a:t>
-            </a:r>
-          </a:p>
-        </p:txBody>
-      </p:sp>
-      <p:sp>
-        <p:nvSpPr>
-          <p:cNvPr id="88" name="TextBox 87"/>
-          <p:cNvSpPr txBox="1"/>
-          <p:nvPr/>
-        </p:nvSpPr>
-        <p:spPr>
-          <a:xfrm>
-            <a:off x="7342631" y="4718304"/>
-            <a:ext cx="502920" cy="109728"/>
-          </a:xfrm>
-          <a:prstGeom prst="rect">
-            <a:avLst/>
-          </a:prstGeom>
-          <a:noFill/>
-        </p:spPr>
-        <p:txBody>
-          <a:bodyPr wrap="none" lIns="0" rIns="0" tIns="0" bIns="0" anchor="ctr">
-            <a:spAutoFit/>
-          </a:bodyPr>
-          <a:lstStyle/>
-          <a:p>
-            <a:pPr algn="l">
-              <a:spcBef>
-                <a:spcPts val="0"/>
-              </a:spcBef>
-              <a:spcAft>
-                <a:spcPts val="0"/>
-              </a:spcAft>
-            </a:pPr>
-            <a:r>
-              <a:rPr sz="530" b="0">
-                <a:solidFill>
-                  <a:srgbClr val="6D7973"/>
-                </a:solidFill>
-                <a:latin typeface="Segoe UI"/>
-              </a:rPr>
-              <a:t>policiais</a:t>
-            </a:r>
-          </a:p>
-        </p:txBody>
-      </p:sp>
-      <p:sp>
-        <p:nvSpPr>
-          <p:cNvPr id="89" name="TextBox 88"/>
-          <p:cNvSpPr txBox="1"/>
-          <p:nvPr/>
-        </p:nvSpPr>
-        <p:spPr>
-          <a:xfrm>
-            <a:off x="6775703" y="4873752"/>
-            <a:ext cx="2194560" cy="73152"/>
-          </a:xfrm>
-          <a:prstGeom prst="rect">
-            <a:avLst/>
-          </a:prstGeom>
-          <a:noFill/>
-        </p:spPr>
-        <p:txBody>
-          <a:bodyPr wrap="none" lIns="0" rIns="0" tIns="0" bIns="0" anchor="ctr">
-            <a:spAutoFit/>
-          </a:bodyPr>
-          <a:lstStyle/>
-          <a:p>
-            <a:pPr algn="l">
-              <a:spcBef>
-                <a:spcPts val="0"/>
-              </a:spcBef>
-              <a:spcAft>
-                <a:spcPts val="0"/>
-              </a:spcAft>
-            </a:pPr>
-            <a:r>
-              <a:rPr sz="430" b="0">
-                <a:solidFill>
-                  <a:srgbClr val="6D7973"/>
-                </a:solidFill>
-                <a:latin typeface="Segoe UI"/>
-              </a:rPr>
-              <a:t>10 bases; 04 prioritárias em 2026.</a:t>
-            </a:r>
-          </a:p>
-        </p:txBody>
-      </p:sp>
-      <p:sp>
-        <p:nvSpPr>
-          <p:cNvPr id="90" name="Rounded Rectangle 89"/>
-          <p:cNvSpPr/>
-          <p:nvPr/>
-        </p:nvSpPr>
-        <p:spPr>
-          <a:xfrm>
-            <a:off x="6647688" y="6144768"/>
-            <a:ext cx="2487168" cy="274320"/>
-          </a:xfrm>
-          <a:prstGeom prst="roundRect">
-            <a:avLst/>
-          </a:prstGeom>
-          <a:solidFill>
-            <a:srgbClr val="FBF8EF"/>
-          </a:solidFill>
-          <a:ln w="8890">
-            <a:solidFill>
-              <a:srgbClr val="EEE4C9"/>
-            </a:solidFill>
-          </a:ln>
-        </p:spPr>
-        <p:style>
-          <a:lnRef idx="1">
-            <a:schemeClr val="accent1"/>
-          </a:lnRef>
-          <a:fillRef idx="3">
-            <a:schemeClr val="accent1"/>
-          </a:fillRef>
-          <a:effectRef idx="2">
-            <a:schemeClr val="accent1"/>
-          </a:effectRef>
-          <a:fontRef idx="minor">
-            <a:schemeClr val="lt1"/>
-          </a:fontRef>
-        </p:style>
-        <p:txBody>
-          <a:bodyPr rtlCol="0" anchor="ctr"/>
-          <a:lstStyle/>
-          <a:p>
-            <a:pPr algn="ctr"/>
-          </a:p>
-        </p:txBody>
-      </p:sp>
-      <p:sp>
-        <p:nvSpPr>
-          <p:cNvPr id="91" name="TextBox 90"/>
-          <p:cNvSpPr txBox="1"/>
-          <p:nvPr/>
-        </p:nvSpPr>
-        <p:spPr>
-          <a:xfrm>
-            <a:off x="6729984" y="6172200"/>
-            <a:ext cx="2331720" cy="201168"/>
-          </a:xfrm>
-          <a:prstGeom prst="rect">
-            <a:avLst/>
-          </a:prstGeom>
-          <a:noFill/>
-        </p:spPr>
-        <p:txBody>
-          <a:bodyPr wrap="none" lIns="0" rIns="0" tIns="0" bIns="0" anchor="ctr">
-            <a:spAutoFit/>
-          </a:bodyPr>
-          <a:lstStyle/>
-          <a:p>
-            <a:pPr algn="l">
-              <a:spcBef>
-                <a:spcPts val="0"/>
-              </a:spcBef>
-              <a:spcAft>
-                <a:spcPts val="0"/>
-              </a:spcAft>
-            </a:pPr>
-            <a:r>
-              <a:rPr sz="430" b="0">
-                <a:solidFill>
-                  <a:srgbClr val="216F4C"/>
-                </a:solidFill>
-                <a:latin typeface="Segoe UI"/>
-              </a:rPr>
-              <a:t>●  POG — Policiamento Ordinário: 111 soma as perdas dos 12 BPMs com saldo negativo.</a:t>
-            </a:r>
-          </a:p>
-        </p:txBody>
-      </p:sp>
-      <p:sp>
-        <p:nvSpPr>
-          <p:cNvPr id="92" name="Rounded Rectangle 91"/>
-          <p:cNvSpPr/>
-          <p:nvPr/>
-        </p:nvSpPr>
-        <p:spPr>
-          <a:xfrm>
-            <a:off x="9390888" y="2487168"/>
-            <a:ext cx="2569464" cy="4105656"/>
-          </a:xfrm>
-          <a:prstGeom prst="roundRect">
-            <a:avLst/>
-          </a:prstGeom>
-          <a:solidFill>
-            <a:srgbClr val="FFFFFF"/>
-          </a:solidFill>
-          <a:ln w="8890">
-            <a:solidFill>
-              <a:srgbClr val="DFE6E2"/>
-            </a:solidFill>
-          </a:ln>
-        </p:spPr>
-        <p:style>
-          <a:lnRef idx="1">
-            <a:schemeClr val="accent1"/>
-          </a:lnRef>
-          <a:fillRef idx="3">
-            <a:schemeClr val="accent1"/>
-          </a:fillRef>
-          <a:effectRef idx="2">
-            <a:schemeClr val="accent1"/>
-          </a:effectRef>
-          <a:fontRef idx="minor">
-            <a:schemeClr val="lt1"/>
-          </a:fontRef>
-        </p:style>
-        <p:txBody>
-          <a:bodyPr rtlCol="0" anchor="ctr"/>
-          <a:lstStyle/>
-          <a:p>
-            <a:pPr algn="ctr"/>
-          </a:p>
-        </p:txBody>
-      </p:sp>
-      <p:cxnSp>
-        <p:nvCxnSpPr>
-          <p:cNvPr id="93" name="Connector 92"/>
-          <p:cNvCxnSpPr/>
-          <p:nvPr/>
-        </p:nvCxnSpPr>
-        <p:spPr>
-          <a:xfrm>
-            <a:off x="9390888" y="2926080"/>
-            <a:ext cx="2569464" cy="0"/>
-          </a:xfrm>
-          <a:prstGeom prst="line">
-            <a:avLst/>
-          </a:prstGeom>
-          <a:ln w="7620">
-            <a:solidFill>
-              <a:srgbClr val="E9EEEB"/>
-            </a:solidFill>
-          </a:ln>
-        </p:spPr>
-        <p:style>
-          <a:lnRef idx="2">
-            <a:schemeClr val="accent1"/>
-          </a:lnRef>
-          <a:fillRef idx="0">
-            <a:schemeClr val="accent1"/>
-          </a:fillRef>
-          <a:effectRef idx="1">
-            <a:schemeClr val="accent1"/>
-          </a:effectRef>
-          <a:fontRef idx="minor">
-            <a:schemeClr val="tx1"/>
-          </a:fontRef>
-        </p:style>
-      </p:cxnSp>
-      <p:sp>
-        <p:nvSpPr>
-          <p:cNvPr id="94" name="Rounded Rectangle 93"/>
-          <p:cNvSpPr/>
-          <p:nvPr/>
-        </p:nvSpPr>
-        <p:spPr>
-          <a:xfrm>
-            <a:off x="9500615" y="2606040"/>
-            <a:ext cx="246888" cy="228600"/>
-          </a:xfrm>
-          <a:prstGeom prst="roundRect">
-            <a:avLst/>
-          </a:prstGeom>
-          <a:solidFill>
-            <a:srgbClr val="EFF8F3"/>
-          </a:solidFill>
-          <a:ln w="8890">
-            <a:noFill/>
-          </a:ln>
-        </p:spPr>
-        <p:style>
-          <a:lnRef idx="1">
-            <a:schemeClr val="accent1"/>
-          </a:lnRef>
-          <a:fillRef idx="3">
-            <a:schemeClr val="accent1"/>
-          </a:fillRef>
-          <a:effectRef idx="2">
-            <a:schemeClr val="accent1"/>
-          </a:effectRef>
-          <a:fontRef idx="minor">
-            <a:schemeClr val="lt1"/>
-          </a:fontRef>
-        </p:style>
-        <p:txBody>
-          <a:bodyPr rtlCol="0" anchor="ctr"/>
-          <a:lstStyle/>
-          <a:p>
-            <a:pPr algn="ctr"/>
-          </a:p>
-        </p:txBody>
-      </p:sp>
-      <p:sp>
-        <p:nvSpPr>
-          <p:cNvPr id="95" name="TextBox 94"/>
-          <p:cNvSpPr txBox="1"/>
-          <p:nvPr/>
-        </p:nvSpPr>
-        <p:spPr>
-          <a:xfrm>
-            <a:off x="9500615" y="2606040"/>
-            <a:ext cx="246888" cy="228600"/>
-          </a:xfrm>
-          <a:prstGeom prst="rect">
-            <a:avLst/>
-          </a:prstGeom>
-          <a:noFill/>
-        </p:spPr>
-        <p:txBody>
-          <a:bodyPr wrap="none" lIns="0" rIns="0" tIns="0" bIns="0" anchor="ctr">
-            <a:spAutoFit/>
-          </a:bodyPr>
-          <a:lstStyle/>
-          <a:p>
-            <a:pPr algn="ctr">
-              <a:spcBef>
-                <a:spcPts val="0"/>
-              </a:spcBef>
-              <a:spcAft>
-                <a:spcPts val="0"/>
-              </a:spcAft>
-            </a:pPr>
-            <a:r>
-              <a:rPr sz="660" b="1">
-                <a:solidFill>
-                  <a:srgbClr val="13523B"/>
-                </a:solidFill>
-                <a:latin typeface="Segoe UI"/>
-              </a:rPr>
-              <a:t>03</a:t>
-            </a:r>
-          </a:p>
-        </p:txBody>
-      </p:sp>
-      <p:sp>
-        <p:nvSpPr>
-          <p:cNvPr id="96" name="TextBox 95"/>
-          <p:cNvSpPr txBox="1"/>
-          <p:nvPr/>
-        </p:nvSpPr>
-        <p:spPr>
-          <a:xfrm>
-            <a:off x="9811512" y="2587752"/>
-            <a:ext cx="2020824" cy="173736"/>
-          </a:xfrm>
-          <a:prstGeom prst="rect">
-            <a:avLst/>
-          </a:prstGeom>
-          <a:noFill/>
-        </p:spPr>
-        <p:txBody>
-          <a:bodyPr wrap="none" lIns="0" rIns="0" tIns="0" bIns="0" anchor="ctr">
-            <a:spAutoFit/>
-          </a:bodyPr>
-          <a:lstStyle/>
-          <a:p>
-            <a:pPr algn="l">
-              <a:spcBef>
-                <a:spcPts val="0"/>
-              </a:spcBef>
-              <a:spcAft>
-                <a:spcPts val="0"/>
-              </a:spcAft>
-            </a:pPr>
-            <a:r>
-              <a:rPr sz="950" b="1">
-                <a:solidFill>
-                  <a:srgbClr val="16231D"/>
-                </a:solidFill>
-                <a:latin typeface="Segoe UI"/>
-              </a:rPr>
-              <a:t>Aposentadorias</a:t>
-            </a:r>
-          </a:p>
-        </p:txBody>
-      </p:sp>
-      <p:sp>
-        <p:nvSpPr>
-          <p:cNvPr id="97" name="TextBox 96"/>
-          <p:cNvSpPr txBox="1"/>
-          <p:nvPr/>
-        </p:nvSpPr>
-        <p:spPr>
-          <a:xfrm>
-            <a:off x="9811512" y="2761488"/>
-            <a:ext cx="2020824" cy="100584"/>
-          </a:xfrm>
-          <a:prstGeom prst="rect">
-            <a:avLst/>
-          </a:prstGeom>
-          <a:noFill/>
-        </p:spPr>
-        <p:txBody>
-          <a:bodyPr wrap="none" lIns="0" rIns="0" tIns="0" bIns="0" anchor="ctr">
-            <a:spAutoFit/>
-          </a:bodyPr>
-          <a:lstStyle/>
-          <a:p>
-            <a:pPr algn="l">
-              <a:spcBef>
-                <a:spcPts val="0"/>
-              </a:spcBef>
-              <a:spcAft>
-                <a:spcPts val="0"/>
-              </a:spcAft>
-            </a:pPr>
-            <a:r>
-              <a:rPr sz="580" b="0">
-                <a:solidFill>
-                  <a:srgbClr val="6D7973"/>
-                </a:solidFill>
-                <a:latin typeface="Segoe UI"/>
-              </a:rPr>
               <a:t>Impacto nas promoções requeridas</a:t>
             </a:r>
           </a:p>
@@ -7537,15 +6433,15 @@
       </p:sp>
       <p:graphicFrame>
         <p:nvGraphicFramePr>
-          <p:cNvPr id="98" name="Chart 97"/>
+          <p:cNvPr id="72" name="Chart 71"/>
           <p:cNvGraphicFramePr>
             <a:graphicFrameLocks noGrp="1"/>
           </p:cNvGraphicFramePr>
           <p:nvPr/>
         </p:nvGraphicFramePr>
         <p:xfrm>
-          <a:off x="9738360" y="3337560"/>
-          <a:ext cx="1874519" cy="1920240"/>
+          <a:off x="8613648" y="3154680"/>
+          <a:ext cx="2606040" cy="2286000"/>
         </p:xfrm>
         <a:graphic>
           <a:graphicData uri="http://schemas.openxmlformats.org/drawingml/2006/chart">
@@ -7555,13 +6451,13 @@
       </p:graphicFrame>
       <p:sp>
         <p:nvSpPr>
-          <p:cNvPr id="99" name="TextBox 98"/>
+          <p:cNvPr id="73" name="TextBox 72"/>
           <p:cNvSpPr txBox="1"/>
           <p:nvPr/>
         </p:nvSpPr>
         <p:spPr>
           <a:xfrm>
-            <a:off x="10259568" y="3922776"/>
+            <a:off x="9491472" y="3904487"/>
             <a:ext cx="841248" cy="310896"/>
           </a:xfrm>
           <a:prstGeom prst="rect">
@@ -7597,13 +6493,13 @@
       </p:sp>
       <p:sp>
         <p:nvSpPr>
-          <p:cNvPr id="100" name="TextBox 99"/>
+          <p:cNvPr id="74" name="TextBox 73"/>
           <p:cNvSpPr txBox="1"/>
           <p:nvPr/>
         </p:nvSpPr>
         <p:spPr>
           <a:xfrm>
-            <a:off x="10351008" y="4224528"/>
+            <a:off x="9582912" y="4206240"/>
             <a:ext cx="658368" cy="109728"/>
           </a:xfrm>
           <a:prstGeom prst="rect">
@@ -7639,13 +6535,13 @@
       </p:sp>
       <p:sp>
         <p:nvSpPr>
-          <p:cNvPr id="101" name="Rectangle 100"/>
+          <p:cNvPr id="75" name="Rectangle 74"/>
           <p:cNvSpPr/>
           <p:nvPr/>
         </p:nvSpPr>
         <p:spPr>
           <a:xfrm>
-            <a:off x="9592056" y="5413248"/>
+            <a:off x="8302752" y="5504688"/>
             <a:ext cx="64008" cy="64008"/>
           </a:xfrm>
           <a:prstGeom prst="rect">
@@ -7684,14 +6580,14 @@
       </p:sp>
       <p:sp>
         <p:nvSpPr>
-          <p:cNvPr id="102" name="TextBox 101"/>
+          <p:cNvPr id="76" name="TextBox 75"/>
           <p:cNvSpPr txBox="1"/>
           <p:nvPr/>
         </p:nvSpPr>
         <p:spPr>
           <a:xfrm>
-            <a:off x="9710928" y="5367528"/>
-            <a:ext cx="1234440" cy="146304"/>
+            <a:off x="8421624" y="5458968"/>
+            <a:ext cx="1828800" cy="146304"/>
           </a:xfrm>
           <a:prstGeom prst="rect">
             <a:avLst/>
@@ -7726,13 +6622,13 @@
       </p:sp>
       <p:sp>
         <p:nvSpPr>
-          <p:cNvPr id="103" name="TextBox 102"/>
+          <p:cNvPr id="77" name="TextBox 76"/>
           <p:cNvSpPr txBox="1"/>
           <p:nvPr/>
         </p:nvSpPr>
         <p:spPr>
           <a:xfrm>
-            <a:off x="11064240" y="5367528"/>
+            <a:off x="11018520" y="5458968"/>
             <a:ext cx="640080" cy="146304"/>
           </a:xfrm>
           <a:prstGeom prst="rect">
@@ -7768,13 +6664,13 @@
       </p:sp>
       <p:sp>
         <p:nvSpPr>
-          <p:cNvPr id="104" name="Rectangle 103"/>
+          <p:cNvPr id="78" name="Rectangle 77"/>
           <p:cNvSpPr/>
           <p:nvPr/>
         </p:nvSpPr>
         <p:spPr>
           <a:xfrm>
-            <a:off x="9592056" y="5614416"/>
+            <a:off x="8302752" y="5715000"/>
             <a:ext cx="64008" cy="64008"/>
           </a:xfrm>
           <a:prstGeom prst="rect">
@@ -7813,14 +6709,14 @@
       </p:sp>
       <p:sp>
         <p:nvSpPr>
-          <p:cNvPr id="105" name="TextBox 104"/>
+          <p:cNvPr id="79" name="TextBox 78"/>
           <p:cNvSpPr txBox="1"/>
           <p:nvPr/>
         </p:nvSpPr>
         <p:spPr>
           <a:xfrm>
-            <a:off x="9710928" y="5568696"/>
-            <a:ext cx="1234440" cy="146304"/>
+            <a:off x="8421624" y="5669280"/>
+            <a:ext cx="1828800" cy="146304"/>
           </a:xfrm>
           <a:prstGeom prst="rect">
             <a:avLst/>
@@ -7855,13 +6751,13 @@
       </p:sp>
       <p:sp>
         <p:nvSpPr>
-          <p:cNvPr id="106" name="TextBox 105"/>
+          <p:cNvPr id="80" name="TextBox 79"/>
           <p:cNvSpPr txBox="1"/>
           <p:nvPr/>
         </p:nvSpPr>
         <p:spPr>
           <a:xfrm>
-            <a:off x="11064240" y="5568696"/>
+            <a:off x="11018520" y="5669280"/>
             <a:ext cx="640080" cy="146304"/>
           </a:xfrm>
           <a:prstGeom prst="rect">
@@ -7897,7 +6793,7 @@
       </p:sp>
       <p:sp>
         <p:nvSpPr>
-          <p:cNvPr id="107" name="TextBox 106"/>
+          <p:cNvPr id="81" name="TextBox 80"/>
           <p:cNvSpPr txBox="1"/>
           <p:nvPr/>
         </p:nvSpPr>
@@ -7939,7 +6835,7 @@
       </p:sp>
       <p:sp>
         <p:nvSpPr>
-          <p:cNvPr id="108" name="TextBox 107"/>
+          <p:cNvPr id="82" name="TextBox 81"/>
           <p:cNvSpPr txBox="1"/>
           <p:nvPr/>
         </p:nvSpPr>
@@ -8240,7 +7136,7 @@
                 </a:solidFill>
                 <a:latin typeface="Segoe UI"/>
               </a:rPr>
-              <a:t>Origem por OPM e município · dados agregados, sem nomes ou matrículas</a:t>
+              <a:t>Origem por batalhão e município · dados agregados, sem nomes ou matrículas</a:t>
             </a:r>
           </a:p>
         </p:txBody>
@@ -8411,7 +7307,7 @@
                 </a:solidFill>
                 <a:latin typeface="Segoe UI"/>
               </a:rPr>
-              <a:t>04</a:t>
+              <a:t>03</a:t>
             </a:r>
           </a:p>
         </p:txBody>
@@ -8583,7 +7479,7 @@
                 </a:solidFill>
                 <a:latin typeface="Segoe UI"/>
               </a:rPr>
-              <a:t>O ranking cobre demissões e exonerações individualizadas; aposentadorias não possuem OPM na base atual.</a:t>
+              <a:t>O ranking cobre demissões e exonerações individualizadas; aposentadorias não possuem unidade de origem na base atual.</a:t>
             </a:r>
           </a:p>
         </p:txBody>
@@ -9477,7 +8373,7 @@
                 </a:solidFill>
                 <a:latin typeface="Segoe UI"/>
               </a:rPr>
-              <a:t>04A</a:t>
+              <a:t>03A</a:t>
             </a:r>
           </a:p>
         </p:txBody>
@@ -11252,7 +10148,7 @@
                 </a:solidFill>
                 <a:latin typeface="Segoe UI"/>
               </a:rPr>
-              <a:t>04B</a:t>
+              <a:t>03B</a:t>
             </a:r>
           </a:p>
         </p:txBody>

</xml_diff>

<commit_message>
Adiciona card de reestruturação dos batalhões do interior
</commit_message>
<xml_diff>
--- a/exportacoes/Painel_Gestao_Pessoal_PMCE_EDITAVEL.pptx
+++ b/exportacoes/Painel_Gestao_Pessoal_PMCE_EDITAVEL.pptx
@@ -4077,7 +4077,7 @@
         <p:spPr>
           <a:xfrm>
             <a:off x="448056" y="1143000"/>
-            <a:ext cx="3017520" cy="82296"/>
+            <a:ext cx="3474720" cy="82296"/>
           </a:xfrm>
           <a:prstGeom prst="rect">
             <a:avLst/>
@@ -4105,7 +4105,7 @@
                 </a:solidFill>
                 <a:latin typeface="Segoe UI"/>
               </a:rPr>
-              <a:t>Os mostradores consolidam simultaneamente as cinco bases</a:t>
+              <a:t>Os mostradores consolidam os indicadores estratégicos das bases analisadas</a:t>
             </a:r>
           </a:p>
         </p:txBody>
@@ -4360,7 +4360,7 @@
                 </a:solidFill>
                 <a:latin typeface="Segoe UI"/>
               </a:rPr>
-              <a:t>●  5 bases consolidadas</a:t>
+              <a:t>●  6 bases consolidadas</a:t>
             </a:r>
           </a:p>
         </p:txBody>
@@ -4373,8 +4373,8 @@
         </p:nvSpPr>
         <p:spPr>
           <a:xfrm>
-            <a:off x="448056" y="1389888"/>
-            <a:ext cx="2743200" cy="1042415"/>
+            <a:off x="329184" y="1389888"/>
+            <a:ext cx="2221992" cy="1042415"/>
           </a:xfrm>
           <a:prstGeom prst="roundRect">
             <a:avLst/>
@@ -4418,7 +4418,7 @@
         </p:nvSpPr>
         <p:spPr>
           <a:xfrm>
-            <a:off x="448056" y="1453896"/>
+            <a:off x="329184" y="1453896"/>
             <a:ext cx="32004" cy="914399"/>
           </a:xfrm>
           <a:prstGeom prst="rect">
@@ -4461,8 +4461,8 @@
         </p:nvSpPr>
         <p:spPr>
           <a:xfrm>
-            <a:off x="576072" y="1508760"/>
-            <a:ext cx="2075688" cy="274320"/>
+            <a:off x="457200" y="1508760"/>
+            <a:ext cx="1554480" cy="274320"/>
           </a:xfrm>
           <a:prstGeom prst="rect">
             <a:avLst/>
@@ -4484,7 +4484,7 @@
               </a:spcAft>
             </a:pPr>
             <a:r>
-              <a:rPr sz="680" b="1">
+              <a:rPr sz="620" b="1">
                 <a:solidFill>
                   <a:srgbClr val="16231D"/>
                 </a:solidFill>
@@ -4504,7 +4504,7 @@
         </p:nvSpPr>
         <p:spPr>
           <a:xfrm>
-            <a:off x="2816352" y="1508760"/>
+            <a:off x="2176272" y="1508760"/>
             <a:ext cx="256032" cy="256032"/>
           </a:xfrm>
           <a:prstGeom prst="roundRect">
@@ -4547,7 +4547,7 @@
         </p:nvSpPr>
         <p:spPr>
           <a:xfrm>
-            <a:off x="2816352" y="1508760"/>
+            <a:off x="2176272" y="1508760"/>
             <a:ext cx="256032" cy="256032"/>
           </a:xfrm>
           <a:prstGeom prst="rect">
@@ -4589,7 +4589,7 @@
         </p:nvSpPr>
         <p:spPr>
           <a:xfrm>
-            <a:off x="576072" y="1847088"/>
+            <a:off x="457200" y="1847088"/>
             <a:ext cx="768096" cy="329184"/>
           </a:xfrm>
           <a:prstGeom prst="rect">
@@ -4631,7 +4631,7 @@
         </p:nvSpPr>
         <p:spPr>
           <a:xfrm>
-            <a:off x="1280160" y="1938528"/>
+            <a:off x="1161288" y="1938528"/>
             <a:ext cx="822960" cy="137160"/>
           </a:xfrm>
           <a:prstGeom prst="rect">
@@ -4673,8 +4673,8 @@
         </p:nvCxnSpPr>
         <p:spPr>
           <a:xfrm>
-            <a:off x="576072" y="2267712"/>
-            <a:ext cx="146304" cy="0"/>
+            <a:off x="457200" y="2267712"/>
+            <a:ext cx="146303" cy="0"/>
           </a:xfrm>
           <a:prstGeom prst="line">
             <a:avLst/>
@@ -4708,8 +4708,8 @@
         </p:nvSpPr>
         <p:spPr>
           <a:xfrm>
-            <a:off x="768096" y="2185416"/>
-            <a:ext cx="2286000" cy="146304"/>
+            <a:off x="649224" y="2185416"/>
+            <a:ext cx="1764792" cy="146304"/>
           </a:xfrm>
           <a:prstGeom prst="rect">
             <a:avLst/>
@@ -4731,7 +4731,7 @@
               </a:spcAft>
             </a:pPr>
             <a:r>
-              <a:rPr sz="550" b="0">
+              <a:rPr sz="459" b="0">
                 <a:solidFill>
                   <a:srgbClr val="6D7973"/>
                 </a:solidFill>
@@ -4750,8 +4750,8 @@
         </p:nvSpPr>
         <p:spPr>
           <a:xfrm>
-            <a:off x="3300984" y="1389888"/>
-            <a:ext cx="2743200" cy="1042415"/>
+            <a:off x="2660904" y="1389888"/>
+            <a:ext cx="2221992" cy="1042415"/>
           </a:xfrm>
           <a:prstGeom prst="roundRect">
             <a:avLst/>
@@ -4795,7 +4795,7 @@
         </p:nvSpPr>
         <p:spPr>
           <a:xfrm>
-            <a:off x="3300984" y="1453896"/>
+            <a:off x="2660904" y="1453896"/>
             <a:ext cx="32004" cy="914399"/>
           </a:xfrm>
           <a:prstGeom prst="rect">
@@ -4838,8 +4838,8 @@
         </p:nvSpPr>
         <p:spPr>
           <a:xfrm>
-            <a:off x="3429000" y="1508760"/>
-            <a:ext cx="2075688" cy="310896"/>
+            <a:off x="2788920" y="1508760"/>
+            <a:ext cx="1554480" cy="310896"/>
           </a:xfrm>
           <a:prstGeom prst="rect">
             <a:avLst/>
@@ -4861,14 +4861,14 @@
               </a:spcAft>
             </a:pPr>
             <a:r>
-              <a:rPr sz="620" b="1">
+              <a:rPr sz="530" b="1">
                 <a:solidFill>
                   <a:srgbClr val="16231D"/>
                 </a:solidFill>
                 <a:latin typeface="Segoe UI"/>
               </a:rPr>
-              <a:t>RAIO — Necessidade de efetivo para compor
-as 20 bases satélites em 3 níveis de implementação</a:t>
+              <a:t>RAIO — Necessidade para as 20 bases
+satélites em 3 níveis de implementação</a:t>
             </a:r>
           </a:p>
         </p:txBody>
@@ -4881,7 +4881,7 @@
         </p:nvSpPr>
         <p:spPr>
           <a:xfrm>
-            <a:off x="5669279" y="1508760"/>
+            <a:off x="4507992" y="1508760"/>
             <a:ext cx="256032" cy="256032"/>
           </a:xfrm>
           <a:prstGeom prst="roundRect">
@@ -4924,7 +4924,7 @@
         </p:nvSpPr>
         <p:spPr>
           <a:xfrm>
-            <a:off x="5669279" y="1508760"/>
+            <a:off x="4507992" y="1508760"/>
             <a:ext cx="256032" cy="256032"/>
           </a:xfrm>
           <a:prstGeom prst="rect">
@@ -4966,7 +4966,7 @@
         </p:nvSpPr>
         <p:spPr>
           <a:xfrm>
-            <a:off x="3429000" y="1847088"/>
+            <a:off x="2788920" y="1847088"/>
             <a:ext cx="768096" cy="329184"/>
           </a:xfrm>
           <a:prstGeom prst="rect">
@@ -5008,7 +5008,7 @@
         </p:nvSpPr>
         <p:spPr>
           <a:xfrm>
-            <a:off x="4133087" y="1938528"/>
+            <a:off x="3493008" y="1938528"/>
             <a:ext cx="822960" cy="137160"/>
           </a:xfrm>
           <a:prstGeom prst="rect">
@@ -5050,8 +5050,8 @@
         </p:nvCxnSpPr>
         <p:spPr>
           <a:xfrm>
-            <a:off x="3429000" y="2267712"/>
-            <a:ext cx="146303" cy="0"/>
+            <a:off x="2788920" y="2267712"/>
+            <a:ext cx="146304" cy="0"/>
           </a:xfrm>
           <a:prstGeom prst="line">
             <a:avLst/>
@@ -5085,8 +5085,8 @@
         </p:nvSpPr>
         <p:spPr>
           <a:xfrm>
-            <a:off x="3621024" y="2185416"/>
-            <a:ext cx="2286000" cy="146304"/>
+            <a:off x="2980944" y="2185416"/>
+            <a:ext cx="1764792" cy="146304"/>
           </a:xfrm>
           <a:prstGeom prst="rect">
             <a:avLst/>
@@ -5108,7 +5108,7 @@
               </a:spcAft>
             </a:pPr>
             <a:r>
-              <a:rPr sz="550" b="0">
+              <a:rPr sz="440" b="0">
                 <a:solidFill>
                   <a:srgbClr val="6D7973"/>
                 </a:solidFill>
@@ -5127,8 +5127,8 @@
         </p:nvSpPr>
         <p:spPr>
           <a:xfrm>
-            <a:off x="6153912" y="1389888"/>
-            <a:ext cx="2743200" cy="1042415"/>
+            <a:off x="4992624" y="1389888"/>
+            <a:ext cx="2221992" cy="1042415"/>
           </a:xfrm>
           <a:prstGeom prst="roundRect">
             <a:avLst/>
@@ -5172,7 +5172,7 @@
         </p:nvSpPr>
         <p:spPr>
           <a:xfrm>
-            <a:off x="6153912" y="1453896"/>
+            <a:off x="4992624" y="1453896"/>
             <a:ext cx="32004" cy="914399"/>
           </a:xfrm>
           <a:prstGeom prst="rect">
@@ -5215,8 +5215,8 @@
         </p:nvSpPr>
         <p:spPr>
           <a:xfrm>
-            <a:off x="6281928" y="1508760"/>
-            <a:ext cx="2075688" cy="237744"/>
+            <a:off x="5120640" y="1508760"/>
+            <a:ext cx="1554480" cy="237744"/>
           </a:xfrm>
           <a:prstGeom prst="rect">
             <a:avLst/>
@@ -5238,7 +5238,7 @@
               </a:spcAft>
             </a:pPr>
             <a:r>
-              <a:rPr sz="780" b="1">
+              <a:rPr sz="610" b="1">
                 <a:solidFill>
                   <a:srgbClr val="16231D"/>
                 </a:solidFill>
@@ -5257,7 +5257,7 @@
         </p:nvSpPr>
         <p:spPr>
           <a:xfrm>
-            <a:off x="8522208" y="1508760"/>
+            <a:off x="6839712" y="1508760"/>
             <a:ext cx="256032" cy="256032"/>
           </a:xfrm>
           <a:prstGeom prst="roundRect">
@@ -5300,7 +5300,7 @@
         </p:nvSpPr>
         <p:spPr>
           <a:xfrm>
-            <a:off x="8522208" y="1508760"/>
+            <a:off x="6839712" y="1508760"/>
             <a:ext cx="256032" cy="256032"/>
           </a:xfrm>
           <a:prstGeom prst="rect">
@@ -5342,7 +5342,7 @@
         </p:nvSpPr>
         <p:spPr>
           <a:xfrm>
-            <a:off x="6281928" y="1847088"/>
+            <a:off x="5120640" y="1847088"/>
             <a:ext cx="768096" cy="329184"/>
           </a:xfrm>
           <a:prstGeom prst="rect">
@@ -5384,7 +5384,7 @@
         </p:nvSpPr>
         <p:spPr>
           <a:xfrm>
-            <a:off x="6986016" y="1938528"/>
+            <a:off x="5824728" y="1938528"/>
             <a:ext cx="822960" cy="137160"/>
           </a:xfrm>
           <a:prstGeom prst="rect">
@@ -5426,7 +5426,7 @@
         </p:nvCxnSpPr>
         <p:spPr>
           <a:xfrm>
-            <a:off x="6281928" y="2267712"/>
+            <a:off x="5120640" y="2267712"/>
             <a:ext cx="146304" cy="0"/>
           </a:xfrm>
           <a:prstGeom prst="line">
@@ -5461,8 +5461,8 @@
         </p:nvSpPr>
         <p:spPr>
           <a:xfrm>
-            <a:off x="6473952" y="2185416"/>
-            <a:ext cx="2286000" cy="201168"/>
+            <a:off x="5312664" y="2185416"/>
+            <a:ext cx="1764792" cy="201168"/>
           </a:xfrm>
           <a:prstGeom prst="rect">
             <a:avLst/>
@@ -5490,7 +5490,7 @@
                 </a:solidFill>
                 <a:latin typeface="Segoe UI"/>
               </a:rPr>
-              <a:t>POG — Policiamento Ordinário · 34 BPMs territoriais</a:t>
+              <a:t>Policiamento Ordinário · 34 BPMs</a:t>
             </a:r>
           </a:p>
         </p:txBody>
@@ -5503,8 +5503,8 @@
         </p:nvSpPr>
         <p:spPr>
           <a:xfrm>
-            <a:off x="9006840" y="1389888"/>
-            <a:ext cx="2743200" cy="1042415"/>
+            <a:off x="7324344" y="1389888"/>
+            <a:ext cx="2221992" cy="1042415"/>
           </a:xfrm>
           <a:prstGeom prst="roundRect">
             <a:avLst/>
@@ -5548,7 +5548,7 @@
         </p:nvSpPr>
         <p:spPr>
           <a:xfrm>
-            <a:off x="9006840" y="1453896"/>
+            <a:off x="7324344" y="1453896"/>
             <a:ext cx="32004" cy="914399"/>
           </a:xfrm>
           <a:prstGeom prst="rect">
@@ -5591,8 +5591,8 @@
         </p:nvSpPr>
         <p:spPr>
           <a:xfrm>
-            <a:off x="9134856" y="1508760"/>
-            <a:ext cx="2075688" cy="274320"/>
+            <a:off x="7452360" y="1508760"/>
+            <a:ext cx="1554480" cy="310896"/>
           </a:xfrm>
           <a:prstGeom prst="rect">
             <a:avLst/>
@@ -5614,15 +5614,14 @@
               </a:spcAft>
             </a:pPr>
             <a:r>
-              <a:rPr sz="540" b="1">
+              <a:rPr sz="509" b="1">
                 <a:solidFill>
                   <a:srgbClr val="16231D"/>
                 </a:solidFill>
                 <a:latin typeface="Segoe UI"/>
               </a:rPr>
-              <a:t>COPAC — Necessidade de efetivo
-para compor as 10 bases, sendo 04
-prioritárias em 2026 (PReVio)</a:t>
+              <a:t>COPAC — Necessidade para 10 bases,
+sendo 04 prioritárias em 2026 (PReVio)</a:t>
             </a:r>
           </a:p>
         </p:txBody>
@@ -5635,7 +5634,7 @@
         </p:nvSpPr>
         <p:spPr>
           <a:xfrm>
-            <a:off x="11375136" y="1508760"/>
+            <a:off x="9171432" y="1508760"/>
             <a:ext cx="256032" cy="256032"/>
           </a:xfrm>
           <a:prstGeom prst="roundRect">
@@ -5678,7 +5677,7 @@
         </p:nvSpPr>
         <p:spPr>
           <a:xfrm>
-            <a:off x="11375136" y="1508760"/>
+            <a:off x="9171432" y="1508760"/>
             <a:ext cx="256032" cy="256032"/>
           </a:xfrm>
           <a:prstGeom prst="rect">
@@ -5720,7 +5719,7 @@
         </p:nvSpPr>
         <p:spPr>
           <a:xfrm>
-            <a:off x="9134856" y="1847088"/>
+            <a:off x="7452360" y="1847088"/>
             <a:ext cx="768096" cy="329184"/>
           </a:xfrm>
           <a:prstGeom prst="rect">
@@ -5762,7 +5761,7 @@
         </p:nvSpPr>
         <p:spPr>
           <a:xfrm>
-            <a:off x="9838944" y="1938528"/>
+            <a:off x="8156448" y="1938528"/>
             <a:ext cx="822960" cy="137160"/>
           </a:xfrm>
           <a:prstGeom prst="rect">
@@ -5804,7 +5803,7 @@
         </p:nvCxnSpPr>
         <p:spPr>
           <a:xfrm>
-            <a:off x="9134856" y="2267712"/>
+            <a:off x="7452360" y="2267712"/>
             <a:ext cx="146304" cy="0"/>
           </a:xfrm>
           <a:prstGeom prst="line">
@@ -5839,8 +5838,8 @@
         </p:nvSpPr>
         <p:spPr>
           <a:xfrm>
-            <a:off x="9326880" y="2185416"/>
-            <a:ext cx="2286000" cy="146304"/>
+            <a:off x="7644383" y="2185416"/>
+            <a:ext cx="1764792" cy="146304"/>
           </a:xfrm>
           <a:prstGeom prst="rect">
             <a:avLst/>
@@ -5862,13 +5861,13 @@
               </a:spcAft>
             </a:pPr>
             <a:r>
-              <a:rPr sz="550" b="0">
+              <a:rPr sz="440" b="0">
                 <a:solidFill>
                   <a:srgbClr val="6D7973"/>
                 </a:solidFill>
                 <a:latin typeface="Segoe UI"/>
               </a:rPr>
-              <a:t>10 bases · 04 prioritárias em 2026</a:t>
+              <a:t>10 bases · 04 prioritárias</a:t>
             </a:r>
           </a:p>
         </p:txBody>
@@ -5881,8 +5880,8 @@
         </p:nvSpPr>
         <p:spPr>
           <a:xfrm>
-            <a:off x="228600" y="2487168"/>
-            <a:ext cx="7543800" cy="4105656"/>
+            <a:off x="9656064" y="1389888"/>
+            <a:ext cx="2221992" cy="1042415"/>
           </a:xfrm>
           <a:prstGeom prst="roundRect">
             <a:avLst/>
@@ -5918,23 +5917,278 @@
           </a:p>
         </p:txBody>
       </p:sp>
+      <p:sp>
+        <p:nvSpPr>
+          <p:cNvPr id="59" name="Rectangle 58"/>
+          <p:cNvSpPr/>
+          <p:nvPr/>
+        </p:nvSpPr>
+        <p:spPr>
+          <a:xfrm>
+            <a:off x="9656064" y="1453896"/>
+            <a:ext cx="32004" cy="914399"/>
+          </a:xfrm>
+          <a:prstGeom prst="rect">
+            <a:avLst/>
+          </a:prstGeom>
+          <a:solidFill>
+            <a:srgbClr val="698342"/>
+          </a:solidFill>
+          <a:ln w="8890">
+            <a:noFill/>
+          </a:ln>
+        </p:spPr>
+        <p:style>
+          <a:lnRef idx="1">
+            <a:schemeClr val="accent1"/>
+          </a:lnRef>
+          <a:fillRef idx="3">
+            <a:schemeClr val="accent1"/>
+          </a:fillRef>
+          <a:effectRef idx="2">
+            <a:schemeClr val="accent1"/>
+          </a:effectRef>
+          <a:fontRef idx="minor">
+            <a:schemeClr val="lt1"/>
+          </a:fontRef>
+        </p:style>
+        <p:txBody>
+          <a:bodyPr rtlCol="0" anchor="ctr"/>
+          <a:lstStyle/>
+          <a:p>
+            <a:pPr algn="ctr"/>
+          </a:p>
+        </p:txBody>
+      </p:sp>
+      <p:sp>
+        <p:nvSpPr>
+          <p:cNvPr id="60" name="TextBox 59"/>
+          <p:cNvSpPr txBox="1"/>
+          <p:nvPr/>
+        </p:nvSpPr>
+        <p:spPr>
+          <a:xfrm>
+            <a:off x="9784080" y="1508760"/>
+            <a:ext cx="1554480" cy="274320"/>
+          </a:xfrm>
+          <a:prstGeom prst="rect">
+            <a:avLst/>
+          </a:prstGeom>
+          <a:noFill/>
+        </p:spPr>
+        <p:txBody>
+          <a:bodyPr wrap="none" lIns="0" rIns="0" tIns="0" bIns="0" anchor="t">
+            <a:spAutoFit/>
+          </a:bodyPr>
+          <a:lstStyle/>
+          <a:p>
+            <a:pPr algn="l">
+              <a:spcBef>
+                <a:spcPts val="0"/>
+              </a:spcBef>
+              <a:spcAft>
+                <a:spcPts val="0"/>
+              </a:spcAft>
+            </a:pPr>
+            <a:r>
+              <a:rPr sz="580" b="1">
+                <a:solidFill>
+                  <a:srgbClr val="16231D"/>
+                </a:solidFill>
+                <a:latin typeface="Segoe UI"/>
+              </a:rPr>
+              <a:t>Reestruturação dos batalhões
+do interior</a:t>
+            </a:r>
+          </a:p>
+        </p:txBody>
+      </p:sp>
+      <p:sp>
+        <p:nvSpPr>
+          <p:cNvPr id="61" name="Rounded Rectangle 60"/>
+          <p:cNvSpPr/>
+          <p:nvPr/>
+        </p:nvSpPr>
+        <p:spPr>
+          <a:xfrm>
+            <a:off x="11503152" y="1508760"/>
+            <a:ext cx="256032" cy="256032"/>
+          </a:xfrm>
+          <a:prstGeom prst="roundRect">
+            <a:avLst/>
+          </a:prstGeom>
+          <a:solidFill>
+            <a:srgbClr val="EDF3E4"/>
+          </a:solidFill>
+          <a:ln w="8890">
+            <a:noFill/>
+          </a:ln>
+        </p:spPr>
+        <p:style>
+          <a:lnRef idx="1">
+            <a:schemeClr val="accent1"/>
+          </a:lnRef>
+          <a:fillRef idx="3">
+            <a:schemeClr val="accent1"/>
+          </a:fillRef>
+          <a:effectRef idx="2">
+            <a:schemeClr val="accent1"/>
+          </a:effectRef>
+          <a:fontRef idx="minor">
+            <a:schemeClr val="lt1"/>
+          </a:fontRef>
+        </p:style>
+        <p:txBody>
+          <a:bodyPr rtlCol="0" anchor="ctr"/>
+          <a:lstStyle/>
+          <a:p>
+            <a:pPr algn="ctr"/>
+          </a:p>
+        </p:txBody>
+      </p:sp>
+      <p:sp>
+        <p:nvSpPr>
+          <p:cNvPr id="62" name="TextBox 61"/>
+          <p:cNvSpPr txBox="1"/>
+          <p:nvPr/>
+        </p:nvSpPr>
+        <p:spPr>
+          <a:xfrm>
+            <a:off x="11503152" y="1508760"/>
+            <a:ext cx="256032" cy="256032"/>
+          </a:xfrm>
+          <a:prstGeom prst="rect">
+            <a:avLst/>
+          </a:prstGeom>
+          <a:noFill/>
+        </p:spPr>
+        <p:txBody>
+          <a:bodyPr wrap="none" lIns="0" rIns="0" tIns="0" bIns="0" anchor="ctr">
+            <a:spAutoFit/>
+          </a:bodyPr>
+          <a:lstStyle/>
+          <a:p>
+            <a:pPr algn="ctr">
+              <a:spcBef>
+                <a:spcPts val="0"/>
+              </a:spcBef>
+              <a:spcAft>
+                <a:spcPts val="0"/>
+              </a:spcAft>
+            </a:pPr>
+            <a:r>
+              <a:rPr sz="800" b="1">
+                <a:solidFill>
+                  <a:srgbClr val="698342"/>
+                </a:solidFill>
+                <a:latin typeface="Segoe UI"/>
+              </a:rPr>
+              <a:t>●</a:t>
+            </a:r>
+          </a:p>
+        </p:txBody>
+      </p:sp>
+      <p:sp>
+        <p:nvSpPr>
+          <p:cNvPr id="63" name="TextBox 62"/>
+          <p:cNvSpPr txBox="1"/>
+          <p:nvPr/>
+        </p:nvSpPr>
+        <p:spPr>
+          <a:xfrm>
+            <a:off x="9784080" y="1847088"/>
+            <a:ext cx="768096" cy="329184"/>
+          </a:xfrm>
+          <a:prstGeom prst="rect">
+            <a:avLst/>
+          </a:prstGeom>
+          <a:noFill/>
+        </p:spPr>
+        <p:txBody>
+          <a:bodyPr wrap="none" lIns="0" rIns="0" tIns="0" bIns="0" anchor="ctr">
+            <a:spAutoFit/>
+          </a:bodyPr>
+          <a:lstStyle/>
+          <a:p>
+            <a:pPr algn="l">
+              <a:spcBef>
+                <a:spcPts val="0"/>
+              </a:spcBef>
+              <a:spcAft>
+                <a:spcPts val="0"/>
+              </a:spcAft>
+            </a:pPr>
+            <a:r>
+              <a:rPr sz="2500" b="1">
+                <a:solidFill>
+                  <a:srgbClr val="16231D"/>
+                </a:solidFill>
+                <a:latin typeface="Segoe UI"/>
+              </a:rPr>
+              <a:t>9</a:t>
+            </a:r>
+          </a:p>
+        </p:txBody>
+      </p:sp>
+      <p:sp>
+        <p:nvSpPr>
+          <p:cNvPr id="64" name="TextBox 63"/>
+          <p:cNvSpPr txBox="1"/>
+          <p:nvPr/>
+        </p:nvSpPr>
+        <p:spPr>
+          <a:xfrm>
+            <a:off x="10488168" y="1938528"/>
+            <a:ext cx="822960" cy="137160"/>
+          </a:xfrm>
+          <a:prstGeom prst="rect">
+            <a:avLst/>
+          </a:prstGeom>
+          <a:noFill/>
+        </p:spPr>
+        <p:txBody>
+          <a:bodyPr wrap="none" lIns="0" rIns="0" tIns="0" bIns="0" anchor="ctr">
+            <a:spAutoFit/>
+          </a:bodyPr>
+          <a:lstStyle/>
+          <a:p>
+            <a:pPr algn="l">
+              <a:spcBef>
+                <a:spcPts val="0"/>
+              </a:spcBef>
+              <a:spcAft>
+                <a:spcPts val="0"/>
+              </a:spcAft>
+            </a:pPr>
+            <a:r>
+              <a:rPr sz="690" b="0">
+                <a:solidFill>
+                  <a:srgbClr val="6D7973"/>
+                </a:solidFill>
+                <a:latin typeface="Segoe UI"/>
+              </a:rPr>
+              <a:t>batalhões</a:t>
+            </a:r>
+          </a:p>
+        </p:txBody>
+      </p:sp>
       <p:cxnSp>
         <p:nvCxnSpPr>
-          <p:cNvPr id="59" name="Connector 58"/>
+          <p:cNvPr id="65" name="Connector 64"/>
           <p:cNvCxnSpPr/>
           <p:nvPr/>
         </p:nvCxnSpPr>
         <p:spPr>
           <a:xfrm>
-            <a:off x="228600" y="2926080"/>
-            <a:ext cx="7543800" cy="0"/>
+            <a:off x="9784080" y="2267712"/>
+            <a:ext cx="146304" cy="0"/>
           </a:xfrm>
           <a:prstGeom prst="line">
             <a:avLst/>
           </a:prstGeom>
-          <a:ln w="7620">
+          <a:ln w="16510">
             <a:solidFill>
-              <a:srgbClr val="E9EEEB"/>
+              <a:srgbClr val="698342"/>
             </a:solidFill>
           </a:ln>
         </p:spPr>
@@ -5955,7 +6209,129 @@
       </p:cxnSp>
       <p:sp>
         <p:nvSpPr>
-          <p:cNvPr id="60" name="Rounded Rectangle 59"/>
+          <p:cNvPr id="66" name="TextBox 65"/>
+          <p:cNvSpPr txBox="1"/>
+          <p:nvPr/>
+        </p:nvSpPr>
+        <p:spPr>
+          <a:xfrm>
+            <a:off x="9976104" y="2185416"/>
+            <a:ext cx="1764792" cy="146304"/>
+          </a:xfrm>
+          <a:prstGeom prst="rect">
+            <a:avLst/>
+          </a:prstGeom>
+          <a:noFill/>
+        </p:spPr>
+        <p:txBody>
+          <a:bodyPr wrap="none" lIns="0" rIns="0" tIns="0" bIns="0" anchor="t">
+            <a:spAutoFit/>
+          </a:bodyPr>
+          <a:lstStyle/>
+          <a:p>
+            <a:pPr algn="l">
+              <a:spcBef>
+                <a:spcPts val="0"/>
+              </a:spcBef>
+              <a:spcAft>
+                <a:spcPts val="0"/>
+              </a:spcAft>
+            </a:pPr>
+            <a:r>
+              <a:rPr sz="430" b="0">
+                <a:solidFill>
+                  <a:srgbClr val="6D7973"/>
+                </a:solidFill>
+                <a:latin typeface="Segoe UI"/>
+              </a:rPr>
+              <a:t>8 abaixo da média · 1 acima</a:t>
+            </a:r>
+          </a:p>
+        </p:txBody>
+      </p:sp>
+      <p:sp>
+        <p:nvSpPr>
+          <p:cNvPr id="67" name="Rounded Rectangle 66"/>
+          <p:cNvSpPr/>
+          <p:nvPr/>
+        </p:nvSpPr>
+        <p:spPr>
+          <a:xfrm>
+            <a:off x="228600" y="2487168"/>
+            <a:ext cx="7543800" cy="4105656"/>
+          </a:xfrm>
+          <a:prstGeom prst="roundRect">
+            <a:avLst/>
+          </a:prstGeom>
+          <a:solidFill>
+            <a:srgbClr val="FFFFFF"/>
+          </a:solidFill>
+          <a:ln w="8890">
+            <a:solidFill>
+              <a:srgbClr val="DFE6E2"/>
+            </a:solidFill>
+          </a:ln>
+        </p:spPr>
+        <p:style>
+          <a:lnRef idx="1">
+            <a:schemeClr val="accent1"/>
+          </a:lnRef>
+          <a:fillRef idx="3">
+            <a:schemeClr val="accent1"/>
+          </a:fillRef>
+          <a:effectRef idx="2">
+            <a:schemeClr val="accent1"/>
+          </a:effectRef>
+          <a:fontRef idx="minor">
+            <a:schemeClr val="lt1"/>
+          </a:fontRef>
+        </p:style>
+        <p:txBody>
+          <a:bodyPr rtlCol="0" anchor="ctr"/>
+          <a:lstStyle/>
+          <a:p>
+            <a:pPr algn="ctr"/>
+          </a:p>
+        </p:txBody>
+      </p:sp>
+      <p:cxnSp>
+        <p:nvCxnSpPr>
+          <p:cNvPr id="68" name="Connector 67"/>
+          <p:cNvCxnSpPr/>
+          <p:nvPr/>
+        </p:nvCxnSpPr>
+        <p:spPr>
+          <a:xfrm>
+            <a:off x="228600" y="2926080"/>
+            <a:ext cx="7543800" cy="0"/>
+          </a:xfrm>
+          <a:prstGeom prst="line">
+            <a:avLst/>
+          </a:prstGeom>
+          <a:ln w="7620">
+            <a:solidFill>
+              <a:srgbClr val="E9EEEB"/>
+            </a:solidFill>
+          </a:ln>
+        </p:spPr>
+        <p:style>
+          <a:lnRef idx="2">
+            <a:schemeClr val="accent1"/>
+          </a:lnRef>
+          <a:fillRef idx="0">
+            <a:schemeClr val="accent1"/>
+          </a:fillRef>
+          <a:effectRef idx="1">
+            <a:schemeClr val="accent1"/>
+          </a:effectRef>
+          <a:fontRef idx="minor">
+            <a:schemeClr val="tx1"/>
+          </a:fontRef>
+        </p:style>
+      </p:cxnSp>
+      <p:sp>
+        <p:nvSpPr>
+          <p:cNvPr id="69" name="Rounded Rectangle 68"/>
           <p:cNvSpPr/>
           <p:nvPr/>
         </p:nvSpPr>
@@ -5998,7 +6374,7 @@
       </p:sp>
       <p:sp>
         <p:nvSpPr>
-          <p:cNvPr id="61" name="TextBox 60"/>
+          <p:cNvPr id="70" name="TextBox 69"/>
           <p:cNvSpPr txBox="1"/>
           <p:nvPr/>
         </p:nvSpPr>
@@ -6040,7 +6416,7 @@
       </p:sp>
       <p:sp>
         <p:nvSpPr>
-          <p:cNvPr id="62" name="TextBox 61"/>
+          <p:cNvPr id="71" name="TextBox 70"/>
           <p:cNvSpPr txBox="1"/>
           <p:nvPr/>
         </p:nvSpPr>
@@ -6082,7 +6458,7 @@
       </p:sp>
       <p:sp>
         <p:nvSpPr>
-          <p:cNvPr id="63" name="TextBox 62"/>
+          <p:cNvPr id="72" name="TextBox 71"/>
           <p:cNvSpPr txBox="1"/>
           <p:nvPr/>
         </p:nvSpPr>
@@ -6124,7 +6500,7 @@
       </p:sp>
       <p:graphicFrame>
         <p:nvGraphicFramePr>
-          <p:cNvPr id="64" name="Chart 63"/>
+          <p:cNvPr id="73" name="Chart 72"/>
           <p:cNvGraphicFramePr>
             <a:graphicFrameLocks noGrp="1"/>
           </p:cNvGraphicFramePr>
@@ -6142,7 +6518,7 @@
       </p:graphicFrame>
       <p:sp>
         <p:nvSpPr>
-          <p:cNvPr id="65" name="TextBox 64"/>
+          <p:cNvPr id="74" name="TextBox 73"/>
           <p:cNvSpPr txBox="1"/>
           <p:nvPr/>
         </p:nvSpPr>
@@ -6184,7 +6560,7 @@
       </p:sp>
       <p:sp>
         <p:nvSpPr>
-          <p:cNvPr id="66" name="Rounded Rectangle 65"/>
+          <p:cNvPr id="75" name="Rounded Rectangle 74"/>
           <p:cNvSpPr/>
           <p:nvPr/>
         </p:nvSpPr>
@@ -6229,7 +6605,7 @@
       </p:sp>
       <p:cxnSp>
         <p:nvCxnSpPr>
-          <p:cNvPr id="67" name="Connector 66"/>
+          <p:cNvPr id="76" name="Connector 75"/>
           <p:cNvCxnSpPr/>
           <p:nvPr/>
         </p:nvCxnSpPr>
@@ -6264,7 +6640,7 @@
       </p:cxnSp>
       <p:sp>
         <p:nvSpPr>
-          <p:cNvPr id="68" name="Rounded Rectangle 67"/>
+          <p:cNvPr id="77" name="Rounded Rectangle 76"/>
           <p:cNvSpPr/>
           <p:nvPr/>
         </p:nvSpPr>
@@ -6307,7 +6683,7 @@
       </p:sp>
       <p:sp>
         <p:nvSpPr>
-          <p:cNvPr id="69" name="TextBox 68"/>
+          <p:cNvPr id="78" name="TextBox 77"/>
           <p:cNvSpPr txBox="1"/>
           <p:nvPr/>
         </p:nvSpPr>
@@ -6349,7 +6725,7 @@
       </p:sp>
       <p:sp>
         <p:nvSpPr>
-          <p:cNvPr id="70" name="TextBox 69"/>
+          <p:cNvPr id="79" name="TextBox 78"/>
           <p:cNvSpPr txBox="1"/>
           <p:nvPr/>
         </p:nvSpPr>
@@ -6391,7 +6767,7 @@
       </p:sp>
       <p:sp>
         <p:nvSpPr>
-          <p:cNvPr id="71" name="TextBox 70"/>
+          <p:cNvPr id="80" name="TextBox 79"/>
           <p:cNvSpPr txBox="1"/>
           <p:nvPr/>
         </p:nvSpPr>
@@ -6433,7 +6809,7 @@
       </p:sp>
       <p:graphicFrame>
         <p:nvGraphicFramePr>
-          <p:cNvPr id="72" name="Chart 71"/>
+          <p:cNvPr id="81" name="Chart 80"/>
           <p:cNvGraphicFramePr>
             <a:graphicFrameLocks noGrp="1"/>
           </p:cNvGraphicFramePr>
@@ -6451,7 +6827,7 @@
       </p:graphicFrame>
       <p:sp>
         <p:nvSpPr>
-          <p:cNvPr id="73" name="TextBox 72"/>
+          <p:cNvPr id="82" name="TextBox 81"/>
           <p:cNvSpPr txBox="1"/>
           <p:nvPr/>
         </p:nvSpPr>
@@ -6493,7 +6869,7 @@
       </p:sp>
       <p:sp>
         <p:nvSpPr>
-          <p:cNvPr id="74" name="TextBox 73"/>
+          <p:cNvPr id="83" name="TextBox 82"/>
           <p:cNvSpPr txBox="1"/>
           <p:nvPr/>
         </p:nvSpPr>
@@ -6535,7 +6911,7 @@
       </p:sp>
       <p:sp>
         <p:nvSpPr>
-          <p:cNvPr id="75" name="Rectangle 74"/>
+          <p:cNvPr id="84" name="Rectangle 83"/>
           <p:cNvSpPr/>
           <p:nvPr/>
         </p:nvSpPr>
@@ -6580,7 +6956,7 @@
       </p:sp>
       <p:sp>
         <p:nvSpPr>
-          <p:cNvPr id="76" name="TextBox 75"/>
+          <p:cNvPr id="85" name="TextBox 84"/>
           <p:cNvSpPr txBox="1"/>
           <p:nvPr/>
         </p:nvSpPr>
@@ -6622,7 +6998,7 @@
       </p:sp>
       <p:sp>
         <p:nvSpPr>
-          <p:cNvPr id="77" name="TextBox 76"/>
+          <p:cNvPr id="86" name="TextBox 85"/>
           <p:cNvSpPr txBox="1"/>
           <p:nvPr/>
         </p:nvSpPr>
@@ -6664,7 +7040,7 @@
       </p:sp>
       <p:sp>
         <p:nvSpPr>
-          <p:cNvPr id="78" name="Rectangle 77"/>
+          <p:cNvPr id="87" name="Rectangle 86"/>
           <p:cNvSpPr/>
           <p:nvPr/>
         </p:nvSpPr>
@@ -6709,7 +7085,7 @@
       </p:sp>
       <p:sp>
         <p:nvSpPr>
-          <p:cNvPr id="79" name="TextBox 78"/>
+          <p:cNvPr id="88" name="TextBox 87"/>
           <p:cNvSpPr txBox="1"/>
           <p:nvPr/>
         </p:nvSpPr>
@@ -6751,7 +7127,7 @@
       </p:sp>
       <p:sp>
         <p:nvSpPr>
-          <p:cNvPr id="80" name="TextBox 79"/>
+          <p:cNvPr id="89" name="TextBox 88"/>
           <p:cNvSpPr txBox="1"/>
           <p:nvPr/>
         </p:nvSpPr>
@@ -6793,7 +7169,7 @@
       </p:sp>
       <p:sp>
         <p:nvSpPr>
-          <p:cNvPr id="81" name="TextBox 80"/>
+          <p:cNvPr id="90" name="TextBox 89"/>
           <p:cNvSpPr txBox="1"/>
           <p:nvPr/>
         </p:nvSpPr>
@@ -6835,7 +7211,7 @@
       </p:sp>
       <p:sp>
         <p:nvSpPr>
-          <p:cNvPr id="82" name="TextBox 81"/>
+          <p:cNvPr id="91" name="TextBox 90"/>
           <p:cNvSpPr txBox="1"/>
           <p:nvPr/>
         </p:nvSpPr>

</xml_diff>

<commit_message>
Alinha cards e aprimora composição da reestruturação
</commit_message>
<xml_diff>
--- a/exportacoes/Painel_Gestao_Pessoal_PMCE_EDITAVEL.pptx
+++ b/exportacoes/Painel_Gestao_Pessoal_PMCE_EDITAVEL.pptx
@@ -4373,8 +4373,8 @@
         </p:nvSpPr>
         <p:spPr>
           <a:xfrm>
-            <a:off x="329184" y="1389888"/>
-            <a:ext cx="2221992" cy="1042415"/>
+            <a:off x="320040" y="1389888"/>
+            <a:ext cx="3429000" cy="749808"/>
           </a:xfrm>
           <a:prstGeom prst="roundRect">
             <a:avLst/>
@@ -4418,8 +4418,8 @@
         </p:nvSpPr>
         <p:spPr>
           <a:xfrm>
-            <a:off x="329184" y="1453896"/>
-            <a:ext cx="32004" cy="914399"/>
+            <a:off x="320040" y="1453896"/>
+            <a:ext cx="32004" cy="621792"/>
           </a:xfrm>
           <a:prstGeom prst="rect">
             <a:avLst/>
@@ -4461,8 +4461,8 @@
         </p:nvSpPr>
         <p:spPr>
           <a:xfrm>
-            <a:off x="457200" y="1508760"/>
-            <a:ext cx="1554480" cy="274320"/>
+            <a:off x="448056" y="1463040"/>
+            <a:ext cx="2761488" cy="201168"/>
           </a:xfrm>
           <a:prstGeom prst="rect">
             <a:avLst/>
@@ -4490,8 +4490,7 @@
                 </a:solidFill>
                 <a:latin typeface="Segoe UI"/>
               </a:rPr>
-              <a:t>Saídas de efetivo
-(exoneração — aposentadoria)</a:t>
+              <a:t>Saídas de efetivo (exoneração — aposentadoria)</a:t>
             </a:r>
           </a:p>
         </p:txBody>
@@ -4504,7 +4503,7 @@
         </p:nvSpPr>
         <p:spPr>
           <a:xfrm>
-            <a:off x="2176272" y="1508760"/>
+            <a:off x="3374135" y="1463040"/>
             <a:ext cx="256032" cy="256032"/>
           </a:xfrm>
           <a:prstGeom prst="roundRect">
@@ -4547,7 +4546,7 @@
         </p:nvSpPr>
         <p:spPr>
           <a:xfrm>
-            <a:off x="2176272" y="1508760"/>
+            <a:off x="3374135" y="1463040"/>
             <a:ext cx="256032" cy="256032"/>
           </a:xfrm>
           <a:prstGeom prst="rect">
@@ -4589,8 +4588,8 @@
         </p:nvSpPr>
         <p:spPr>
           <a:xfrm>
-            <a:off x="457200" y="1847088"/>
-            <a:ext cx="768096" cy="329184"/>
+            <a:off x="448056" y="1719072"/>
+            <a:ext cx="768096" cy="274320"/>
           </a:xfrm>
           <a:prstGeom prst="rect">
             <a:avLst/>
@@ -4612,7 +4611,7 @@
               </a:spcAft>
             </a:pPr>
             <a:r>
-              <a:rPr sz="2500" b="1">
+              <a:rPr sz="2100" b="1">
                 <a:solidFill>
                   <a:srgbClr val="16231D"/>
                 </a:solidFill>
@@ -4631,7 +4630,7 @@
         </p:nvSpPr>
         <p:spPr>
           <a:xfrm>
-            <a:off x="1161288" y="1938528"/>
+            <a:off x="1152144" y="1792224"/>
             <a:ext cx="822960" cy="137160"/>
           </a:xfrm>
           <a:prstGeom prst="rect">
@@ -4654,7 +4653,7 @@
               </a:spcAft>
             </a:pPr>
             <a:r>
-              <a:rPr sz="690" b="0">
+              <a:rPr sz="640" b="0">
                 <a:solidFill>
                   <a:srgbClr val="6D7973"/>
                 </a:solidFill>
@@ -4673,7 +4672,7 @@
         </p:nvCxnSpPr>
         <p:spPr>
           <a:xfrm>
-            <a:off x="457200" y="2267712"/>
+            <a:off x="448056" y="2039112"/>
             <a:ext cx="146303" cy="0"/>
           </a:xfrm>
           <a:prstGeom prst="line">
@@ -4708,8 +4707,8 @@
         </p:nvSpPr>
         <p:spPr>
           <a:xfrm>
-            <a:off x="649224" y="2185416"/>
-            <a:ext cx="1764792" cy="146304"/>
+            <a:off x="640080" y="1975103"/>
+            <a:ext cx="2971800" cy="146304"/>
           </a:xfrm>
           <a:prstGeom prst="rect">
             <a:avLst/>
@@ -4731,7 +4730,7 @@
               </a:spcAft>
             </a:pPr>
             <a:r>
-              <a:rPr sz="459" b="0">
+              <a:rPr sz="470" b="0">
                 <a:solidFill>
                   <a:srgbClr val="6D7973"/>
                 </a:solidFill>
@@ -4750,8 +4749,8 @@
         </p:nvSpPr>
         <p:spPr>
           <a:xfrm>
-            <a:off x="2660904" y="1389888"/>
-            <a:ext cx="2221992" cy="1042415"/>
+            <a:off x="4379976" y="1389888"/>
+            <a:ext cx="3429000" cy="749808"/>
           </a:xfrm>
           <a:prstGeom prst="roundRect">
             <a:avLst/>
@@ -4795,14 +4794,14 @@
         </p:nvSpPr>
         <p:spPr>
           <a:xfrm>
-            <a:off x="2660904" y="1453896"/>
-            <a:ext cx="32004" cy="914399"/>
+            <a:off x="4379976" y="1453896"/>
+            <a:ext cx="32004" cy="621792"/>
           </a:xfrm>
           <a:prstGeom prst="rect">
             <a:avLst/>
           </a:prstGeom>
           <a:solidFill>
-            <a:srgbClr val="3B7E9D"/>
+            <a:srgbClr val="216F4C"/>
           </a:solidFill>
           <a:ln w="8890">
             <a:noFill/>
@@ -4838,8 +4837,8 @@
         </p:nvSpPr>
         <p:spPr>
           <a:xfrm>
-            <a:off x="2788920" y="1508760"/>
-            <a:ext cx="1554480" cy="310896"/>
+            <a:off x="4507992" y="1463040"/>
+            <a:ext cx="2761488" cy="201168"/>
           </a:xfrm>
           <a:prstGeom prst="rect">
             <a:avLst/>
@@ -4861,14 +4860,13 @@
               </a:spcAft>
             </a:pPr>
             <a:r>
-              <a:rPr sz="530" b="1">
+              <a:rPr sz="620" b="1">
                 <a:solidFill>
                   <a:srgbClr val="16231D"/>
                 </a:solidFill>
                 <a:latin typeface="Segoe UI"/>
               </a:rPr>
-              <a:t>RAIO — Necessidade para as 20 bases
-satélites em 3 níveis de implementação</a:t>
+              <a:t>Déficit de efetivo — POG</a:t>
             </a:r>
           </a:p>
         </p:txBody>
@@ -4881,14 +4879,14 @@
         </p:nvSpPr>
         <p:spPr>
           <a:xfrm>
-            <a:off x="4507992" y="1508760"/>
+            <a:off x="7434071" y="1463040"/>
             <a:ext cx="256032" cy="256032"/>
           </a:xfrm>
           <a:prstGeom prst="roundRect">
             <a:avLst/>
           </a:prstGeom>
           <a:solidFill>
-            <a:srgbClr val="E7F1F6"/>
+            <a:srgbClr val="E4F2E9"/>
           </a:solidFill>
           <a:ln w="8890">
             <a:noFill/>
@@ -4924,7 +4922,7 @@
         </p:nvSpPr>
         <p:spPr>
           <a:xfrm>
-            <a:off x="4507992" y="1508760"/>
+            <a:off x="7434071" y="1463040"/>
             <a:ext cx="256032" cy="256032"/>
           </a:xfrm>
           <a:prstGeom prst="rect">
@@ -4949,7 +4947,7 @@
             <a:r>
               <a:rPr sz="800" b="1">
                 <a:solidFill>
-                  <a:srgbClr val="3B7E9D"/>
+                  <a:srgbClr val="216F4C"/>
                 </a:solidFill>
                 <a:latin typeface="Segoe UI"/>
               </a:rPr>
@@ -4966,8 +4964,8 @@
         </p:nvSpPr>
         <p:spPr>
           <a:xfrm>
-            <a:off x="2788920" y="1847088"/>
-            <a:ext cx="768096" cy="329184"/>
+            <a:off x="4507992" y="1719072"/>
+            <a:ext cx="768096" cy="274320"/>
           </a:xfrm>
           <a:prstGeom prst="rect">
             <a:avLst/>
@@ -4989,13 +4987,13 @@
               </a:spcAft>
             </a:pPr>
             <a:r>
-              <a:rPr sz="2500" b="1">
+              <a:rPr sz="2100" b="1">
                 <a:solidFill>
                   <a:srgbClr val="16231D"/>
                 </a:solidFill>
                 <a:latin typeface="Segoe UI"/>
               </a:rPr>
-              <a:t>912</a:t>
+              <a:t>111</a:t>
             </a:r>
           </a:p>
         </p:txBody>
@@ -5008,7 +5006,7 @@
         </p:nvSpPr>
         <p:spPr>
           <a:xfrm>
-            <a:off x="3493008" y="1938528"/>
+            <a:off x="5212080" y="1792224"/>
             <a:ext cx="822960" cy="137160"/>
           </a:xfrm>
           <a:prstGeom prst="rect">
@@ -5031,7 +5029,7 @@
               </a:spcAft>
             </a:pPr>
             <a:r>
-              <a:rPr sz="690" b="0">
+              <a:rPr sz="640" b="0">
                 <a:solidFill>
                   <a:srgbClr val="6D7973"/>
                 </a:solidFill>
@@ -5050,7 +5048,7 @@
         </p:nvCxnSpPr>
         <p:spPr>
           <a:xfrm>
-            <a:off x="2788920" y="2267712"/>
+            <a:off x="4507992" y="2039112"/>
             <a:ext cx="146304" cy="0"/>
           </a:xfrm>
           <a:prstGeom prst="line">
@@ -5058,7 +5056,7 @@
           </a:prstGeom>
           <a:ln w="16510">
             <a:solidFill>
-              <a:srgbClr val="3B7E9D"/>
+              <a:srgbClr val="216F4C"/>
             </a:solidFill>
           </a:ln>
         </p:spPr>
@@ -5085,8 +5083,8 @@
         </p:nvSpPr>
         <p:spPr>
           <a:xfrm>
-            <a:off x="2980944" y="2185416"/>
-            <a:ext cx="1764792" cy="146304"/>
+            <a:off x="4700016" y="1975103"/>
+            <a:ext cx="2971800" cy="146304"/>
           </a:xfrm>
           <a:prstGeom prst="rect">
             <a:avLst/>
@@ -5108,13 +5106,13 @@
               </a:spcAft>
             </a:pPr>
             <a:r>
-              <a:rPr sz="440" b="0">
+              <a:rPr sz="470" b="0">
                 <a:solidFill>
                   <a:srgbClr val="6D7973"/>
                 </a:solidFill>
                 <a:latin typeface="Segoe UI"/>
               </a:rPr>
-              <a:t>20 bases · 31 municípios satélite</a:t>
+              <a:t>Policiamento Ordinário · 34 BPMs</a:t>
             </a:r>
           </a:p>
         </p:txBody>
@@ -5127,8 +5125,8 @@
         </p:nvSpPr>
         <p:spPr>
           <a:xfrm>
-            <a:off x="4992624" y="1389888"/>
-            <a:ext cx="2221992" cy="1042415"/>
+            <a:off x="8439912" y="1389888"/>
+            <a:ext cx="3429000" cy="749808"/>
           </a:xfrm>
           <a:prstGeom prst="roundRect">
             <a:avLst/>
@@ -5172,14 +5170,14 @@
         </p:nvSpPr>
         <p:spPr>
           <a:xfrm>
-            <a:off x="4992624" y="1453896"/>
-            <a:ext cx="32004" cy="914399"/>
+            <a:off x="8439912" y="1453896"/>
+            <a:ext cx="32004" cy="621792"/>
           </a:xfrm>
           <a:prstGeom prst="rect">
             <a:avLst/>
           </a:prstGeom>
           <a:solidFill>
-            <a:srgbClr val="216F4C"/>
+            <a:srgbClr val="698342"/>
           </a:solidFill>
           <a:ln w="8890">
             <a:noFill/>
@@ -5215,8 +5213,8 @@
         </p:nvSpPr>
         <p:spPr>
           <a:xfrm>
-            <a:off x="5120640" y="1508760"/>
-            <a:ext cx="1554480" cy="237744"/>
+            <a:off x="8567928" y="1463040"/>
+            <a:ext cx="2761488" cy="201168"/>
           </a:xfrm>
           <a:prstGeom prst="rect">
             <a:avLst/>
@@ -5238,13 +5236,13 @@
               </a:spcAft>
             </a:pPr>
             <a:r>
-              <a:rPr sz="610" b="1">
+              <a:rPr sz="620" b="1">
                 <a:solidFill>
                   <a:srgbClr val="16231D"/>
                 </a:solidFill>
                 <a:latin typeface="Segoe UI"/>
               </a:rPr>
-              <a:t>Déficit de efetivo — POG</a:t>
+              <a:t>Reestruturação dos batalhões do interior</a:t>
             </a:r>
           </a:p>
         </p:txBody>
@@ -5257,14 +5255,14 @@
         </p:nvSpPr>
         <p:spPr>
           <a:xfrm>
-            <a:off x="6839712" y="1508760"/>
+            <a:off x="11494008" y="1463040"/>
             <a:ext cx="256032" cy="256032"/>
           </a:xfrm>
           <a:prstGeom prst="roundRect">
             <a:avLst/>
           </a:prstGeom>
           <a:solidFill>
-            <a:srgbClr val="E4F2E9"/>
+            <a:srgbClr val="EDF3E4"/>
           </a:solidFill>
           <a:ln w="8890">
             <a:noFill/>
@@ -5300,7 +5298,7 @@
         </p:nvSpPr>
         <p:spPr>
           <a:xfrm>
-            <a:off x="6839712" y="1508760"/>
+            <a:off x="11494008" y="1463040"/>
             <a:ext cx="256032" cy="256032"/>
           </a:xfrm>
           <a:prstGeom prst="rect">
@@ -5325,7 +5323,7 @@
             <a:r>
               <a:rPr sz="800" b="1">
                 <a:solidFill>
-                  <a:srgbClr val="216F4C"/>
+                  <a:srgbClr val="698342"/>
                 </a:solidFill>
                 <a:latin typeface="Segoe UI"/>
               </a:rPr>
@@ -5342,8 +5340,8 @@
         </p:nvSpPr>
         <p:spPr>
           <a:xfrm>
-            <a:off x="5120640" y="1847088"/>
-            <a:ext cx="768096" cy="329184"/>
+            <a:off x="8567928" y="1719072"/>
+            <a:ext cx="768096" cy="274320"/>
           </a:xfrm>
           <a:prstGeom prst="rect">
             <a:avLst/>
@@ -5365,13 +5363,13 @@
               </a:spcAft>
             </a:pPr>
             <a:r>
-              <a:rPr sz="2500" b="1">
+              <a:rPr sz="2100" b="1">
                 <a:solidFill>
                   <a:srgbClr val="16231D"/>
                 </a:solidFill>
                 <a:latin typeface="Segoe UI"/>
               </a:rPr>
-              <a:t>111</a:t>
+              <a:t>9</a:t>
             </a:r>
           </a:p>
         </p:txBody>
@@ -5384,7 +5382,7 @@
         </p:nvSpPr>
         <p:spPr>
           <a:xfrm>
-            <a:off x="5824728" y="1938528"/>
+            <a:off x="9272016" y="1792224"/>
             <a:ext cx="822960" cy="137160"/>
           </a:xfrm>
           <a:prstGeom prst="rect">
@@ -5407,13 +5405,13 @@
               </a:spcAft>
             </a:pPr>
             <a:r>
-              <a:rPr sz="690" b="0">
+              <a:rPr sz="640" b="0">
                 <a:solidFill>
                   <a:srgbClr val="6D7973"/>
                 </a:solidFill>
                 <a:latin typeface="Segoe UI"/>
               </a:rPr>
-              <a:t>policiais</a:t>
+              <a:t>batalhões</a:t>
             </a:r>
           </a:p>
         </p:txBody>
@@ -5426,7 +5424,7 @@
         </p:nvCxnSpPr>
         <p:spPr>
           <a:xfrm>
-            <a:off x="5120640" y="2267712"/>
+            <a:off x="8567928" y="2039112"/>
             <a:ext cx="146304" cy="0"/>
           </a:xfrm>
           <a:prstGeom prst="line">
@@ -5434,7 +5432,7 @@
           </a:prstGeom>
           <a:ln w="16510">
             <a:solidFill>
-              <a:srgbClr val="216F4C"/>
+              <a:srgbClr val="698342"/>
             </a:solidFill>
           </a:ln>
         </p:spPr>
@@ -5461,8 +5459,8 @@
         </p:nvSpPr>
         <p:spPr>
           <a:xfrm>
-            <a:off x="5312664" y="2185416"/>
-            <a:ext cx="1764792" cy="201168"/>
+            <a:off x="8759952" y="1975103"/>
+            <a:ext cx="2971800" cy="146304"/>
           </a:xfrm>
           <a:prstGeom prst="rect">
             <a:avLst/>
@@ -5484,13 +5482,13 @@
               </a:spcAft>
             </a:pPr>
             <a:r>
-              <a:rPr sz="440" b="0">
+              <a:rPr sz="470" b="0">
                 <a:solidFill>
                   <a:srgbClr val="6D7973"/>
                 </a:solidFill>
                 <a:latin typeface="Segoe UI"/>
               </a:rPr>
-              <a:t>Policiamento Ordinário · 34 BPMs</a:t>
+              <a:t>8 abaixo da média · 1 acima</a:t>
             </a:r>
           </a:p>
         </p:txBody>
@@ -5503,8 +5501,8 @@
         </p:nvSpPr>
         <p:spPr>
           <a:xfrm>
-            <a:off x="7324344" y="1389888"/>
-            <a:ext cx="2221992" cy="1042415"/>
+            <a:off x="2350008" y="2231136"/>
+            <a:ext cx="3429000" cy="749808"/>
           </a:xfrm>
           <a:prstGeom prst="roundRect">
             <a:avLst/>
@@ -5548,14 +5546,14 @@
         </p:nvSpPr>
         <p:spPr>
           <a:xfrm>
-            <a:off x="7324344" y="1453896"/>
-            <a:ext cx="32004" cy="914399"/>
+            <a:off x="2350008" y="2295144"/>
+            <a:ext cx="32004" cy="621792"/>
           </a:xfrm>
           <a:prstGeom prst="rect">
             <a:avLst/>
           </a:prstGeom>
           <a:solidFill>
-            <a:srgbClr val="2B8982"/>
+            <a:srgbClr val="3B7E9D"/>
           </a:solidFill>
           <a:ln w="8890">
             <a:noFill/>
@@ -5591,8 +5589,8 @@
         </p:nvSpPr>
         <p:spPr>
           <a:xfrm>
-            <a:off x="7452360" y="1508760"/>
-            <a:ext cx="1554480" cy="310896"/>
+            <a:off x="2478024" y="2304288"/>
+            <a:ext cx="2761488" cy="237744"/>
           </a:xfrm>
           <a:prstGeom prst="rect">
             <a:avLst/>
@@ -5614,14 +5612,13 @@
               </a:spcAft>
             </a:pPr>
             <a:r>
-              <a:rPr sz="509" b="1">
+              <a:rPr sz="560" b="1">
                 <a:solidFill>
                   <a:srgbClr val="16231D"/>
                 </a:solidFill>
                 <a:latin typeface="Segoe UI"/>
               </a:rPr>
-              <a:t>COPAC — Necessidade para 10 bases,
-sendo 04 prioritárias em 2026 (PReVio)</a:t>
+              <a:t>RAIO — Necessidade para as 20 bases satélites em 3 níveis de implementação</a:t>
             </a:r>
           </a:p>
         </p:txBody>
@@ -5634,14 +5631,14 @@
         </p:nvSpPr>
         <p:spPr>
           <a:xfrm>
-            <a:off x="9171432" y="1508760"/>
+            <a:off x="5404104" y="2304288"/>
             <a:ext cx="256032" cy="256032"/>
           </a:xfrm>
           <a:prstGeom prst="roundRect">
             <a:avLst/>
           </a:prstGeom>
           <a:solidFill>
-            <a:srgbClr val="E3F3F1"/>
+            <a:srgbClr val="E7F1F6"/>
           </a:solidFill>
           <a:ln w="8890">
             <a:noFill/>
@@ -5677,7 +5674,7 @@
         </p:nvSpPr>
         <p:spPr>
           <a:xfrm>
-            <a:off x="9171432" y="1508760"/>
+            <a:off x="5404104" y="2304288"/>
             <a:ext cx="256032" cy="256032"/>
           </a:xfrm>
           <a:prstGeom prst="rect">
@@ -5702,7 +5699,7 @@
             <a:r>
               <a:rPr sz="800" b="1">
                 <a:solidFill>
-                  <a:srgbClr val="2B8982"/>
+                  <a:srgbClr val="3B7E9D"/>
                 </a:solidFill>
                 <a:latin typeface="Segoe UI"/>
               </a:rPr>
@@ -5719,8 +5716,8 @@
         </p:nvSpPr>
         <p:spPr>
           <a:xfrm>
-            <a:off x="7452360" y="1847088"/>
-            <a:ext cx="768096" cy="329184"/>
+            <a:off x="2478024" y="2560320"/>
+            <a:ext cx="768096" cy="274320"/>
           </a:xfrm>
           <a:prstGeom prst="rect">
             <a:avLst/>
@@ -5742,13 +5739,13 @@
               </a:spcAft>
             </a:pPr>
             <a:r>
-              <a:rPr sz="2500" b="1">
+              <a:rPr sz="2100" b="1">
                 <a:solidFill>
                   <a:srgbClr val="16231D"/>
                 </a:solidFill>
                 <a:latin typeface="Segoe UI"/>
               </a:rPr>
-              <a:t>229</a:t>
+              <a:t>912</a:t>
             </a:r>
           </a:p>
         </p:txBody>
@@ -5761,7 +5758,7 @@
         </p:nvSpPr>
         <p:spPr>
           <a:xfrm>
-            <a:off x="8156448" y="1938528"/>
+            <a:off x="3182112" y="2633472"/>
             <a:ext cx="822960" cy="137160"/>
           </a:xfrm>
           <a:prstGeom prst="rect">
@@ -5784,7 +5781,7 @@
               </a:spcAft>
             </a:pPr>
             <a:r>
-              <a:rPr sz="690" b="0">
+              <a:rPr sz="640" b="0">
                 <a:solidFill>
                   <a:srgbClr val="6D7973"/>
                 </a:solidFill>
@@ -5803,15 +5800,15 @@
         </p:nvCxnSpPr>
         <p:spPr>
           <a:xfrm>
-            <a:off x="7452360" y="2267712"/>
-            <a:ext cx="146304" cy="0"/>
+            <a:off x="2478024" y="2880360"/>
+            <a:ext cx="146303" cy="0"/>
           </a:xfrm>
           <a:prstGeom prst="line">
             <a:avLst/>
           </a:prstGeom>
           <a:ln w="16510">
             <a:solidFill>
-              <a:srgbClr val="2B8982"/>
+              <a:srgbClr val="3B7E9D"/>
             </a:solidFill>
           </a:ln>
         </p:spPr>
@@ -5838,8 +5835,8 @@
         </p:nvSpPr>
         <p:spPr>
           <a:xfrm>
-            <a:off x="7644383" y="2185416"/>
-            <a:ext cx="1764792" cy="146304"/>
+            <a:off x="2670048" y="2816351"/>
+            <a:ext cx="2971800" cy="146304"/>
           </a:xfrm>
           <a:prstGeom prst="rect">
             <a:avLst/>
@@ -5861,13 +5858,13 @@
               </a:spcAft>
             </a:pPr>
             <a:r>
-              <a:rPr sz="440" b="0">
+              <a:rPr sz="470" b="0">
                 <a:solidFill>
                   <a:srgbClr val="6D7973"/>
                 </a:solidFill>
                 <a:latin typeface="Segoe UI"/>
               </a:rPr>
-              <a:t>10 bases · 04 prioritárias</a:t>
+              <a:t>20 bases · 31 municípios satélite</a:t>
             </a:r>
           </a:p>
         </p:txBody>
@@ -5880,8 +5877,8 @@
         </p:nvSpPr>
         <p:spPr>
           <a:xfrm>
-            <a:off x="9656064" y="1389888"/>
-            <a:ext cx="2221992" cy="1042415"/>
+            <a:off x="6409944" y="2231136"/>
+            <a:ext cx="3429000" cy="749808"/>
           </a:xfrm>
           <a:prstGeom prst="roundRect">
             <a:avLst/>
@@ -5925,14 +5922,14 @@
         </p:nvSpPr>
         <p:spPr>
           <a:xfrm>
-            <a:off x="9656064" y="1453896"/>
-            <a:ext cx="32004" cy="914399"/>
+            <a:off x="6409944" y="2295144"/>
+            <a:ext cx="32004" cy="621792"/>
           </a:xfrm>
           <a:prstGeom prst="rect">
             <a:avLst/>
           </a:prstGeom>
           <a:solidFill>
-            <a:srgbClr val="698342"/>
+            <a:srgbClr val="2B8982"/>
           </a:solidFill>
           <a:ln w="8890">
             <a:noFill/>
@@ -5968,8 +5965,8 @@
         </p:nvSpPr>
         <p:spPr>
           <a:xfrm>
-            <a:off x="9784080" y="1508760"/>
-            <a:ext cx="1554480" cy="274320"/>
+            <a:off x="6537959" y="2304288"/>
+            <a:ext cx="2761488" cy="237744"/>
           </a:xfrm>
           <a:prstGeom prst="rect">
             <a:avLst/>
@@ -5991,14 +5988,13 @@
               </a:spcAft>
             </a:pPr>
             <a:r>
-              <a:rPr sz="580" b="1">
+              <a:rPr sz="560" b="1">
                 <a:solidFill>
                   <a:srgbClr val="16231D"/>
                 </a:solidFill>
                 <a:latin typeface="Segoe UI"/>
               </a:rPr>
-              <a:t>Reestruturação dos batalhões
-do interior</a:t>
+              <a:t>COPAC — Necessidade para 10 bases, sendo 04 prioritárias em 2026 (PReVio)</a:t>
             </a:r>
           </a:p>
         </p:txBody>
@@ -6011,14 +6007,14 @@
         </p:nvSpPr>
         <p:spPr>
           <a:xfrm>
-            <a:off x="11503152" y="1508760"/>
+            <a:off x="9464040" y="2304288"/>
             <a:ext cx="256032" cy="256032"/>
           </a:xfrm>
           <a:prstGeom prst="roundRect">
             <a:avLst/>
           </a:prstGeom>
           <a:solidFill>
-            <a:srgbClr val="EDF3E4"/>
+            <a:srgbClr val="E3F3F1"/>
           </a:solidFill>
           <a:ln w="8890">
             <a:noFill/>
@@ -6054,7 +6050,7 @@
         </p:nvSpPr>
         <p:spPr>
           <a:xfrm>
-            <a:off x="11503152" y="1508760"/>
+            <a:off x="9464040" y="2304288"/>
             <a:ext cx="256032" cy="256032"/>
           </a:xfrm>
           <a:prstGeom prst="rect">
@@ -6079,7 +6075,7 @@
             <a:r>
               <a:rPr sz="800" b="1">
                 <a:solidFill>
-                  <a:srgbClr val="698342"/>
+                  <a:srgbClr val="2B8982"/>
                 </a:solidFill>
                 <a:latin typeface="Segoe UI"/>
               </a:rPr>
@@ -6096,8 +6092,8 @@
         </p:nvSpPr>
         <p:spPr>
           <a:xfrm>
-            <a:off x="9784080" y="1847088"/>
-            <a:ext cx="768096" cy="329184"/>
+            <a:off x="6537959" y="2560320"/>
+            <a:ext cx="768096" cy="274320"/>
           </a:xfrm>
           <a:prstGeom prst="rect">
             <a:avLst/>
@@ -6119,13 +6115,13 @@
               </a:spcAft>
             </a:pPr>
             <a:r>
-              <a:rPr sz="2500" b="1">
+              <a:rPr sz="2100" b="1">
                 <a:solidFill>
                   <a:srgbClr val="16231D"/>
                 </a:solidFill>
                 <a:latin typeface="Segoe UI"/>
               </a:rPr>
-              <a:t>9</a:t>
+              <a:t>229</a:t>
             </a:r>
           </a:p>
         </p:txBody>
@@ -6138,7 +6134,7 @@
         </p:nvSpPr>
         <p:spPr>
           <a:xfrm>
-            <a:off x="10488168" y="1938528"/>
+            <a:off x="7242048" y="2633472"/>
             <a:ext cx="822960" cy="137160"/>
           </a:xfrm>
           <a:prstGeom prst="rect">
@@ -6161,13 +6157,13 @@
               </a:spcAft>
             </a:pPr>
             <a:r>
-              <a:rPr sz="690" b="0">
+              <a:rPr sz="640" b="0">
                 <a:solidFill>
                   <a:srgbClr val="6D7973"/>
                 </a:solidFill>
                 <a:latin typeface="Segoe UI"/>
               </a:rPr>
-              <a:t>batalhões</a:t>
+              <a:t>policiais</a:t>
             </a:r>
           </a:p>
         </p:txBody>
@@ -6180,15 +6176,15 @@
         </p:nvCxnSpPr>
         <p:spPr>
           <a:xfrm>
-            <a:off x="9784080" y="2267712"/>
-            <a:ext cx="146304" cy="0"/>
+            <a:off x="6537959" y="2880360"/>
+            <a:ext cx="146305" cy="0"/>
           </a:xfrm>
           <a:prstGeom prst="line">
             <a:avLst/>
           </a:prstGeom>
           <a:ln w="16510">
             <a:solidFill>
-              <a:srgbClr val="698342"/>
+              <a:srgbClr val="2B8982"/>
             </a:solidFill>
           </a:ln>
         </p:spPr>
@@ -6215,8 +6211,8 @@
         </p:nvSpPr>
         <p:spPr>
           <a:xfrm>
-            <a:off x="9976104" y="2185416"/>
-            <a:ext cx="1764792" cy="146304"/>
+            <a:off x="6729983" y="2816351"/>
+            <a:ext cx="2971800" cy="146304"/>
           </a:xfrm>
           <a:prstGeom prst="rect">
             <a:avLst/>
@@ -6238,13 +6234,13 @@
               </a:spcAft>
             </a:pPr>
             <a:r>
-              <a:rPr sz="430" b="0">
+              <a:rPr sz="470" b="0">
                 <a:solidFill>
                   <a:srgbClr val="6D7973"/>
                 </a:solidFill>
                 <a:latin typeface="Segoe UI"/>
               </a:rPr>
-              <a:t>8 abaixo da média · 1 acima</a:t>
+              <a:t>10 bases · 04 prioritárias</a:t>
             </a:r>
           </a:p>
         </p:txBody>
@@ -6257,8 +6253,8 @@
         </p:nvSpPr>
         <p:spPr>
           <a:xfrm>
-            <a:off x="228600" y="2487168"/>
-            <a:ext cx="7543800" cy="4105656"/>
+            <a:off x="228600" y="3072384"/>
+            <a:ext cx="7543800" cy="3520440"/>
           </a:xfrm>
           <a:prstGeom prst="roundRect">
             <a:avLst/>
@@ -6302,7 +6298,7 @@
         </p:nvCxnSpPr>
         <p:spPr>
           <a:xfrm>
-            <a:off x="228600" y="2926080"/>
+            <a:off x="228600" y="3511296"/>
             <a:ext cx="7543800" cy="0"/>
           </a:xfrm>
           <a:prstGeom prst="line">
@@ -6337,7 +6333,7 @@
         </p:nvSpPr>
         <p:spPr>
           <a:xfrm>
-            <a:off x="338328" y="2606040"/>
+            <a:off x="338328" y="3191256"/>
             <a:ext cx="246888" cy="228600"/>
           </a:xfrm>
           <a:prstGeom prst="roundRect">
@@ -6380,7 +6376,7 @@
         </p:nvSpPr>
         <p:spPr>
           <a:xfrm>
-            <a:off x="338328" y="2606040"/>
+            <a:off x="338328" y="3191256"/>
             <a:ext cx="246888" cy="228600"/>
           </a:xfrm>
           <a:prstGeom prst="rect">
@@ -6422,7 +6418,7 @@
         </p:nvSpPr>
         <p:spPr>
           <a:xfrm>
-            <a:off x="649224" y="2587752"/>
+            <a:off x="649224" y="3172968"/>
             <a:ext cx="6995160" cy="173736"/>
           </a:xfrm>
           <a:prstGeom prst="rect">
@@ -6464,7 +6460,7 @@
         </p:nvSpPr>
         <p:spPr>
           <a:xfrm>
-            <a:off x="649224" y="2761488"/>
+            <a:off x="649224" y="3346703"/>
             <a:ext cx="6995160" cy="100584"/>
           </a:xfrm>
           <a:prstGeom prst="rect">
@@ -6507,8 +6503,8 @@
           <p:nvPr/>
         </p:nvGraphicFramePr>
         <p:xfrm>
-          <a:off x="420624" y="3026664"/>
-          <a:ext cx="7095744" cy="3127248"/>
+          <a:off x="420624" y="3611880"/>
+          <a:ext cx="7095744" cy="2468880"/>
         </p:xfrm>
         <a:graphic>
           <a:graphicData uri="http://schemas.openxmlformats.org/drawingml/2006/chart">
@@ -6566,8 +6562,8 @@
         </p:nvSpPr>
         <p:spPr>
           <a:xfrm>
-            <a:off x="7882127" y="2487168"/>
-            <a:ext cx="4078224" cy="4105656"/>
+            <a:off x="7882127" y="3072384"/>
+            <a:ext cx="4078224" cy="3520440"/>
           </a:xfrm>
           <a:prstGeom prst="roundRect">
             <a:avLst/>
@@ -6611,7 +6607,7 @@
         </p:nvCxnSpPr>
         <p:spPr>
           <a:xfrm>
-            <a:off x="7882127" y="2926080"/>
+            <a:off x="7882127" y="3511296"/>
             <a:ext cx="4078224" cy="0"/>
           </a:xfrm>
           <a:prstGeom prst="line">
@@ -6646,7 +6642,7 @@
         </p:nvSpPr>
         <p:spPr>
           <a:xfrm>
-            <a:off x="7991855" y="2606040"/>
+            <a:off x="7991855" y="3191256"/>
             <a:ext cx="246888" cy="228600"/>
           </a:xfrm>
           <a:prstGeom prst="roundRect">
@@ -6689,7 +6685,7 @@
         </p:nvSpPr>
         <p:spPr>
           <a:xfrm>
-            <a:off x="7991855" y="2606040"/>
+            <a:off x="7991855" y="3191256"/>
             <a:ext cx="246888" cy="228600"/>
           </a:xfrm>
           <a:prstGeom prst="rect">
@@ -6731,7 +6727,7 @@
         </p:nvSpPr>
         <p:spPr>
           <a:xfrm>
-            <a:off x="8302752" y="2587752"/>
+            <a:off x="8302752" y="3172968"/>
             <a:ext cx="3529584" cy="173736"/>
           </a:xfrm>
           <a:prstGeom prst="rect">
@@ -6773,7 +6769,7 @@
         </p:nvSpPr>
         <p:spPr>
           <a:xfrm>
-            <a:off x="8302752" y="2761488"/>
+            <a:off x="8302752" y="3346703"/>
             <a:ext cx="3529584" cy="100584"/>
           </a:xfrm>
           <a:prstGeom prst="rect">
@@ -6816,8 +6812,8 @@
           <p:nvPr/>
         </p:nvGraphicFramePr>
         <p:xfrm>
-          <a:off x="8613648" y="3154680"/>
-          <a:ext cx="2606040" cy="2286000"/>
+          <a:off x="8613648" y="3685032"/>
+          <a:ext cx="2606040" cy="1920240"/>
         </p:xfrm>
         <a:graphic>
           <a:graphicData uri="http://schemas.openxmlformats.org/drawingml/2006/chart">
@@ -6833,7 +6829,7 @@
         </p:nvSpPr>
         <p:spPr>
           <a:xfrm>
-            <a:off x="9491472" y="3904487"/>
+            <a:off x="9491472" y="4315968"/>
             <a:ext cx="841248" cy="310896"/>
           </a:xfrm>
           <a:prstGeom prst="rect">
@@ -6875,7 +6871,7 @@
         </p:nvSpPr>
         <p:spPr>
           <a:xfrm>
-            <a:off x="9582912" y="4206240"/>
+            <a:off x="9582912" y="4617720"/>
             <a:ext cx="658368" cy="109728"/>
           </a:xfrm>
           <a:prstGeom prst="rect">
@@ -6917,7 +6913,7 @@
         </p:nvSpPr>
         <p:spPr>
           <a:xfrm>
-            <a:off x="8302752" y="5504688"/>
+            <a:off x="8302752" y="5806440"/>
             <a:ext cx="64008" cy="64008"/>
           </a:xfrm>
           <a:prstGeom prst="rect">
@@ -6962,7 +6958,7 @@
         </p:nvSpPr>
         <p:spPr>
           <a:xfrm>
-            <a:off x="8421624" y="5458968"/>
+            <a:off x="8421624" y="5760720"/>
             <a:ext cx="1828800" cy="146304"/>
           </a:xfrm>
           <a:prstGeom prst="rect">
@@ -7004,7 +7000,7 @@
         </p:nvSpPr>
         <p:spPr>
           <a:xfrm>
-            <a:off x="11018520" y="5458968"/>
+            <a:off x="11018520" y="5760720"/>
             <a:ext cx="640080" cy="146304"/>
           </a:xfrm>
           <a:prstGeom prst="rect">
@@ -7046,7 +7042,7 @@
         </p:nvSpPr>
         <p:spPr>
           <a:xfrm>
-            <a:off x="8302752" y="5715000"/>
+            <a:off x="8302752" y="6016752"/>
             <a:ext cx="64008" cy="64008"/>
           </a:xfrm>
           <a:prstGeom prst="rect">
@@ -7091,7 +7087,7 @@
         </p:nvSpPr>
         <p:spPr>
           <a:xfrm>
-            <a:off x="8421624" y="5669280"/>
+            <a:off x="8421624" y="5971032"/>
             <a:ext cx="1828800" cy="146304"/>
           </a:xfrm>
           <a:prstGeom prst="rect">
@@ -7133,7 +7129,7 @@
         </p:nvSpPr>
         <p:spPr>
           <a:xfrm>
-            <a:off x="11018520" y="5669280"/>
+            <a:off x="11018520" y="5971032"/>
             <a:ext cx="640080" cy="146304"/>
           </a:xfrm>
           <a:prstGeom prst="rect">

</xml_diff>

<commit_message>
Atualiza projeção do COPAC PReVio
</commit_message>
<xml_diff>
--- a/exportacoes/Painel_Gestao_Pessoal_PMCE_EDITAVEL.pptx
+++ b/exportacoes/Painel_Gestao_Pessoal_PMCE_EDITAVEL.pptx
@@ -3804,7 +3804,7 @@
                 </a:solidFill>
                 <a:latin typeface="Segoe UI"/>
               </a:rPr>
-              <a:t>21 de agosto de 2026</a:t>
+              <a:t>09 de setembro de 2026</a:t>
             </a:r>
           </a:p>
         </p:txBody>
@@ -4273,7 +4273,7 @@
                 </a:solidFill>
                 <a:latin typeface="Segoe UI"/>
               </a:rPr>
-              <a:t>21/08/2026</a:t>
+              <a:t>09/09/2026</a:t>
             </a:r>
           </a:p>
         </p:txBody>
@@ -5929,7 +5929,7 @@
             <a:avLst/>
           </a:prstGeom>
           <a:solidFill>
-            <a:srgbClr val="2B8982"/>
+            <a:srgbClr val="2F855A"/>
           </a:solidFill>
           <a:ln w="8890">
             <a:noFill/>
@@ -5988,13 +5988,13 @@
               </a:spcAft>
             </a:pPr>
             <a:r>
-              <a:rPr sz="560" b="1">
+              <a:rPr sz="580" b="1">
                 <a:solidFill>
                   <a:srgbClr val="16231D"/>
                 </a:solidFill>
                 <a:latin typeface="Segoe UI"/>
               </a:rPr>
-              <a:t>COPAC — Necessidade para 10 bases, sendo 04 prioritárias em 2026 (PReVio)</a:t>
+              <a:t>COPAC — Efetivo mínimo para 12 bases cidadãs do PReVio</a:t>
             </a:r>
           </a:p>
         </p:txBody>
@@ -6014,7 +6014,7 @@
             <a:avLst/>
           </a:prstGeom>
           <a:solidFill>
-            <a:srgbClr val="E3F3F1"/>
+            <a:srgbClr val="E5F3EA"/>
           </a:solidFill>
           <a:ln w="8890">
             <a:noFill/>
@@ -6075,7 +6075,7 @@
             <a:r>
               <a:rPr sz="800" b="1">
                 <a:solidFill>
-                  <a:srgbClr val="2B8982"/>
+                  <a:srgbClr val="2F855A"/>
                 </a:solidFill>
                 <a:latin typeface="Segoe UI"/>
               </a:rPr>
@@ -6121,7 +6121,7 @@
                 </a:solidFill>
                 <a:latin typeface="Segoe UI"/>
               </a:rPr>
-              <a:t>229</a:t>
+              <a:t>360</a:t>
             </a:r>
           </a:p>
         </p:txBody>
@@ -6184,7 +6184,7 @@
           </a:prstGeom>
           <a:ln w="16510">
             <a:solidFill>
-              <a:srgbClr val="2B8982"/>
+              <a:srgbClr val="2F855A"/>
             </a:solidFill>
           </a:ln>
         </p:spPr>
@@ -6240,7 +6240,7 @@
                 </a:solidFill>
                 <a:latin typeface="Segoe UI"/>
               </a:rPr>
-              <a:t>10 bases · 04 prioritárias</a:t>
+              <a:t>12 bases · 30 policiais por base</a:t>
             </a:r>
           </a:p>
         </p:txBody>
@@ -7242,7 +7242,7 @@
                 </a:solidFill>
                 <a:latin typeface="Segoe UI"/>
               </a:rPr>
-              <a:t>●  Fontes consolidadas em 21/08/2026</a:t>
+              <a:t>●  Fontes consolidadas em 09/09/2026</a:t>
             </a:r>
           </a:p>
         </p:txBody>

</xml_diff>

<commit_message>
Corrige definição da sigla POG
</commit_message>
<xml_diff>
--- a/exportacoes/Painel_Gestao_Pessoal_PMCE_EDITAVEL.pptx
+++ b/exportacoes/Painel_Gestao_Pessoal_PMCE_EDITAVEL.pptx
@@ -5106,13 +5106,13 @@
               </a:spcAft>
             </a:pPr>
             <a:r>
-              <a:rPr sz="470" b="0">
+              <a:rPr sz="450" b="0">
                 <a:solidFill>
                   <a:srgbClr val="6D7973"/>
                 </a:solidFill>
                 <a:latin typeface="Segoe UI"/>
               </a:rPr>
-              <a:t>Policiamento Ordinário · 34 BPMs</a:t>
+              <a:t>Policiamento Ostensivo Geral · 34 BPMs</a:t>
             </a:r>
           </a:p>
         </p:txBody>

</xml_diff>